<commit_message>
Poster: poster-legible fonts + preview image/PDF backend
Rebuild make_poster.py around a single layout spec with two backends: the editable
PPTX and a matplotlib preview (PNG+PDF) at the identical point sizes, so readability
can be checked without PowerPoint/LibreOffice (none installed here).

Fonts raised to poster scale (title 66, headers 40, body 30, code 23; previously
17-40). Title now wraps to two lines instead of being clipped. Verified via the
rendered preview.

Co-Authored-By: Claude Opus 4.8 (1M context) <noreply@anthropic.com>
</commit_message>
<xml_diff>
--- a/poster/USRSE26_poster.pptx
+++ b/poster/USRSE26_poster.pptx
@@ -3097,7 +3097,7 @@
         <p:spPr>
           <a:xfrm>
             <a:off x="0" y="0"/>
-            <a:ext cx="43891200" cy="3840480"/>
+            <a:ext cx="43891200" cy="5303520"/>
           </a:xfrm>
           <a:prstGeom prst="rect">
             <a:avLst/>
@@ -3141,7 +3141,7 @@
         <p:spPr>
           <a:xfrm>
             <a:off x="731520" y="320040"/>
-            <a:ext cx="42428160" cy="3291840"/>
+            <a:ext cx="42428160" cy="4754880"/>
           </a:xfrm>
           <a:prstGeom prst="rect">
             <a:avLst/>
@@ -3154,52 +3154,43 @@
           </a:bodyPr>
           <a:lstStyle/>
           <a:p>
-            <a:pPr>
-              <a:spcBef>
-                <a:spcPts val="0"/>
-              </a:spcBef>
-              <a:spcAft>
-                <a:spcPts val="200"/>
-              </a:spcAft>
-            </a:pPr>
-            <a:r>
-              <a:rPr sz="4000" b="1">
-                <a:solidFill>
-                  <a:srgbClr val="FFFFFF"/>
-                </a:solidFill>
-              </a:rPr>
-              <a:t>Automated Problem-to-Solution Generation for a Tokamak Fusion-Plasma Simulation</a:t>
-            </a:r>
-          </a:p>
-          <a:p>
-            <a:pPr>
-              <a:spcBef>
-                <a:spcPts val="0"/>
-              </a:spcBef>
+            <a:pPr algn="l">
               <a:spcAft>
                 <a:spcPts val="600"/>
               </a:spcAft>
             </a:pPr>
             <a:r>
-              <a:rPr sz="2400" b="0">
-                <a:solidFill>
-                  <a:srgbClr val="CFE6EA"/>
+              <a:rPr sz="6600" b="1">
+                <a:solidFill>
+                  <a:srgbClr val="FFFFFF"/>
                 </a:solidFill>
               </a:rPr>
-              <a:t>A hierarchical multi-agent PETSc system: from a plain-language prompt to a verified Grad-Shafranov MHD-equilibrium solver</a:t>
-            </a:r>
-          </a:p>
-          <a:p>
-            <a:pPr>
-              <a:spcBef>
-                <a:spcPts val="0"/>
-              </a:spcBef>
+              <a:t>Automated Problem-to-Solution Generation for a Tokamak Fusion-Plasma Simulation</a:t>
+            </a:r>
+          </a:p>
+          <a:p>
+            <a:pPr algn="l">
               <a:spcAft>
                 <a:spcPts val="600"/>
               </a:spcAft>
             </a:pPr>
             <a:r>
-              <a:rPr sz="1800" b="0">
+              <a:rPr sz="3400" b="0">
+                <a:solidFill>
+                  <a:srgbClr val="CFE6EA"/>
+                </a:solidFill>
+              </a:rPr>
+              <a:t>A hierarchical multi-agent PETSc system: from a plain-language prompt to a verified Grad-Shafranov solver</a:t>
+            </a:r>
+          </a:p>
+          <a:p>
+            <a:pPr algn="l">
+              <a:spcAft>
+                <a:spcPts val="600"/>
+              </a:spcAft>
+            </a:pPr>
+            <a:r>
+              <a:rPr sz="2700" b="0">
                 <a:solidFill>
                   <a:srgbClr val="FFFFFF"/>
                 </a:solidFill>
@@ -3217,8 +3208,8 @@
         </p:nvSpPr>
         <p:spPr>
           <a:xfrm>
-            <a:off x="731520" y="4389120"/>
-            <a:ext cx="13716000" cy="7863840"/>
+            <a:off x="640080" y="5852160"/>
+            <a:ext cx="13624560" cy="7680960"/>
           </a:xfrm>
           <a:prstGeom prst="roundRect">
             <a:avLst/>
@@ -3226,7 +3217,7 @@
           <a:solidFill>
             <a:srgbClr val="FFFFFF"/>
           </a:solidFill>
-          <a:ln w="19050">
+          <a:ln w="25400">
             <a:solidFill>
               <a:srgbClr val="007D8A"/>
             </a:solidFill>
@@ -3257,16 +3248,16 @@
       </p:sp>
       <p:sp>
         <p:nvSpPr>
-          <p:cNvPr id="5" name="Rounded Rectangle 4"/>
+          <p:cNvPr id="5" name="Rectangle 4"/>
           <p:cNvSpPr/>
           <p:nvPr/>
         </p:nvSpPr>
         <p:spPr>
           <a:xfrm>
-            <a:off x="731520" y="4389120"/>
-            <a:ext cx="13716000" cy="1005840"/>
-          </a:xfrm>
-          <a:prstGeom prst="roundRect">
+            <a:off x="640080" y="5852160"/>
+            <a:ext cx="13624560" cy="1143000"/>
+          </a:xfrm>
+          <a:prstGeom prst="rect">
             <a:avLst/>
           </a:prstGeom>
           <a:solidFill>
@@ -3292,12 +3283,12 @@
           </a:fontRef>
         </p:style>
         <p:txBody>
-          <a:bodyPr rtlCol="0" anchor="ctr" wrap="square" lIns="228600"/>
+          <a:bodyPr rtlCol="0" anchor="ctr" lIns="274320"/>
           <a:lstStyle/>
           <a:p>
             <a:pPr algn="ctr"/>
             <a:r>
-              <a:rPr sz="2600" b="1">
+              <a:rPr sz="4000" b="1">
                 <a:solidFill>
                   <a:srgbClr val="FFFFFF"/>
                 </a:solidFill>
@@ -3315,8 +3306,8 @@
         </p:nvSpPr>
         <p:spPr>
           <a:xfrm>
-            <a:off x="1051560" y="5623560"/>
-            <a:ext cx="13075920" cy="6400800"/>
+            <a:off x="914400" y="7178040"/>
+            <a:ext cx="13075920" cy="6126480"/>
           </a:xfrm>
           <a:prstGeom prst="rect">
             <a:avLst/>
@@ -3329,57 +3320,48 @@
           </a:bodyPr>
           <a:lstStyle/>
           <a:p>
-            <a:pPr>
-              <a:spcBef>
-                <a:spcPts val="0"/>
-              </a:spcBef>
-              <a:spcAft>
-                <a:spcPts val="1000"/>
-              </a:spcAft>
-            </a:pPr>
-            <a:r>
-              <a:rPr sz="1900" b="0">
-                <a:solidFill>
-                  <a:srgbClr val="1F1F1F"/>
-                </a:solidFill>
-              </a:rPr>
-              <a:t>Turning a scientific idea into correct, fast HPC simulation code still demands scarce, largely implicit expertise in numerical methods and library APIs.</a:t>
-            </a:r>
-          </a:p>
-          <a:p>
-            <a:pPr>
-              <a:spcBef>
-                <a:spcPts val="0"/>
-              </a:spcBef>
-              <a:spcAft>
-                <a:spcPts val="1000"/>
-              </a:spcAft>
-            </a:pPr>
-            <a:r>
-              <a:rPr sz="1900" b="0">
-                <a:solidFill>
-                  <a:srgbClr val="1F1F1F"/>
-                </a:solidFill>
-              </a:rPr>
-              <a:t>Question: can a hierarchical multi-agent AI system automate that path for a real fusion-energy problem — and can the result be verified, not merely plausible?</a:t>
-            </a:r>
-          </a:p>
-          <a:p>
-            <a:pPr>
-              <a:spcBef>
-                <a:spcPts val="0"/>
-              </a:spcBef>
+            <a:pPr algn="l">
               <a:spcAft>
                 <a:spcPts val="600"/>
               </a:spcAft>
             </a:pPr>
             <a:r>
-              <a:rPr sz="1900" b="0">
+              <a:rPr sz="3000" b="0">
                 <a:solidFill>
                   <a:srgbClr val="1F1F1F"/>
                 </a:solidFill>
               </a:rPr>
-              <a:t>We apply the open PETSc multi-agent system to the tokamak Grad-Shafranov equilibrium, the MHD stretch goal of the DOE proposal on automated PDE problem-to-solution generation.</a:t>
+              <a:t>Correct, fast HPC simulation code still demands scarce, implicit expertise in numerical methods and library APIs.</a:t>
+            </a:r>
+          </a:p>
+          <a:p>
+            <a:pPr algn="l">
+              <a:spcAft>
+                <a:spcPts val="600"/>
+              </a:spcAft>
+            </a:pPr>
+            <a:r>
+              <a:rPr sz="3000" b="0">
+                <a:solidFill>
+                  <a:srgbClr val="1F1F1F"/>
+                </a:solidFill>
+              </a:rPr>
+              <a:t>Can a multi-agent AI system automate the path from a plain-language idea to VERIFIED code for a real fusion problem?</a:t>
+            </a:r>
+          </a:p>
+          <a:p>
+            <a:pPr algn="l">
+              <a:spcAft>
+                <a:spcPts val="600"/>
+              </a:spcAft>
+            </a:pPr>
+            <a:r>
+              <a:rPr sz="3000" b="0">
+                <a:solidFill>
+                  <a:srgbClr val="1F1F1F"/>
+                </a:solidFill>
+              </a:rPr>
+              <a:t>We apply the open PETSc multi-agent system to the tokamak Grad-Shafranov equilibrium.</a:t>
             </a:r>
           </a:p>
         </p:txBody>
@@ -3392,8 +3374,8 @@
         </p:nvSpPr>
         <p:spPr>
           <a:xfrm>
-            <a:off x="731520" y="12618720"/>
-            <a:ext cx="13716000" cy="7315200"/>
+            <a:off x="640080" y="13990320"/>
+            <a:ext cx="13624560" cy="7680960"/>
           </a:xfrm>
           <a:prstGeom prst="roundRect">
             <a:avLst/>
@@ -3401,7 +3383,7 @@
           <a:solidFill>
             <a:srgbClr val="FFFFFF"/>
           </a:solidFill>
-          <a:ln w="19050">
+          <a:ln w="25400">
             <a:solidFill>
               <a:srgbClr val="007D8A"/>
             </a:solidFill>
@@ -3432,16 +3414,16 @@
       </p:sp>
       <p:sp>
         <p:nvSpPr>
-          <p:cNvPr id="8" name="Rounded Rectangle 7"/>
+          <p:cNvPr id="8" name="Rectangle 7"/>
           <p:cNvSpPr/>
           <p:nvPr/>
         </p:nvSpPr>
         <p:spPr>
           <a:xfrm>
-            <a:off x="731520" y="12618720"/>
-            <a:ext cx="13716000" cy="1005840"/>
-          </a:xfrm>
-          <a:prstGeom prst="roundRect">
+            <a:off x="640080" y="13990320"/>
+            <a:ext cx="13624560" cy="1143000"/>
+          </a:xfrm>
+          <a:prstGeom prst="rect">
             <a:avLst/>
           </a:prstGeom>
           <a:solidFill>
@@ -3467,17 +3449,17 @@
           </a:fontRef>
         </p:style>
         <p:txBody>
-          <a:bodyPr rtlCol="0" anchor="ctr" wrap="square" lIns="228600"/>
+          <a:bodyPr rtlCol="0" anchor="ctr" lIns="274320"/>
           <a:lstStyle/>
           <a:p>
             <a:pPr algn="ctr"/>
             <a:r>
-              <a:rPr sz="2600" b="1">
+              <a:rPr sz="4000" b="1">
                 <a:solidFill>
                   <a:srgbClr val="FFFFFF"/>
                 </a:solidFill>
               </a:rPr>
-              <a:t>2  The problem: Grad-Shafranov</a:t>
+              <a:t>2  The problem</a:t>
             </a:r>
           </a:p>
         </p:txBody>
@@ -3490,8 +3472,8 @@
         </p:nvSpPr>
         <p:spPr>
           <a:xfrm>
-            <a:off x="1051560" y="13853160"/>
-            <a:ext cx="13075920" cy="5852160"/>
+            <a:off x="914400" y="15316200"/>
+            <a:ext cx="13075920" cy="6126480"/>
           </a:xfrm>
           <a:prstGeom prst="rect">
             <a:avLst/>
@@ -3504,75 +3486,63 @@
           </a:bodyPr>
           <a:lstStyle/>
           <a:p>
-            <a:pPr>
-              <a:spcBef>
-                <a:spcPts val="0"/>
-              </a:spcBef>
-              <a:spcAft>
-                <a:spcPts val="800"/>
-              </a:spcAft>
-            </a:pPr>
-            <a:r>
-              <a:rPr sz="1900" b="0">
-                <a:solidFill>
-                  <a:srgbClr val="1F1F1F"/>
-                </a:solidFill>
-              </a:rPr>
-              <a:t>Axisymmetric ideal-MHD force balance for the poloidal flux ψ(R,Z):</a:t>
-            </a:r>
-          </a:p>
-          <a:p>
-            <a:pPr algn="ctr">
-              <a:spcBef>
-                <a:spcPts val="0"/>
-              </a:spcBef>
-              <a:spcAft>
-                <a:spcPts val="800"/>
-              </a:spcAft>
-            </a:pPr>
-            <a:r>
-              <a:rPr sz="2600" b="1">
-                <a:solidFill>
-                  <a:srgbClr val="007D8A"/>
-                </a:solidFill>
-              </a:rPr>
-              <a:t>Δ* ψ = -μ₀ R² p′(ψ) - F F′(ψ)</a:t>
-            </a:r>
-          </a:p>
-          <a:p>
-            <a:pPr>
-              <a:spcBef>
-                <a:spcPts val="0"/>
-              </a:spcBef>
-              <a:spcAft>
-                <a:spcPts val="800"/>
-              </a:spcAft>
-            </a:pPr>
-            <a:r>
-              <a:rPr sz="1900" b="0">
-                <a:solidFill>
-                  <a:srgbClr val="1F1F1F"/>
-                </a:solidFill>
-              </a:rPr>
-              <a:t>Its solution gives the flux surfaces, magnetic axis, and safety factor q that determine whether the plasma stays confined.</a:t>
-            </a:r>
-          </a:p>
-          <a:p>
-            <a:pPr>
-              <a:spcBef>
-                <a:spcPts val="0"/>
-              </a:spcBef>
+            <a:pPr algn="l">
               <a:spcAft>
                 <a:spcPts val="600"/>
               </a:spcAft>
             </a:pPr>
             <a:r>
-              <a:rPr sz="1900" b="0">
+              <a:rPr sz="3000" b="0">
                 <a:solidFill>
                   <a:srgbClr val="1F1F1F"/>
                 </a:solidFill>
               </a:rPr>
-              <a:t>Elliptic, nonlinear, time-independent → a natural PETSc SNES problem; verifiable against a manufactured exact solution.</a:t>
+              <a:t>Axisymmetric ideal-MHD force balance for the poloidal flux psi(R,Z):</a:t>
+            </a:r>
+          </a:p>
+          <a:p>
+            <a:pPr algn="ctr">
+              <a:spcAft>
+                <a:spcPts val="600"/>
+              </a:spcAft>
+            </a:pPr>
+            <a:r>
+              <a:rPr sz="4000" b="1">
+                <a:solidFill>
+                  <a:srgbClr val="007D8A"/>
+                </a:solidFill>
+              </a:rPr>
+              <a:t>Δ*psi = -μ₀R² p'(psi) - F F'(psi)</a:t>
+            </a:r>
+          </a:p>
+          <a:p>
+            <a:pPr algn="l">
+              <a:spcAft>
+                <a:spcPts val="600"/>
+              </a:spcAft>
+            </a:pPr>
+            <a:r>
+              <a:rPr sz="3000" b="0">
+                <a:solidFill>
+                  <a:srgbClr val="1F1F1F"/>
+                </a:solidFill>
+              </a:rPr>
+              <a:t>Gives the flux surfaces, magnetic axis, and safety factor q.</a:t>
+            </a:r>
+          </a:p>
+          <a:p>
+            <a:pPr algn="l">
+              <a:spcAft>
+                <a:spcPts val="600"/>
+              </a:spcAft>
+            </a:pPr>
+            <a:r>
+              <a:rPr sz="3000" b="0">
+                <a:solidFill>
+                  <a:srgbClr val="1F1F1F"/>
+                </a:solidFill>
+              </a:rPr>
+              <a:t>Elliptic, nonlinear → PETSc SNES; verifiable vs an exact solution.</a:t>
             </a:r>
           </a:p>
         </p:txBody>
@@ -3585,8 +3555,8 @@
         </p:nvSpPr>
         <p:spPr>
           <a:xfrm>
-            <a:off x="731520" y="20299680"/>
-            <a:ext cx="13716000" cy="12070080"/>
+            <a:off x="640080" y="22128480"/>
+            <a:ext cx="13624560" cy="10241279"/>
           </a:xfrm>
           <a:prstGeom prst="roundRect">
             <a:avLst/>
@@ -3594,7 +3564,7 @@
           <a:solidFill>
             <a:srgbClr val="FFFFFF"/>
           </a:solidFill>
-          <a:ln w="19050">
+          <a:ln w="25400">
             <a:solidFill>
               <a:srgbClr val="007D8A"/>
             </a:solidFill>
@@ -3625,16 +3595,16 @@
       </p:sp>
       <p:sp>
         <p:nvSpPr>
-          <p:cNvPr id="11" name="Rounded Rectangle 10"/>
+          <p:cNvPr id="11" name="Rectangle 10"/>
           <p:cNvSpPr/>
           <p:nvPr/>
         </p:nvSpPr>
         <p:spPr>
           <a:xfrm>
-            <a:off x="731520" y="20299680"/>
-            <a:ext cx="13716000" cy="1005840"/>
-          </a:xfrm>
-          <a:prstGeom prst="roundRect">
+            <a:off x="640080" y="22128480"/>
+            <a:ext cx="13624560" cy="1143000"/>
+          </a:xfrm>
+          <a:prstGeom prst="rect">
             <a:avLst/>
           </a:prstGeom>
           <a:solidFill>
@@ -3660,12 +3630,12 @@
           </a:fontRef>
         </p:style>
         <p:txBody>
-          <a:bodyPr rtlCol="0" anchor="ctr" wrap="square" lIns="228600"/>
+          <a:bodyPr rtlCol="0" anchor="ctr" lIns="274320"/>
           <a:lstStyle/>
           <a:p>
             <a:pPr algn="ctr"/>
             <a:r>
-              <a:rPr sz="2600" b="1">
+              <a:rPr sz="4000" b="1">
                 <a:solidFill>
                   <a:srgbClr val="FFFFFF"/>
                 </a:solidFill>
@@ -3683,8 +3653,8 @@
         </p:nvSpPr>
         <p:spPr>
           <a:xfrm>
-            <a:off x="1051560" y="21534120"/>
-            <a:ext cx="13075920" cy="10607040"/>
+            <a:off x="914400" y="23454360"/>
+            <a:ext cx="13075920" cy="8686799"/>
           </a:xfrm>
           <a:prstGeom prst="rect">
             <a:avLst/>
@@ -3697,129 +3667,93 @@
           </a:bodyPr>
           <a:lstStyle/>
           <a:p>
-            <a:pPr>
-              <a:spcBef>
-                <a:spcPts val="0"/>
-              </a:spcBef>
-              <a:spcAft>
-                <a:spcPts val="800"/>
-              </a:spcAft>
-            </a:pPr>
-            <a:r>
-              <a:rPr sz="1900" b="0">
-                <a:solidFill>
-                  <a:srgbClr val="1F1F1F"/>
-                </a:solidFill>
-              </a:rPr>
-              <a:t>Three layers of specialist agents, each a Model-Context-Protocol server:</a:t>
-            </a:r>
-          </a:p>
-          <a:p>
-            <a:pPr>
-              <a:spcBef>
-                <a:spcPts val="0"/>
-              </a:spcBef>
+            <a:pPr algn="l">
               <a:spcAft>
                 <a:spcPts val="600"/>
               </a:spcAft>
             </a:pPr>
             <a:r>
-              <a:rPr sz="1800" b="0">
+              <a:rPr sz="3000" b="0">
                 <a:solidFill>
                   <a:srgbClr val="1F1F1F"/>
                 </a:solidFill>
               </a:rPr>
-              <a:t>Problem Definition — Mathematical Modeling agent → strong/weak form, PDE identity.</a:t>
-            </a:r>
-          </a:p>
-          <a:p>
-            <a:pPr>
-              <a:spcBef>
-                <a:spcPts val="0"/>
-              </a:spcBef>
-              <a:spcAft>
-                <a:spcPts val="200"/>
-              </a:spcAft>
-            </a:pPr>
-            <a:r>
-              <a:rPr sz="1800" b="0">
-                <a:solidFill>
-                  <a:srgbClr val="1F1F1F"/>
-                </a:solidFill>
-              </a:rPr>
-              <a:t>Agent Execution — Numerical Analysis agent → grid, discretization, solver;</a:t>
-            </a:r>
-          </a:p>
-          <a:p>
-            <a:pPr>
-              <a:spcBef>
-                <a:spcPts val="0"/>
-              </a:spcBef>
-              <a:spcAft>
-                <a:spcPts val="200"/>
-              </a:spcAft>
-            </a:pPr>
-            <a:r>
-              <a:rPr sz="1800" b="0">
-                <a:solidFill>
-                  <a:srgbClr val="1F1F1F"/>
-                </a:solidFill>
-              </a:rPr>
-              <a:t>        HPC Code Generation agent → writes, compiles &amp; runs PETSc C;</a:t>
-            </a:r>
-          </a:p>
-          <a:p>
-            <a:pPr>
-              <a:spcBef>
-                <a:spcPts val="0"/>
-              </a:spcBef>
+              <a:t>Three layers of specialist agents (MCP servers):</a:t>
+            </a:r>
+          </a:p>
+          <a:p>
+            <a:pPr algn="l">
               <a:spcAft>
                 <a:spcPts val="600"/>
               </a:spcAft>
             </a:pPr>
             <a:r>
-              <a:rPr sz="1800" b="0">
+              <a:rPr sz="3000" b="0">
                 <a:solidFill>
                   <a:srgbClr val="1F1F1F"/>
                 </a:solidFill>
               </a:rPr>
-              <a:t>        compile-run agent → make / run on the real machine.</a:t>
-            </a:r>
-          </a:p>
-          <a:p>
-            <a:pPr>
-              <a:spcBef>
-                <a:spcPts val="0"/>
-              </a:spcBef>
+              <a:t>• Modeling → PDE identity &amp; strong/weak forms</a:t>
+            </a:r>
+          </a:p>
+          <a:p>
+            <a:pPr algn="l">
               <a:spcAft>
                 <a:spcPts val="600"/>
               </a:spcAft>
             </a:pPr>
             <a:r>
-              <a:rPr sz="1800" b="0">
+              <a:rPr sz="3000" b="0">
                 <a:solidFill>
                   <a:srgbClr val="1F1F1F"/>
                 </a:solidFill>
               </a:rPr>
-              <a:t>Workflow Control — a project-owned driver that records every artifact with provenance (reproducible, resumable).</a:t>
-            </a:r>
-          </a:p>
-          <a:p>
-            <a:pPr>
-              <a:spcBef>
-                <a:spcPts val="0"/>
-              </a:spcBef>
+              <a:t>• Numerical Analysis → grid, discretization, solver</a:t>
+            </a:r>
+          </a:p>
+          <a:p>
+            <a:pPr algn="l">
               <a:spcAft>
                 <a:spcPts val="600"/>
               </a:spcAft>
             </a:pPr>
             <a:r>
-              <a:rPr sz="1800" b="0">
+              <a:rPr sz="3000" b="0">
+                <a:solidFill>
+                  <a:srgbClr val="1F1F1F"/>
+                </a:solidFill>
+              </a:rPr>
+              <a:t>• HPC Code Generation → writes, compiles &amp; runs PETSc C</a:t>
+            </a:r>
+          </a:p>
+          <a:p>
+            <a:pPr algn="l">
+              <a:spcAft>
+                <a:spcPts val="600"/>
+              </a:spcAft>
+            </a:pPr>
+            <a:r>
+              <a:rPr sz="3000" b="0">
+                <a:solidFill>
+                  <a:srgbClr val="1F1F1F"/>
+                </a:solidFill>
+              </a:rPr>
+              <a:t>• Driver → records every artifact (provenance)</a:t>
+            </a:r>
+          </a:p>
+          <a:p>
+            <a:pPr algn="l">
+              <a:spcAft>
+                <a:spcPts val="600"/>
+              </a:spcAft>
+            </a:pPr>
+            <a:r>
+              <a:rPr sz="2700" b="0">
                 <a:solidFill>
                   <a:srgbClr val="4A4A4A"/>
                 </a:solidFill>
               </a:rPr>
-              <a:t>All agents run against Argonne's Argo gateway (Claude Opus 4.8).</a:t>
+              <a:t>All agents run on ANL's Argo gateway (Claude Opus 4.8).</a:t>
             </a:r>
           </a:p>
         </p:txBody>
@@ -3832,8 +3766,8 @@
         </p:nvSpPr>
         <p:spPr>
           <a:xfrm>
-            <a:off x="15087600" y="4389120"/>
-            <a:ext cx="13716000" cy="7498079"/>
+            <a:off x="14767559" y="5852160"/>
+            <a:ext cx="13624560" cy="7680960"/>
           </a:xfrm>
           <a:prstGeom prst="roundRect">
             <a:avLst/>
@@ -3841,7 +3775,7 @@
           <a:solidFill>
             <a:srgbClr val="FFFFFF"/>
           </a:solidFill>
-          <a:ln w="19050">
+          <a:ln w="25400">
             <a:solidFill>
               <a:srgbClr val="007D8A"/>
             </a:solidFill>
@@ -3872,16 +3806,16 @@
       </p:sp>
       <p:sp>
         <p:nvSpPr>
-          <p:cNvPr id="14" name="Rounded Rectangle 13"/>
+          <p:cNvPr id="14" name="Rectangle 13"/>
           <p:cNvSpPr/>
           <p:nvPr/>
         </p:nvSpPr>
         <p:spPr>
           <a:xfrm>
-            <a:off x="15087600" y="4389120"/>
-            <a:ext cx="13716000" cy="1005840"/>
-          </a:xfrm>
-          <a:prstGeom prst="roundRect">
+            <a:off x="14767559" y="5852160"/>
+            <a:ext cx="13624560" cy="1143000"/>
+          </a:xfrm>
+          <a:prstGeom prst="rect">
             <a:avLst/>
           </a:prstGeom>
           <a:solidFill>
@@ -3907,12 +3841,12 @@
           </a:fontRef>
         </p:style>
         <p:txBody>
-          <a:bodyPr rtlCol="0" anchor="ctr" wrap="square" lIns="228600"/>
+          <a:bodyPr rtlCol="0" anchor="ctr" lIns="274320"/>
           <a:lstStyle/>
           <a:p>
             <a:pPr algn="ctr"/>
             <a:r>
-              <a:rPr sz="2600" b="1">
+              <a:rPr sz="4000" b="1">
                 <a:solidFill>
                   <a:srgbClr val="FFFFFF"/>
                 </a:solidFill>
@@ -3930,8 +3864,8 @@
         </p:nvSpPr>
         <p:spPr>
           <a:xfrm>
-            <a:off x="15407640" y="5623560"/>
-            <a:ext cx="13075920" cy="6035040"/>
+            <a:off x="15041880" y="7178040"/>
+            <a:ext cx="13075920" cy="6126480"/>
           </a:xfrm>
           <a:prstGeom prst="rect">
             <a:avLst/>
@@ -3944,93 +3878,78 @@
           </a:bodyPr>
           <a:lstStyle/>
           <a:p>
-            <a:pPr>
-              <a:spcBef>
-                <a:spcPts val="0"/>
-              </a:spcBef>
-              <a:spcAft>
-                <a:spcPts val="800"/>
-              </a:spcAft>
-            </a:pPr>
-            <a:r>
-              <a:rPr sz="1900" b="1">
-                <a:solidFill>
-                  <a:srgbClr val="1F1F1F"/>
-                </a:solidFill>
-              </a:rPr>
-              <a:t>Prompt: “the Grad-Shafranov equilibrium for the plasma in a tokamak.”</a:t>
-            </a:r>
-          </a:p>
-          <a:p>
-            <a:pPr>
-              <a:spcBef>
-                <a:spcPts val="0"/>
-              </a:spcBef>
+            <a:pPr algn="l">
               <a:spcAft>
                 <a:spcPts val="600"/>
               </a:spcAft>
             </a:pPr>
             <a:r>
-              <a:rPr sz="1800" b="0">
+              <a:rPr sz="3000" b="1">
                 <a:solidFill>
                   <a:srgbClr val="1F1F1F"/>
                 </a:solidFill>
               </a:rPr>
-              <a:t>Modeling agent → identified ‘Grad-Shafranov equation’; time-dependent = False.</a:t>
-            </a:r>
-          </a:p>
-          <a:p>
-            <a:pPr>
-              <a:spcBef>
-                <a:spcPts val="0"/>
-              </a:spcBef>
+              <a:t>Prompt: “the Grad-Shafranov equilibrium for the plasma in a tokamak.”</a:t>
+            </a:r>
+          </a:p>
+          <a:p>
+            <a:pPr algn="l">
               <a:spcAft>
                 <a:spcPts val="600"/>
               </a:spcAft>
             </a:pPr>
             <a:r>
-              <a:rPr sz="1800" b="0">
+              <a:rPr sz="3000" b="0">
                 <a:solidFill>
                   <a:srgbClr val="1F1F1F"/>
                 </a:solidFill>
               </a:rPr>
-              <a:t>Numerical Analysis agent → nonlinear solve with SNES.</a:t>
-            </a:r>
-          </a:p>
-          <a:p>
-            <a:pPr>
-              <a:spcBef>
-                <a:spcPts val="0"/>
-              </a:spcBef>
+              <a:t>Modeling → ‘Grad-Shafranov equation’, steady.</a:t>
+            </a:r>
+          </a:p>
+          <a:p>
+            <a:pPr algn="l">
               <a:spcAft>
                 <a:spcPts val="600"/>
               </a:spcAft>
             </a:pPr>
             <a:r>
-              <a:rPr sz="1800" b="0">
+              <a:rPr sz="3000" b="0">
                 <a:solidFill>
                   <a:srgbClr val="1F1F1F"/>
                 </a:solidFill>
               </a:rPr>
-              <a:t>Code Generation agent → 267-line PETSc DMDA+SNES solver (true Jacobian, MMS check).</a:t>
-            </a:r>
-          </a:p>
-          <a:p>
-            <a:pPr>
-              <a:spcBef>
-                <a:spcPts val="0"/>
-              </a:spcBef>
+              <a:t>Numerical Analysis → nonlinear ⇒ SNES.</a:t>
+            </a:r>
+          </a:p>
+          <a:p>
+            <a:pPr algn="l">
               <a:spcAft>
                 <a:spcPts val="600"/>
               </a:spcAft>
             </a:pPr>
             <a:r>
-              <a:rPr sz="1800" b="1">
+              <a:rPr sz="3000" b="0">
+                <a:solidFill>
+                  <a:srgbClr val="1F1F1F"/>
+                </a:solidFill>
+              </a:rPr>
+              <a:t>Code Generation → 267-line PETSc DMDA+SNES solver.</a:t>
+            </a:r>
+          </a:p>
+          <a:p>
+            <a:pPr algn="l">
+              <a:spcAft>
+                <a:spcPts val="600"/>
+              </a:spcAft>
+            </a:pPr>
+            <a:r>
+              <a:rPr sz="3000" b="1">
                 <a:solidFill>
                   <a:srgbClr val="007D8A"/>
                 </a:solidFill>
               </a:rPr>
-              <a:t>Compiled and ran on 1 and 4 MPI ranks — no human edits.</a:t>
+              <a:t>Compiled &amp; ran on 1 and 4 MPI ranks — no human edits.</a:t>
             </a:r>
           </a:p>
         </p:txBody>
@@ -4043,8 +3962,8 @@
         </p:nvSpPr>
         <p:spPr>
           <a:xfrm>
-            <a:off x="15087600" y="12252959"/>
-            <a:ext cx="13716000" cy="7680960"/>
+            <a:off x="14767559" y="13990320"/>
+            <a:ext cx="13624560" cy="7680960"/>
           </a:xfrm>
           <a:prstGeom prst="roundRect">
             <a:avLst/>
@@ -4052,7 +3971,7 @@
           <a:solidFill>
             <a:srgbClr val="FFFFFF"/>
           </a:solidFill>
-          <a:ln w="19050">
+          <a:ln w="25400">
             <a:solidFill>
               <a:srgbClr val="007D8A"/>
             </a:solidFill>
@@ -4083,16 +4002,16 @@
       </p:sp>
       <p:sp>
         <p:nvSpPr>
-          <p:cNvPr id="17" name="Rounded Rectangle 16"/>
+          <p:cNvPr id="17" name="Rectangle 16"/>
           <p:cNvSpPr/>
           <p:nvPr/>
         </p:nvSpPr>
         <p:spPr>
           <a:xfrm>
-            <a:off x="15087600" y="12252959"/>
-            <a:ext cx="13716000" cy="1005840"/>
-          </a:xfrm>
-          <a:prstGeom prst="roundRect">
+            <a:off x="14767559" y="13990320"/>
+            <a:ext cx="13624560" cy="1143000"/>
+          </a:xfrm>
+          <a:prstGeom prst="rect">
             <a:avLst/>
           </a:prstGeom>
           <a:solidFill>
@@ -4118,17 +4037,17 @@
           </a:fontRef>
         </p:style>
         <p:txBody>
-          <a:bodyPr rtlCol="0" anchor="ctr" wrap="square" lIns="228600"/>
+          <a:bodyPr rtlCol="0" anchor="ctr" lIns="274320"/>
           <a:lstStyle/>
           <a:p>
             <a:pPr algn="ctr"/>
             <a:r>
-              <a:rPr sz="2600" b="1">
+              <a:rPr sz="4000" b="1">
                 <a:solidFill>
                   <a:srgbClr val="FFFFFF"/>
                 </a:solidFill>
               </a:rPr>
-              <a:t>5  The agent-generated solver (excerpt)</a:t>
+              <a:t>5  Generated solver (excerpt)</a:t>
             </a:r>
           </a:p>
         </p:txBody>
@@ -4141,8 +4060,8 @@
         </p:nvSpPr>
         <p:spPr>
           <a:xfrm>
-            <a:off x="15407640" y="13487399"/>
-            <a:ext cx="13075920" cy="6217920"/>
+            <a:off x="15041880" y="15316200"/>
+            <a:ext cx="13075920" cy="6126480"/>
           </a:xfrm>
           <a:prstGeom prst="rect">
             <a:avLst/>
@@ -4155,155 +4074,99 @@
           </a:bodyPr>
           <a:lstStyle/>
           <a:p>
-            <a:pPr>
-              <a:spcBef>
-                <a:spcPts val="0"/>
-              </a:spcBef>
-              <a:spcAft>
-                <a:spcPts val="200"/>
-              </a:spcAft>
-            </a:pPr>
-            <a:r>
-              <a:rPr sz="1300" b="0">
-                <a:solidFill>
-                  <a:srgbClr val="4A4A4A"/>
-                </a:solidFill>
-                <a:latin typeface="Consolas"/>
-              </a:rPr>
-              <a:t>/* residual: Delta*_h psi - f, Dirichlet on edges */</a:t>
-            </a:r>
-          </a:p>
-          <a:p>
-            <a:pPr>
-              <a:spcBef>
-                <a:spcPts val="0"/>
-              </a:spcBef>
-              <a:spcAft>
-                <a:spcPts val="200"/>
-              </a:spcAft>
-            </a:pPr>
-            <a:r>
-              <a:rPr sz="1300" b="0">
-                <a:solidFill>
-                  <a:srgbClr val="1F1F1F"/>
-                </a:solidFill>
-                <a:latin typeface="Consolas"/>
-              </a:rPr>
-              <a:t>dRR = (x[j][i+1]-2*x[j][i]+x[j][i-1])/(hR*hR);</a:t>
-            </a:r>
-          </a:p>
-          <a:p>
-            <a:pPr>
-              <a:spcBef>
-                <a:spcPts val="0"/>
-              </a:spcBef>
-              <a:spcAft>
-                <a:spcPts val="200"/>
-              </a:spcAft>
-            </a:pPr>
-            <a:r>
-              <a:rPr sz="1300" b="0">
-                <a:solidFill>
-                  <a:srgbClr val="1F1F1F"/>
-                </a:solidFill>
-                <a:latin typeface="Consolas"/>
-              </a:rPr>
-              <a:t>dR  = (x[j][i+1]-x[j][i-1])/(2*hR);</a:t>
-            </a:r>
-          </a:p>
-          <a:p>
-            <a:pPr>
-              <a:spcBef>
-                <a:spcPts val="0"/>
-              </a:spcBef>
-              <a:spcAft>
-                <a:spcPts val="200"/>
-              </a:spcAft>
-            </a:pPr>
-            <a:r>
-              <a:rPr sz="1300" b="0">
-                <a:solidFill>
-                  <a:srgbClr val="1F1F1F"/>
-                </a:solidFill>
-                <a:latin typeface="Consolas"/>
-              </a:rPr>
-              <a:t>dZZ = (x[j+1][i]-2*x[j][i]+x[j-1][i])/(hZ*hZ);</a:t>
-            </a:r>
-          </a:p>
-          <a:p>
-            <a:pPr>
-              <a:spcBef>
-                <a:spcPts val="0"/>
-              </a:spcBef>
+            <a:pPr algn="l">
               <a:spcAft>
                 <a:spcPts val="600"/>
               </a:spcAft>
             </a:pPr>
             <a:r>
-              <a:rPr sz="1300" b="0">
-                <a:solidFill>
-                  <a:srgbClr val="1F1F1F"/>
+              <a:rPr sz="2300" b="0">
+                <a:solidFill>
+                  <a:srgbClr val="4A4A4A"/>
                 </a:solidFill>
                 <a:latin typeface="Consolas"/>
               </a:rPr>
-              <a:t>f[j][i] = dRR - dR/R + dZZ - ForcingF(user,R,Z);</a:t>
-            </a:r>
-          </a:p>
-          <a:p>
-            <a:pPr>
-              <a:spcBef>
-                <a:spcPts val="0"/>
-              </a:spcBef>
-              <a:spcAft>
-                <a:spcPts val="200"/>
-              </a:spcAft>
-            </a:pPr>
-            <a:r>
-              <a:rPr sz="1300" b="0">
-                <a:solidFill>
-                  <a:srgbClr val="1F1F1F"/>
-                </a:solidFill>
-                <a:latin typeface="Consolas"/>
-              </a:rPr>
-              <a:t>SNESSetFunction(snes, r, FormFunction, &amp;user);</a:t>
-            </a:r>
-          </a:p>
-          <a:p>
-            <a:pPr>
-              <a:spcBef>
-                <a:spcPts val="0"/>
-              </a:spcBef>
-              <a:spcAft>
-                <a:spcPts val="200"/>
-              </a:spcAft>
-            </a:pPr>
-            <a:r>
-              <a:rPr sz="1300" b="0">
-                <a:solidFill>
-                  <a:srgbClr val="1F1F1F"/>
-                </a:solidFill>
-                <a:latin typeface="Consolas"/>
-              </a:rPr>
-              <a:t>SNESSetJacobian(snes, J, J, FormJacobian, &amp;user);</a:t>
-            </a:r>
-          </a:p>
-          <a:p>
-            <a:pPr>
-              <a:spcBef>
-                <a:spcPts val="0"/>
-              </a:spcBef>
+              <a:t>/* residual: Delta*_h psi - f */</a:t>
+            </a:r>
+          </a:p>
+          <a:p>
+            <a:pPr algn="l">
               <a:spcAft>
                 <a:spcPts val="600"/>
               </a:spcAft>
             </a:pPr>
             <a:r>
-              <a:rPr sz="1300" b="0">
+              <a:rPr sz="2300" b="0">
                 <a:solidFill>
                   <a:srgbClr val="1F1F1F"/>
                 </a:solidFill>
                 <a:latin typeface="Consolas"/>
               </a:rPr>
-              <a:t>SNESSolve(snes, NULL, x);</a:t>
+              <a:t>dRR=(x[j][i+1]-2x[j][i]+x[j][i-1])/hR2;</a:t>
+            </a:r>
+          </a:p>
+          <a:p>
+            <a:pPr algn="l">
+              <a:spcAft>
+                <a:spcPts val="600"/>
+              </a:spcAft>
+            </a:pPr>
+            <a:r>
+              <a:rPr sz="2300" b="0">
+                <a:solidFill>
+                  <a:srgbClr val="1F1F1F"/>
+                </a:solidFill>
+                <a:latin typeface="Consolas"/>
+              </a:rPr>
+              <a:t>dZZ=(x[j+1][i]-2x[j][i]+x[j-1][i])/hZ2;</a:t>
+            </a:r>
+          </a:p>
+          <a:p>
+            <a:pPr algn="l">
+              <a:spcAft>
+                <a:spcPts val="600"/>
+              </a:spcAft>
+            </a:pPr>
+            <a:r>
+              <a:rPr sz="2300" b="0">
+                <a:solidFill>
+                  <a:srgbClr val="1F1F1F"/>
+                </a:solidFill>
+                <a:latin typeface="Consolas"/>
+              </a:rPr>
+              <a:t>f[j][i]=dRR-dR/R+dZZ-ForcingF(u,R,Z);</a:t>
+            </a:r>
+          </a:p>
+          <a:p>
+            <a:pPr algn="l">
+              <a:spcAft>
+                <a:spcPts val="600"/>
+              </a:spcAft>
+            </a:pPr>
+            <a:r>
+              <a:rPr sz="2300" b="0">
+                <a:solidFill>
+                  <a:srgbClr val="1F1F1F"/>
+                </a:solidFill>
+                <a:latin typeface="Consolas"/>
+              </a:rPr>
+              <a:t>SNESSetJacobian(snes,J,J,FormJacobian,&amp;u);</a:t>
+            </a:r>
+          </a:p>
+          <a:p>
+            <a:pPr algn="l">
+              <a:spcAft>
+                <a:spcPts val="600"/>
+              </a:spcAft>
+            </a:pPr>
+            <a:r>
+              <a:rPr sz="2300" b="0">
+                <a:solidFill>
+                  <a:srgbClr val="1F1F1F"/>
+                </a:solidFill>
+                <a:latin typeface="Consolas"/>
+              </a:rPr>
+              <a:t>SNESSolve(snes,NULL,x);</a:t>
             </a:r>
           </a:p>
         </p:txBody>
@@ -4316,8 +4179,8 @@
         </p:nvSpPr>
         <p:spPr>
           <a:xfrm>
-            <a:off x="15087600" y="20299680"/>
-            <a:ext cx="13716000" cy="12070080"/>
+            <a:off x="28895039" y="17282160"/>
+            <a:ext cx="13624560" cy="7680960"/>
           </a:xfrm>
           <a:prstGeom prst="roundRect">
             <a:avLst/>
@@ -4325,7 +4188,7 @@
           <a:solidFill>
             <a:srgbClr val="FFFFFF"/>
           </a:solidFill>
-          <a:ln w="19050">
+          <a:ln w="25400">
             <a:solidFill>
               <a:srgbClr val="007D8A"/>
             </a:solidFill>
@@ -4354,9 +4217,371 @@
           </a:p>
         </p:txBody>
       </p:sp>
+      <p:sp>
+        <p:nvSpPr>
+          <p:cNvPr id="20" name="Rectangle 19"/>
+          <p:cNvSpPr/>
+          <p:nvPr/>
+        </p:nvSpPr>
+        <p:spPr>
+          <a:xfrm>
+            <a:off x="28895039" y="17282160"/>
+            <a:ext cx="13624560" cy="1143000"/>
+          </a:xfrm>
+          <a:prstGeom prst="rect">
+            <a:avLst/>
+          </a:prstGeom>
+          <a:solidFill>
+            <a:srgbClr val="002B5C"/>
+          </a:solidFill>
+          <a:ln>
+            <a:noFill/>
+          </a:ln>
+          <a:effectLst/>
+        </p:spPr>
+        <p:style>
+          <a:lnRef idx="1">
+            <a:schemeClr val="accent1"/>
+          </a:lnRef>
+          <a:fillRef idx="3">
+            <a:schemeClr val="accent1"/>
+          </a:fillRef>
+          <a:effectRef idx="2">
+            <a:schemeClr val="accent1"/>
+          </a:effectRef>
+          <a:fontRef idx="minor">
+            <a:schemeClr val="lt1"/>
+          </a:fontRef>
+        </p:style>
+        <p:txBody>
+          <a:bodyPr rtlCol="0" anchor="ctr" lIns="274320"/>
+          <a:lstStyle/>
+          <a:p>
+            <a:pPr algn="ctr"/>
+            <a:r>
+              <a:rPr sz="4000" b="1">
+                <a:solidFill>
+                  <a:srgbClr val="FFFFFF"/>
+                </a:solidFill>
+              </a:rPr>
+              <a:t>7  Decision-gate metrics</a:t>
+            </a:r>
+          </a:p>
+        </p:txBody>
+      </p:sp>
+      <p:sp>
+        <p:nvSpPr>
+          <p:cNvPr id="21" name="TextBox 20"/>
+          <p:cNvSpPr txBox="1"/>
+          <p:nvPr/>
+        </p:nvSpPr>
+        <p:spPr>
+          <a:xfrm>
+            <a:off x="29169360" y="18608039"/>
+            <a:ext cx="13075920" cy="6126480"/>
+          </a:xfrm>
+          <a:prstGeom prst="rect">
+            <a:avLst/>
+          </a:prstGeom>
+          <a:noFill/>
+        </p:spPr>
+        <p:txBody>
+          <a:bodyPr wrap="square" anchor="t">
+            <a:spAutoFit/>
+          </a:bodyPr>
+          <a:lstStyle/>
+          <a:p>
+            <a:pPr algn="l">
+              <a:spcAft>
+                <a:spcPts val="600"/>
+              </a:spcAft>
+            </a:pPr>
+            <a:r>
+              <a:rPr sz="3000" b="0">
+                <a:solidFill>
+                  <a:srgbClr val="1F1F1F"/>
+                </a:solidFill>
+              </a:rPr>
+              <a:t>Model identified ✓   Compiled &amp; ran ✓   SNES converged ✓</a:t>
+            </a:r>
+          </a:p>
+          <a:p>
+            <a:pPr algn="l">
+              <a:spcAft>
+                <a:spcPts val="600"/>
+              </a:spcAft>
+            </a:pPr>
+            <a:r>
+              <a:rPr sz="3000" b="0">
+                <a:solidFill>
+                  <a:srgbClr val="1F1F1F"/>
+                </a:solidFill>
+              </a:rPr>
+              <a:t>Second-order: p = 2.00, 2.00, 2.00  (error 8.4e-04 → 1.3e-05, 33→257).</a:t>
+            </a:r>
+          </a:p>
+          <a:p>
+            <a:pPr algn="l">
+              <a:spcAft>
+                <a:spcPts val="600"/>
+              </a:spcAft>
+            </a:pPr>
+            <a:r>
+              <a:rPr sz="3000" b="0">
+                <a:solidFill>
+                  <a:srgbClr val="1F1F1F"/>
+                </a:solidFill>
+              </a:rPr>
+              <a:t>Human effort: 0 solver lines written; 267 generated.</a:t>
+            </a:r>
+          </a:p>
+          <a:p>
+            <a:pPr algn="l">
+              <a:spcAft>
+                <a:spcPts val="600"/>
+              </a:spcAft>
+            </a:pPr>
+            <a:r>
+              <a:rPr sz="3000" b="0">
+                <a:solidFill>
+                  <a:srgbClr val="1F1F1F"/>
+                </a:solidFill>
+              </a:rPr>
+              <a:t>Efficiency: ~450.8 s wall-clock; ~23 LLM completions.</a:t>
+            </a:r>
+          </a:p>
+        </p:txBody>
+      </p:sp>
+      <p:sp>
+        <p:nvSpPr>
+          <p:cNvPr id="22" name="Rounded Rectangle 21"/>
+          <p:cNvSpPr/>
+          <p:nvPr/>
+        </p:nvSpPr>
+        <p:spPr>
+          <a:xfrm>
+            <a:off x="28895039" y="25420319"/>
+            <a:ext cx="13624560" cy="6949440"/>
+          </a:xfrm>
+          <a:prstGeom prst="roundRect">
+            <a:avLst/>
+          </a:prstGeom>
+          <a:solidFill>
+            <a:srgbClr val="FFFFFF"/>
+          </a:solidFill>
+          <a:ln w="25400">
+            <a:solidFill>
+              <a:srgbClr val="007D8A"/>
+            </a:solidFill>
+          </a:ln>
+          <a:effectLst/>
+        </p:spPr>
+        <p:style>
+          <a:lnRef idx="1">
+            <a:schemeClr val="accent1"/>
+          </a:lnRef>
+          <a:fillRef idx="3">
+            <a:schemeClr val="accent1"/>
+          </a:fillRef>
+          <a:effectRef idx="2">
+            <a:schemeClr val="accent1"/>
+          </a:effectRef>
+          <a:fontRef idx="minor">
+            <a:schemeClr val="lt1"/>
+          </a:fontRef>
+        </p:style>
+        <p:txBody>
+          <a:bodyPr rtlCol="0" anchor="ctr"/>
+          <a:lstStyle/>
+          <a:p>
+            <a:pPr algn="ctr"/>
+          </a:p>
+        </p:txBody>
+      </p:sp>
+      <p:sp>
+        <p:nvSpPr>
+          <p:cNvPr id="23" name="Rectangle 22"/>
+          <p:cNvSpPr/>
+          <p:nvPr/>
+        </p:nvSpPr>
+        <p:spPr>
+          <a:xfrm>
+            <a:off x="28895039" y="25420319"/>
+            <a:ext cx="13624560" cy="1143000"/>
+          </a:xfrm>
+          <a:prstGeom prst="rect">
+            <a:avLst/>
+          </a:prstGeom>
+          <a:solidFill>
+            <a:srgbClr val="002B5C"/>
+          </a:solidFill>
+          <a:ln>
+            <a:noFill/>
+          </a:ln>
+          <a:effectLst/>
+        </p:spPr>
+        <p:style>
+          <a:lnRef idx="1">
+            <a:schemeClr val="accent1"/>
+          </a:lnRef>
+          <a:fillRef idx="3">
+            <a:schemeClr val="accent1"/>
+          </a:fillRef>
+          <a:effectRef idx="2">
+            <a:schemeClr val="accent1"/>
+          </a:effectRef>
+          <a:fontRef idx="minor">
+            <a:schemeClr val="lt1"/>
+          </a:fontRef>
+        </p:style>
+        <p:txBody>
+          <a:bodyPr rtlCol="0" anchor="ctr" lIns="274320"/>
+          <a:lstStyle/>
+          <a:p>
+            <a:pPr algn="ctr"/>
+            <a:r>
+              <a:rPr sz="4000" b="1">
+                <a:solidFill>
+                  <a:srgbClr val="FFFFFF"/>
+                </a:solidFill>
+              </a:rPr>
+              <a:t>8  Contributions &amp; conclusions</a:t>
+            </a:r>
+          </a:p>
+        </p:txBody>
+      </p:sp>
+      <p:sp>
+        <p:nvSpPr>
+          <p:cNvPr id="24" name="TextBox 23"/>
+          <p:cNvSpPr txBox="1"/>
+          <p:nvPr/>
+        </p:nvSpPr>
+        <p:spPr>
+          <a:xfrm>
+            <a:off x="29169360" y="26746199"/>
+            <a:ext cx="13075920" cy="5394960"/>
+          </a:xfrm>
+          <a:prstGeom prst="rect">
+            <a:avLst/>
+          </a:prstGeom>
+          <a:noFill/>
+        </p:spPr>
+        <p:txBody>
+          <a:bodyPr wrap="square" anchor="t">
+            <a:spAutoFit/>
+          </a:bodyPr>
+          <a:lstStyle/>
+          <a:p>
+            <a:pPr algn="l">
+              <a:spcAft>
+                <a:spcPts val="600"/>
+              </a:spcAft>
+            </a:pPr>
+            <a:r>
+              <a:rPr sz="3000" b="0">
+                <a:solidFill>
+                  <a:srgbClr val="1F1F1F"/>
+                </a:solidFill>
+              </a:rPr>
+              <a:t>A verified PETSc fusion-MHD solver produced from a prompt.</a:t>
+            </a:r>
+          </a:p>
+          <a:p>
+            <a:pPr algn="l">
+              <a:spcAft>
+                <a:spcPts val="600"/>
+              </a:spcAft>
+            </a:pPr>
+            <a:r>
+              <a:rPr sz="3000" b="0">
+                <a:solidFill>
+                  <a:srgbClr val="1F1F1F"/>
+                </a:solidFill>
+              </a:rPr>
+              <a:t>Verification-driven: exact-solution + convergence checks.</a:t>
+            </a:r>
+          </a:p>
+          <a:p>
+            <a:pPr algn="l">
+              <a:spcAft>
+                <a:spcPts val="600"/>
+              </a:spcAft>
+            </a:pPr>
+            <a:r>
+              <a:rPr sz="2700" b="0">
+                <a:solidFill>
+                  <a:srgbClr val="1F1F1F"/>
+                </a:solidFill>
+              </a:rPr>
+              <a:t>Upstream fixes: CWD-independent servers; graceful no-docs/RAG; reliable capture.</a:t>
+            </a:r>
+          </a:p>
+          <a:p>
+            <a:pPr algn="l">
+              <a:spcAft>
+                <a:spcPts val="600"/>
+              </a:spcAft>
+            </a:pPr>
+            <a:r>
+              <a:rPr sz="2700" b="0">
+                <a:solidFill>
+                  <a:srgbClr val="007D8A"/>
+                </a:solidFill>
+              </a:rPr>
+              <a:t>github.com/engineer-scientist/petsc_mcp_servers_tokamak</a:t>
+            </a:r>
+          </a:p>
+        </p:txBody>
+      </p:sp>
+      <p:sp>
+        <p:nvSpPr>
+          <p:cNvPr id="25" name="Rounded Rectangle 24"/>
+          <p:cNvSpPr/>
+          <p:nvPr/>
+        </p:nvSpPr>
+        <p:spPr>
+          <a:xfrm>
+            <a:off x="14767559" y="22128480"/>
+            <a:ext cx="13624560" cy="10241279"/>
+          </a:xfrm>
+          <a:prstGeom prst="roundRect">
+            <a:avLst/>
+          </a:prstGeom>
+          <a:solidFill>
+            <a:srgbClr val="FFFFFF"/>
+          </a:solidFill>
+          <a:ln w="25400">
+            <a:solidFill>
+              <a:srgbClr val="007D8A"/>
+            </a:solidFill>
+          </a:ln>
+          <a:effectLst/>
+        </p:spPr>
+        <p:style>
+          <a:lnRef idx="1">
+            <a:schemeClr val="accent1"/>
+          </a:lnRef>
+          <a:fillRef idx="3">
+            <a:schemeClr val="accent1"/>
+          </a:fillRef>
+          <a:effectRef idx="2">
+            <a:schemeClr val="accent1"/>
+          </a:effectRef>
+          <a:fontRef idx="minor">
+            <a:schemeClr val="lt1"/>
+          </a:fontRef>
+        </p:style>
+        <p:txBody>
+          <a:bodyPr rtlCol="0" anchor="ctr"/>
+          <a:lstStyle/>
+          <a:p>
+            <a:pPr algn="ctr"/>
+          </a:p>
+        </p:txBody>
+      </p:sp>
       <p:pic>
         <p:nvPicPr>
-          <p:cNvPr id="20" name="Picture 19" descr="gs_flux_surfaces.png"/>
+          <p:cNvPr id="26" name="Picture 25" descr="gs_flux_surfaces.png"/>
           <p:cNvPicPr>
             <a:picLocks noChangeAspect="1"/>
           </p:cNvPicPr>
@@ -4370,8 +4595,8 @@
         </p:blipFill>
         <p:spPr>
           <a:xfrm>
-            <a:off x="18928080" y="20665440"/>
-            <a:ext cx="8778240" cy="10241280"/>
+            <a:off x="17856925" y="22448520"/>
+            <a:ext cx="7445828" cy="8686799"/>
           </a:xfrm>
           <a:prstGeom prst="rect">
             <a:avLst/>
@@ -4380,14 +4605,14 @@
       </p:pic>
       <p:sp>
         <p:nvSpPr>
-          <p:cNvPr id="21" name="TextBox 20"/>
+          <p:cNvPr id="27" name="TextBox 26"/>
           <p:cNvSpPr txBox="1"/>
           <p:nvPr/>
         </p:nvSpPr>
         <p:spPr>
           <a:xfrm>
-            <a:off x="15407640" y="31363919"/>
-            <a:ext cx="13075920" cy="914400"/>
+            <a:off x="15041880" y="31135319"/>
+            <a:ext cx="13075920" cy="1097280"/>
           </a:xfrm>
           <a:prstGeom prst="rect">
             <a:avLst/>
@@ -4400,35 +4625,32 @@
           </a:bodyPr>
           <a:lstStyle/>
           <a:p>
-            <a:pPr algn="ctr">
-              <a:spcBef>
-                <a:spcPts val="0"/>
-              </a:spcBef>
+            <a:pPr algn="l">
               <a:spcAft>
                 <a:spcPts val="600"/>
               </a:spcAft>
             </a:pPr>
             <a:r>
-              <a:rPr sz="1500" b="0">
+              <a:rPr sz="2500" b="0">
                 <a:solidFill>
                   <a:srgbClr val="4A4A4A"/>
                 </a:solidFill>
               </a:rPr>
-              <a:t>Fig. 1  Poloidal flux surfaces ψ(R,Z) of the verified equilibrium (nested surfaces about the magnetic axis).</a:t>
-            </a:r>
-          </a:p>
-        </p:txBody>
-      </p:sp>
-      <p:sp>
-        <p:nvSpPr>
-          <p:cNvPr id="22" name="Rounded Rectangle 21"/>
+              <a:t>Fig. 1  Poloidal flux surfaces psi(R,Z) of the verified equilibrium.</a:t>
+            </a:r>
+          </a:p>
+        </p:txBody>
+      </p:sp>
+      <p:sp>
+        <p:nvSpPr>
+          <p:cNvPr id="28" name="Rounded Rectangle 27"/>
           <p:cNvSpPr/>
           <p:nvPr/>
         </p:nvSpPr>
         <p:spPr>
           <a:xfrm>
-            <a:off x="29443680" y="4389120"/>
-            <a:ext cx="13716000" cy="10424160"/>
+            <a:off x="28895039" y="5852160"/>
+            <a:ext cx="13624560" cy="10972800"/>
           </a:xfrm>
           <a:prstGeom prst="roundRect">
             <a:avLst/>
@@ -4436,7 +4658,7 @@
           <a:solidFill>
             <a:srgbClr val="FFFFFF"/>
           </a:solidFill>
-          <a:ln w="19050">
+          <a:ln w="25400">
             <a:solidFill>
               <a:srgbClr val="007D8A"/>
             </a:solidFill>
@@ -4467,48 +4689,59 @@
       </p:sp>
       <p:sp>
         <p:nvSpPr>
-          <p:cNvPr id="23" name="TextBox 22"/>
-          <p:cNvSpPr txBox="1"/>
+          <p:cNvPr id="29" name="Rectangle 28"/>
+          <p:cNvSpPr/>
           <p:nvPr/>
         </p:nvSpPr>
         <p:spPr>
           <a:xfrm>
-            <a:off x="29763720" y="4617720"/>
-            <a:ext cx="13075920" cy="822960"/>
+            <a:off x="28895039" y="5852160"/>
+            <a:ext cx="13624560" cy="1143000"/>
           </a:xfrm>
           <a:prstGeom prst="rect">
             <a:avLst/>
           </a:prstGeom>
-          <a:noFill/>
-        </p:spPr>
-        <p:txBody>
-          <a:bodyPr wrap="square" anchor="t">
-            <a:spAutoFit/>
-          </a:bodyPr>
-          <a:lstStyle/>
-          <a:p>
-            <a:pPr>
-              <a:spcBef>
-                <a:spcPts val="0"/>
-              </a:spcBef>
-              <a:spcAft>
-                <a:spcPts val="600"/>
-              </a:spcAft>
-            </a:pPr>
-            <a:r>
-              <a:rPr sz="2600" b="1">
-                <a:solidFill>
-                  <a:srgbClr val="002B5C"/>
+          <a:solidFill>
+            <a:srgbClr val="002B5C"/>
+          </a:solidFill>
+          <a:ln>
+            <a:noFill/>
+          </a:ln>
+          <a:effectLst/>
+        </p:spPr>
+        <p:style>
+          <a:lnRef idx="1">
+            <a:schemeClr val="accent1"/>
+          </a:lnRef>
+          <a:fillRef idx="3">
+            <a:schemeClr val="accent1"/>
+          </a:fillRef>
+          <a:effectRef idx="2">
+            <a:schemeClr val="accent1"/>
+          </a:effectRef>
+          <a:fontRef idx="minor">
+            <a:schemeClr val="lt1"/>
+          </a:fontRef>
+        </p:style>
+        <p:txBody>
+          <a:bodyPr rtlCol="0" anchor="ctr" lIns="274320"/>
+          <a:lstStyle/>
+          <a:p>
+            <a:pPr algn="ctr"/>
+            <a:r>
+              <a:rPr sz="4000" b="1">
+                <a:solidFill>
+                  <a:srgbClr val="FFFFFF"/>
                 </a:solidFill>
               </a:rPr>
-              <a:t>6  Verification: it is actually right</a:t>
+              <a:t>6  Verification</a:t>
             </a:r>
           </a:p>
         </p:txBody>
       </p:sp>
       <p:pic>
         <p:nvPicPr>
-          <p:cNvPr id="24" name="Picture 23" descr="gs_convergence.png"/>
+          <p:cNvPr id="30" name="Picture 29" descr="gs_convergence.png"/>
           <p:cNvPicPr>
             <a:picLocks noChangeAspect="1"/>
           </p:cNvPicPr>
@@ -4522,8 +4755,8 @@
         </p:blipFill>
         <p:spPr>
           <a:xfrm>
-            <a:off x="30998160" y="5577840"/>
-            <a:ext cx="10607040" cy="7955280"/>
+            <a:off x="30129480" y="7223760"/>
+            <a:ext cx="11155679" cy="8366759"/>
           </a:xfrm>
           <a:prstGeom prst="rect">
             <a:avLst/>
@@ -4532,14 +4765,14 @@
       </p:pic>
       <p:sp>
         <p:nvSpPr>
-          <p:cNvPr id="25" name="TextBox 24"/>
+          <p:cNvPr id="31" name="TextBox 30"/>
           <p:cNvSpPr txBox="1"/>
           <p:nvPr/>
         </p:nvSpPr>
         <p:spPr>
           <a:xfrm>
-            <a:off x="29763720" y="13716000"/>
-            <a:ext cx="13075920" cy="1005840"/>
+            <a:off x="29169360" y="15590519"/>
+            <a:ext cx="13075920" cy="1097280"/>
           </a:xfrm>
           <a:prstGeom prst="rect">
             <a:avLst/>
@@ -4552,425 +4785,18 @@
           </a:bodyPr>
           <a:lstStyle/>
           <a:p>
-            <a:pPr algn="ctr">
-              <a:spcBef>
-                <a:spcPts val="0"/>
-              </a:spcBef>
+            <a:pPr algn="l">
               <a:spcAft>
                 <a:spcPts val="600"/>
               </a:spcAft>
             </a:pPr>
             <a:r>
-              <a:rPr sz="1500" b="0">
+              <a:rPr sz="2500" b="0">
                 <a:solidFill>
                   <a:srgbClr val="4A4A4A"/>
                 </a:solidFill>
               </a:rPr>
-              <a:t>Fig. 2  Manufactured-solution error vs grid spacing; both norms track the h² reference → observed order p = 2.00, 2.00, 2.00.</a:t>
-            </a:r>
-          </a:p>
-        </p:txBody>
-      </p:sp>
-      <p:sp>
-        <p:nvSpPr>
-          <p:cNvPr id="26" name="Rounded Rectangle 25"/>
-          <p:cNvSpPr/>
-          <p:nvPr/>
-        </p:nvSpPr>
-        <p:spPr>
-          <a:xfrm>
-            <a:off x="29443680" y="15361920"/>
-            <a:ext cx="13716000" cy="8595360"/>
-          </a:xfrm>
-          <a:prstGeom prst="roundRect">
-            <a:avLst/>
-          </a:prstGeom>
-          <a:solidFill>
-            <a:srgbClr val="FFFFFF"/>
-          </a:solidFill>
-          <a:ln w="19050">
-            <a:solidFill>
-              <a:srgbClr val="007D8A"/>
-            </a:solidFill>
-          </a:ln>
-          <a:effectLst/>
-        </p:spPr>
-        <p:style>
-          <a:lnRef idx="1">
-            <a:schemeClr val="accent1"/>
-          </a:lnRef>
-          <a:fillRef idx="3">
-            <a:schemeClr val="accent1"/>
-          </a:fillRef>
-          <a:effectRef idx="2">
-            <a:schemeClr val="accent1"/>
-          </a:effectRef>
-          <a:fontRef idx="minor">
-            <a:schemeClr val="lt1"/>
-          </a:fontRef>
-        </p:style>
-        <p:txBody>
-          <a:bodyPr rtlCol="0" anchor="ctr"/>
-          <a:lstStyle/>
-          <a:p>
-            <a:pPr algn="ctr"/>
-          </a:p>
-        </p:txBody>
-      </p:sp>
-      <p:sp>
-        <p:nvSpPr>
-          <p:cNvPr id="27" name="Rounded Rectangle 26"/>
-          <p:cNvSpPr/>
-          <p:nvPr/>
-        </p:nvSpPr>
-        <p:spPr>
-          <a:xfrm>
-            <a:off x="29443680" y="15361920"/>
-            <a:ext cx="13716000" cy="1005840"/>
-          </a:xfrm>
-          <a:prstGeom prst="roundRect">
-            <a:avLst/>
-          </a:prstGeom>
-          <a:solidFill>
-            <a:srgbClr val="002B5C"/>
-          </a:solidFill>
-          <a:ln>
-            <a:noFill/>
-          </a:ln>
-          <a:effectLst/>
-        </p:spPr>
-        <p:style>
-          <a:lnRef idx="1">
-            <a:schemeClr val="accent1"/>
-          </a:lnRef>
-          <a:fillRef idx="3">
-            <a:schemeClr val="accent1"/>
-          </a:fillRef>
-          <a:effectRef idx="2">
-            <a:schemeClr val="accent1"/>
-          </a:effectRef>
-          <a:fontRef idx="minor">
-            <a:schemeClr val="lt1"/>
-          </a:fontRef>
-        </p:style>
-        <p:txBody>
-          <a:bodyPr rtlCol="0" anchor="ctr" wrap="square" lIns="228600"/>
-          <a:lstStyle/>
-          <a:p>
-            <a:pPr algn="ctr"/>
-            <a:r>
-              <a:rPr sz="2600" b="1">
-                <a:solidFill>
-                  <a:srgbClr val="FFFFFF"/>
-                </a:solidFill>
-              </a:rPr>
-              <a:t>7  Decision-gate metrics</a:t>
-            </a:r>
-          </a:p>
-        </p:txBody>
-      </p:sp>
-      <p:sp>
-        <p:nvSpPr>
-          <p:cNvPr id="28" name="TextBox 27"/>
-          <p:cNvSpPr txBox="1"/>
-          <p:nvPr/>
-        </p:nvSpPr>
-        <p:spPr>
-          <a:xfrm>
-            <a:off x="29763720" y="16596360"/>
-            <a:ext cx="13075920" cy="7132320"/>
-          </a:xfrm>
-          <a:prstGeom prst="rect">
-            <a:avLst/>
-          </a:prstGeom>
-          <a:noFill/>
-        </p:spPr>
-        <p:txBody>
-          <a:bodyPr wrap="square" anchor="t">
-            <a:spAutoFit/>
-          </a:bodyPr>
-          <a:lstStyle/>
-          <a:p>
-            <a:pPr>
-              <a:spcBef>
-                <a:spcPts val="0"/>
-              </a:spcBef>
-              <a:spcAft>
-                <a:spcPts val="600"/>
-              </a:spcAft>
-            </a:pPr>
-            <a:r>
-              <a:rPr sz="1800" b="0">
-                <a:solidFill>
-                  <a:srgbClr val="1F1F1F"/>
-                </a:solidFill>
-              </a:rPr>
-              <a:t>Correctness — model identified ✓; compiled &amp; ran ✓; CONVERGED_FNORM_RELATIVE.</a:t>
-            </a:r>
-          </a:p>
-          <a:p>
-            <a:pPr>
-              <a:spcBef>
-                <a:spcPts val="0"/>
-              </a:spcBef>
-              <a:spcAft>
-                <a:spcPts val="600"/>
-              </a:spcAft>
-            </a:pPr>
-            <a:r>
-              <a:rPr sz="1800" b="0">
-                <a:solidFill>
-                  <a:srgbClr val="1F1F1F"/>
-                </a:solidFill>
-              </a:rPr>
-              <a:t>Second-order convergence: p = 2.00, 2.00, 2.00  (error 8.4e-04 → 1.3e-05 over 33→257).</a:t>
-            </a:r>
-          </a:p>
-          <a:p>
-            <a:pPr>
-              <a:spcBef>
-                <a:spcPts val="0"/>
-              </a:spcBef>
-              <a:spcAft>
-                <a:spcPts val="600"/>
-              </a:spcAft>
-            </a:pPr>
-            <a:r>
-              <a:rPr sz="1800" b="0">
-                <a:solidFill>
-                  <a:srgbClr val="1F1F1F"/>
-                </a:solidFill>
-              </a:rPr>
-              <a:t>Human effort — 0 lines of solver code hand-written; 267 generated by the agents.</a:t>
-            </a:r>
-          </a:p>
-          <a:p>
-            <a:pPr>
-              <a:spcBef>
-                <a:spcPts val="0"/>
-              </a:spcBef>
-              <a:spcAft>
-                <a:spcPts val="600"/>
-              </a:spcAft>
-            </a:pPr>
-            <a:r>
-              <a:rPr sz="1800" b="0">
-                <a:solidFill>
-                  <a:srgbClr val="1F1F1F"/>
-                </a:solidFill>
-              </a:rPr>
-              <a:t>Efficiency — ~450.8 s wall-clock; 5 code-gen tool calls; ~23 LLM completions.</a:t>
-            </a:r>
-          </a:p>
-        </p:txBody>
-      </p:sp>
-      <p:sp>
-        <p:nvSpPr>
-          <p:cNvPr id="29" name="Rounded Rectangle 28"/>
-          <p:cNvSpPr/>
-          <p:nvPr/>
-        </p:nvSpPr>
-        <p:spPr>
-          <a:xfrm>
-            <a:off x="29443680" y="24323040"/>
-            <a:ext cx="13716000" cy="8046720"/>
-          </a:xfrm>
-          <a:prstGeom prst="roundRect">
-            <a:avLst/>
-          </a:prstGeom>
-          <a:solidFill>
-            <a:srgbClr val="FFFFFF"/>
-          </a:solidFill>
-          <a:ln w="19050">
-            <a:solidFill>
-              <a:srgbClr val="007D8A"/>
-            </a:solidFill>
-          </a:ln>
-          <a:effectLst/>
-        </p:spPr>
-        <p:style>
-          <a:lnRef idx="1">
-            <a:schemeClr val="accent1"/>
-          </a:lnRef>
-          <a:fillRef idx="3">
-            <a:schemeClr val="accent1"/>
-          </a:fillRef>
-          <a:effectRef idx="2">
-            <a:schemeClr val="accent1"/>
-          </a:effectRef>
-          <a:fontRef idx="minor">
-            <a:schemeClr val="lt1"/>
-          </a:fontRef>
-        </p:style>
-        <p:txBody>
-          <a:bodyPr rtlCol="0" anchor="ctr"/>
-          <a:lstStyle/>
-          <a:p>
-            <a:pPr algn="ctr"/>
-          </a:p>
-        </p:txBody>
-      </p:sp>
-      <p:sp>
-        <p:nvSpPr>
-          <p:cNvPr id="30" name="Rounded Rectangle 29"/>
-          <p:cNvSpPr/>
-          <p:nvPr/>
-        </p:nvSpPr>
-        <p:spPr>
-          <a:xfrm>
-            <a:off x="29443680" y="24323040"/>
-            <a:ext cx="13716000" cy="1005840"/>
-          </a:xfrm>
-          <a:prstGeom prst="roundRect">
-            <a:avLst/>
-          </a:prstGeom>
-          <a:solidFill>
-            <a:srgbClr val="002B5C"/>
-          </a:solidFill>
-          <a:ln>
-            <a:noFill/>
-          </a:ln>
-          <a:effectLst/>
-        </p:spPr>
-        <p:style>
-          <a:lnRef idx="1">
-            <a:schemeClr val="accent1"/>
-          </a:lnRef>
-          <a:fillRef idx="3">
-            <a:schemeClr val="accent1"/>
-          </a:fillRef>
-          <a:effectRef idx="2">
-            <a:schemeClr val="accent1"/>
-          </a:effectRef>
-          <a:fontRef idx="minor">
-            <a:schemeClr val="lt1"/>
-          </a:fontRef>
-        </p:style>
-        <p:txBody>
-          <a:bodyPr rtlCol="0" anchor="ctr" wrap="square" lIns="228600"/>
-          <a:lstStyle/>
-          <a:p>
-            <a:pPr algn="ctr"/>
-            <a:r>
-              <a:rPr sz="2600" b="1">
-                <a:solidFill>
-                  <a:srgbClr val="FFFFFF"/>
-                </a:solidFill>
-              </a:rPr>
-              <a:t>8  Contributions &amp; conclusions</a:t>
-            </a:r>
-          </a:p>
-        </p:txBody>
-      </p:sp>
-      <p:sp>
-        <p:nvSpPr>
-          <p:cNvPr id="31" name="TextBox 30"/>
-          <p:cNvSpPr txBox="1"/>
-          <p:nvPr/>
-        </p:nvSpPr>
-        <p:spPr>
-          <a:xfrm>
-            <a:off x="29763720" y="25557480"/>
-            <a:ext cx="13075920" cy="6583680"/>
-          </a:xfrm>
-          <a:prstGeom prst="rect">
-            <a:avLst/>
-          </a:prstGeom>
-          <a:noFill/>
-        </p:spPr>
-        <p:txBody>
-          <a:bodyPr wrap="square" anchor="t">
-            <a:spAutoFit/>
-          </a:bodyPr>
-          <a:lstStyle/>
-          <a:p>
-            <a:pPr>
-              <a:spcBef>
-                <a:spcPts val="0"/>
-              </a:spcBef>
-              <a:spcAft>
-                <a:spcPts val="600"/>
-              </a:spcAft>
-            </a:pPr>
-            <a:r>
-              <a:rPr sz="1700" b="0">
-                <a:solidFill>
-                  <a:srgbClr val="1F1F1F"/>
-                </a:solidFill>
-              </a:rPr>
-              <a:t>A multi-agent system generated a correct, verified PETSc fusion-MHD solver from a prompt.</a:t>
-            </a:r>
-          </a:p>
-          <a:p>
-            <a:pPr>
-              <a:spcBef>
-                <a:spcPts val="0"/>
-              </a:spcBef>
-              <a:spcAft>
-                <a:spcPts val="600"/>
-              </a:spcAft>
-            </a:pPr>
-            <a:r>
-              <a:rPr sz="1700" b="0">
-                <a:solidFill>
-                  <a:srgbClr val="1F1F1F"/>
-                </a:solidFill>
-              </a:rPr>
-              <a:t>Verification-driven: exact-solution + grid-convergence checks, not just plausible output.</a:t>
-            </a:r>
-          </a:p>
-          <a:p>
-            <a:pPr>
-              <a:spcBef>
-                <a:spcPts val="0"/>
-              </a:spcBef>
-              <a:spcAft>
-                <a:spcPts val="600"/>
-              </a:spcAft>
-            </a:pPr>
-            <a:r>
-              <a:rPr sz="1700" b="0">
-                <a:solidFill>
-                  <a:srgbClr val="1F1F1F"/>
-                </a:solidFill>
-              </a:rPr>
-              <a:t>Contributed fixes upstream: CWD-independent server resolution; graceful no-docs/RAG operation; reliable code-gen capture.</a:t>
-            </a:r>
-          </a:p>
-          <a:p>
-            <a:pPr>
-              <a:spcBef>
-                <a:spcPts val="0"/>
-              </a:spcBef>
-              <a:spcAft>
-                <a:spcPts val="800"/>
-              </a:spcAft>
-            </a:pPr>
-            <a:r>
-              <a:rPr sz="1700" b="0">
-                <a:solidFill>
-                  <a:srgbClr val="4A4A4A"/>
-                </a:solidFill>
-              </a:rPr>
-              <a:t>Next: shaped real-machine equilibria (Solov’ev/Cerfon-Freidberg), q-profile, GPU scale-up.</a:t>
-            </a:r>
-          </a:p>
-          <a:p>
-            <a:pPr>
-              <a:spcBef>
-                <a:spcPts val="0"/>
-              </a:spcBef>
-              <a:spcAft>
-                <a:spcPts val="600"/>
-              </a:spcAft>
-            </a:pPr>
-            <a:r>
-              <a:rPr sz="1500" b="0">
-                <a:solidFill>
-                  <a:srgbClr val="007D8A"/>
-                </a:solidFill>
-              </a:rPr>
-              <a:t>Code + data: github.com/engineer-scientist/petsc_mcp_servers_tokamak   ·   System: gitlab.com/petsc/petsc_mcp_servers</a:t>
+              <a:t>Fig. 2  Error vs grid spacing tracks h² → observed order p = 2.00, 2.00, 2.00.</a:t>
             </a:r>
           </a:p>
         </p:txBody>

</xml_diff>

<commit_message>
Updating images and poster.
</commit_message>
<xml_diff>
--- a/poster/USRSE26_poster.pptx
+++ b/poster/USRSE26_poster.pptx
@@ -3165,7 +3165,7 @@
                   <a:srgbClr val="FFFFFF"/>
                 </a:solidFill>
               </a:rPr>
-              <a:t>Automated Problem-to-Solution Generation for a Tokamak Fusion-Plasma Simulation</a:t>
+              <a:t>Automated Problem-to-Solution Generation for Tokamak Fusion-Plasma Simulations</a:t>
             </a:r>
           </a:p>
           <a:p>
@@ -3180,7 +3180,7 @@
                   <a:srgbClr val="CFE6EA"/>
                 </a:solidFill>
               </a:rPr>
-              <a:t>A hierarchical multi-agent PETSc system: from a plain-language prompt to a verified Grad-Shafranov solver</a:t>
+              <a:t>A hierarchical multi-agent PETSc system: from a plain-language prompt to verified, real-machine Grad-Shafranov equilibria</a:t>
             </a:r>
           </a:p>
           <a:p>
@@ -3195,7 +3195,7 @@
                   <a:srgbClr val="FFFFFF"/>
                 </a:solidFill>
               </a:rPr>
-              <a:t>[PRESENTER NAME], &lt;email&gt;, ORCID  ·  Mathematics and Computer Science Division, Argonne National Laboratory  ·  US-RSE 2026</a:t>
+              <a:t>Sarthak Sharma (State University of New York at Buffalo)  ·  Dr Junchao Zhang (Mathematics and Computer Science Division, Argonne National Laboratory)  ·  US-RSE 2026</a:t>
             </a:r>
           </a:p>
         </p:txBody>
@@ -3209,7 +3209,7 @@
         <p:spPr>
           <a:xfrm>
             <a:off x="640080" y="5852160"/>
-            <a:ext cx="13624560" cy="7680960"/>
+            <a:ext cx="13624560" cy="4425696"/>
           </a:xfrm>
           <a:prstGeom prst="roundRect">
             <a:avLst/>
@@ -3307,7 +3307,7 @@
         <p:spPr>
           <a:xfrm>
             <a:off x="914400" y="7178040"/>
-            <a:ext cx="13075920" cy="6126480"/>
+            <a:ext cx="13075920" cy="2871216"/>
           </a:xfrm>
           <a:prstGeom prst="rect">
             <a:avLst/>
@@ -3331,7 +3331,7 @@
                   <a:srgbClr val="1F1F1F"/>
                 </a:solidFill>
               </a:rPr>
-              <a:t>Correct, fast HPC simulation code still demands scarce, implicit expertise in numerical methods and library APIs.</a:t>
+              <a:t>Building correct, fast HPC simulation code demands scarce, implicit expertise. Can a multi-agent AI system automate the path from a plain-language idea to VERIFIED code for a real fusion problem?</a:t>
             </a:r>
           </a:p>
           <a:p>
@@ -3341,27 +3341,12 @@
               </a:spcAft>
             </a:pPr>
             <a:r>
-              <a:rPr sz="3000" b="0">
-                <a:solidFill>
-                  <a:srgbClr val="1F1F1F"/>
+              <a:rPr sz="3000" b="1">
+                <a:solidFill>
+                  <a:srgbClr val="007D8A"/>
                 </a:solidFill>
               </a:rPr>
-              <a:t>Can a multi-agent AI system automate the path from a plain-language idea to VERIFIED code for a real fusion problem?</a:t>
-            </a:r>
-          </a:p>
-          <a:p>
-            <a:pPr algn="l">
-              <a:spcAft>
-                <a:spcPts val="600"/>
-              </a:spcAft>
-            </a:pPr>
-            <a:r>
-              <a:rPr sz="3000" b="0">
-                <a:solidFill>
-                  <a:srgbClr val="1F1F1F"/>
-                </a:solidFill>
-              </a:rPr>
-              <a:t>We apply the open PETSc multi-agent system to the tokamak Grad-Shafranov equilibrium.</a:t>
+              <a:t>We answer yes for the tokamak Grad-Shafranov equilibrium — with verification as a first-class deliverable.</a:t>
             </a:r>
           </a:p>
         </p:txBody>
@@ -3374,8 +3359,8 @@
         </p:nvSpPr>
         <p:spPr>
           <a:xfrm>
-            <a:off x="640080" y="13990320"/>
-            <a:ext cx="13624560" cy="7680960"/>
+            <a:off x="640080" y="21412649"/>
+            <a:ext cx="13624560" cy="5818632"/>
           </a:xfrm>
           <a:prstGeom prst="roundRect">
             <a:avLst/>
@@ -3420,7 +3405,7 @@
         </p:nvSpPr>
         <p:spPr>
           <a:xfrm>
-            <a:off x="640080" y="13990320"/>
+            <a:off x="640080" y="21412649"/>
             <a:ext cx="13624560" cy="1143000"/>
           </a:xfrm>
           <a:prstGeom prst="rect">
@@ -3472,8 +3457,8 @@
         </p:nvSpPr>
         <p:spPr>
           <a:xfrm>
-            <a:off x="914400" y="15316200"/>
-            <a:ext cx="13075920" cy="6126480"/>
+            <a:off x="914400" y="22738529"/>
+            <a:ext cx="13075920" cy="4264152"/>
           </a:xfrm>
           <a:prstGeom prst="rect">
             <a:avLst/>
@@ -3527,7 +3512,7 @@
                   <a:srgbClr val="1F1F1F"/>
                 </a:solidFill>
               </a:rPr>
-              <a:t>Gives the flux surfaces, magnetic axis, and safety factor q.</a:t>
+              <a:t>Sets the flux surfaces, magnetic axis, plasma shape, and safety factor q.</a:t>
             </a:r>
           </a:p>
           <a:p>
@@ -3542,7 +3527,7 @@
                   <a:srgbClr val="1F1F1F"/>
                 </a:solidFill>
               </a:rPr>
-              <a:t>Elliptic, nonlinear → PETSc SNES; verifiable vs an exact solution.</a:t>
+              <a:t>Solov'ev profiles admit an EXACT solution → a rigorous verification anchor.</a:t>
             </a:r>
           </a:p>
         </p:txBody>
@@ -3555,8 +3540,8 @@
         </p:nvSpPr>
         <p:spPr>
           <a:xfrm>
-            <a:off x="640080" y="22128480"/>
-            <a:ext cx="13624560" cy="10241279"/>
+            <a:off x="640080" y="27614880"/>
+            <a:ext cx="13624560" cy="4754880"/>
           </a:xfrm>
           <a:prstGeom prst="roundRect">
             <a:avLst/>
@@ -3601,7 +3586,7 @@
         </p:nvSpPr>
         <p:spPr>
           <a:xfrm>
-            <a:off x="640080" y="22128480"/>
+            <a:off x="640080" y="27614880"/>
             <a:ext cx="13624560" cy="1143000"/>
           </a:xfrm>
           <a:prstGeom prst="rect">
@@ -3653,8 +3638,8 @@
         </p:nvSpPr>
         <p:spPr>
           <a:xfrm>
-            <a:off x="914400" y="23454360"/>
-            <a:ext cx="13075920" cy="8686799"/>
+            <a:off x="914400" y="28940760"/>
+            <a:ext cx="13075920" cy="3200400"/>
           </a:xfrm>
           <a:prstGeom prst="rect">
             <a:avLst/>
@@ -3678,7 +3663,7 @@
                   <a:srgbClr val="1F1F1F"/>
                 </a:solidFill>
               </a:rPr>
-              <a:t>Three layers of specialist agents (MCP servers):</a:t>
+              <a:t>Specialist agents (MCP servers) on ANL's Argo (Claude Opus 4.8):</a:t>
             </a:r>
           </a:p>
           <a:p>
@@ -3693,7 +3678,7 @@
                   <a:srgbClr val="1F1F1F"/>
                 </a:solidFill>
               </a:rPr>
-              <a:t>• Modeling → PDE identity &amp; strong/weak forms</a:t>
+              <a:t>• Modeling → PDE identity &amp; weak form</a:t>
             </a:r>
           </a:p>
           <a:p>
@@ -3738,22 +3723,7 @@
                   <a:srgbClr val="1F1F1F"/>
                 </a:solidFill>
               </a:rPr>
-              <a:t>• Driver → records every artifact (provenance)</a:t>
-            </a:r>
-          </a:p>
-          <a:p>
-            <a:pPr algn="l">
-              <a:spcAft>
-                <a:spcPts val="600"/>
-              </a:spcAft>
-            </a:pPr>
-            <a:r>
-              <a:rPr sz="2700" b="0">
-                <a:solidFill>
-                  <a:srgbClr val="4A4A4A"/>
-                </a:solidFill>
-              </a:rPr>
-              <a:t>All agents run on ANL's Argo gateway (Claude Opus 4.8).</a:t>
+              <a:t>• Driver → records every artifact (full provenance)</a:t>
             </a:r>
           </a:p>
         </p:txBody>
@@ -3767,7 +3737,7 @@
         <p:spPr>
           <a:xfrm>
             <a:off x="14767559" y="5852160"/>
-            <a:ext cx="13624560" cy="7680960"/>
+            <a:ext cx="13624560" cy="6132331"/>
           </a:xfrm>
           <a:prstGeom prst="roundRect">
             <a:avLst/>
@@ -3865,7 +3835,7 @@
         <p:spPr>
           <a:xfrm>
             <a:off x="15041880" y="7178040"/>
-            <a:ext cx="13075920" cy="6126480"/>
+            <a:ext cx="13075920" cy="4577851"/>
           </a:xfrm>
           <a:prstGeom prst="rect">
             <a:avLst/>
@@ -3889,7 +3859,7 @@
                   <a:srgbClr val="1F1F1F"/>
                 </a:solidFill>
               </a:rPr>
-              <a:t>Prompt: “the Grad-Shafranov equilibrium for the plasma in a tokamak.”</a:t>
+              <a:t>Prompt: “the Grad-Shafranov equilibrium for a tokamak plasma.”</a:t>
             </a:r>
           </a:p>
           <a:p>
@@ -3919,7 +3889,7 @@
                   <a:srgbClr val="1F1F1F"/>
                 </a:solidFill>
               </a:rPr>
-              <a:t>Numerical Analysis → nonlinear ⇒ SNES.</a:t>
+              <a:t>Numerical Analysis → nonlinear ⇒ SNES on a DMDA.</a:t>
             </a:r>
           </a:p>
           <a:p>
@@ -3934,7 +3904,7 @@
                   <a:srgbClr val="1F1F1F"/>
                 </a:solidFill>
               </a:rPr>
-              <a:t>Code Generation → 267-line PETSc DMDA+SNES solver.</a:t>
+              <a:t>Code Generation → ONE 252-line parametrized PETSc solver.</a:t>
             </a:r>
           </a:p>
           <a:p>
@@ -3962,8 +3932,8 @@
         </p:nvSpPr>
         <p:spPr>
           <a:xfrm>
-            <a:off x="14767559" y="13990320"/>
-            <a:ext cx="13624560" cy="7680960"/>
+            <a:off x="14767559" y="12990331"/>
+            <a:ext cx="13624560" cy="7526791"/>
           </a:xfrm>
           <a:prstGeom prst="roundRect">
             <a:avLst/>
@@ -4008,7 +3978,7 @@
         </p:nvSpPr>
         <p:spPr>
           <a:xfrm>
-            <a:off x="14767559" y="13990320"/>
+            <a:off x="14767559" y="12990331"/>
             <a:ext cx="13624560" cy="1143000"/>
           </a:xfrm>
           <a:prstGeom prst="rect">
@@ -4060,8 +4030,8 @@
         </p:nvSpPr>
         <p:spPr>
           <a:xfrm>
-            <a:off x="15041880" y="15316200"/>
-            <a:ext cx="13075920" cy="6126480"/>
+            <a:off x="15041880" y="14316211"/>
+            <a:ext cx="13075920" cy="5972311"/>
           </a:xfrm>
           <a:prstGeom prst="rect">
             <a:avLst/>
@@ -4086,7 +4056,7 @@
                 </a:solidFill>
                 <a:latin typeface="Consolas"/>
               </a:rPr>
-              <a:t>/* residual: Delta*_h psi - f */</a:t>
+              <a:t>/* GS operator (normalized x=R/R0), 2nd-order FD */</a:t>
             </a:r>
           </a:p>
           <a:p>
@@ -4102,7 +4072,7 @@
                 </a:solidFill>
                 <a:latin typeface="Consolas"/>
               </a:rPr>
-              <a:t>dRR=(x[j][i+1]-2x[j][i]+x[j][i-1])/hR2;</a:t>
+              <a:t>DMDACreate2d(...,DMDA_STENCIL_STAR,...,&amp;da);</a:t>
             </a:r>
           </a:p>
           <a:p>
@@ -4118,7 +4088,7 @@
                 </a:solidFill>
                 <a:latin typeface="Consolas"/>
               </a:rPr>
-              <a:t>dZZ=(x[j+1][i]-2x[j][i]+x[j-1][i])/hZ2;</a:t>
+              <a:t>dxx=(u[j][i+1]-2*u[j][i]+u[j][i-1])/hx2;</a:t>
             </a:r>
           </a:p>
           <a:p>
@@ -4134,7 +4104,7 @@
                 </a:solidFill>
                 <a:latin typeface="Consolas"/>
               </a:rPr>
-              <a:t>f[j][i]=dRR-dR/R+dZZ-ForcingF(u,R,Z);</a:t>
+              <a:t>dyy=(u[j+1][i]-2*u[j][i]+u[j-1][i])/hy2;</a:t>
             </a:r>
           </a:p>
           <a:p>
@@ -4150,7 +4120,7 @@
                 </a:solidFill>
                 <a:latin typeface="Consolas"/>
               </a:rPr>
-              <a:t>SNESSetJacobian(snes,J,J,FormJacobian,&amp;u);</a:t>
+              <a:t>f[j][i]=dxx-dx/x+dyy-((1-A)*x*x+A);</a:t>
             </a:r>
           </a:p>
           <a:p>
@@ -4162,11 +4132,59 @@
             <a:r>
               <a:rPr sz="2300" b="0">
                 <a:solidFill>
-                  <a:srgbClr val="1F1F1F"/>
+                  <a:srgbClr val="4A4A4A"/>
                 </a:solidFill>
                 <a:latin typeface="Consolas"/>
               </a:rPr>
-              <a:t>SNESSolve(snes,NULL,x);</a:t>
+              <a:t>/* Dirichlet BC = analytic CF psi (nonzero) */</a:t>
+            </a:r>
+          </a:p>
+          <a:p>
+            <a:pPr algn="l">
+              <a:spcAft>
+                <a:spcPts val="600"/>
+              </a:spcAft>
+            </a:pPr>
+            <a:r>
+              <a:rPr sz="2300" b="0">
+                <a:solidFill>
+                  <a:srgbClr val="1F1F1F"/>
+                </a:solidFill>
+                <a:latin typeface="Consolas"/>
+              </a:rPr>
+              <a:t>f[b]=u[b]-PsiExact(&amp;u,x,y);</a:t>
+            </a:r>
+          </a:p>
+          <a:p>
+            <a:pPr algn="l">
+              <a:spcAft>
+                <a:spcPts val="600"/>
+              </a:spcAft>
+            </a:pPr>
+            <a:r>
+              <a:rPr sz="2300" b="0">
+                <a:solidFill>
+                  <a:srgbClr val="1F1F1F"/>
+                </a:solidFill>
+                <a:latin typeface="Consolas"/>
+              </a:rPr>
+              <a:t>SNESSetJacobian(snes,J,J,FormJacobian,&amp;u);</a:t>
+            </a:r>
+          </a:p>
+          <a:p>
+            <a:pPr algn="l">
+              <a:spcAft>
+                <a:spcPts val="600"/>
+              </a:spcAft>
+            </a:pPr>
+            <a:r>
+              <a:rPr sz="2300" b="0">
+                <a:solidFill>
+                  <a:srgbClr val="1F1F1F"/>
+                </a:solidFill>
+                <a:latin typeface="Consolas"/>
+              </a:rPr>
+              <a:t>SNESSolve(snes,NULL,X);</a:t>
             </a:r>
           </a:p>
         </p:txBody>
@@ -4179,8 +4197,8 @@
         </p:nvSpPr>
         <p:spPr>
           <a:xfrm>
-            <a:off x="28895039" y="17282160"/>
-            <a:ext cx="13624560" cy="7680960"/>
+            <a:off x="28895039" y="19179540"/>
+            <a:ext cx="13624560" cy="5308092"/>
           </a:xfrm>
           <a:prstGeom prst="roundRect">
             <a:avLst/>
@@ -4225,7 +4243,7 @@
         </p:nvSpPr>
         <p:spPr>
           <a:xfrm>
-            <a:off x="28895039" y="17282160"/>
+            <a:off x="28895039" y="19179540"/>
             <a:ext cx="13624560" cy="1143000"/>
           </a:xfrm>
           <a:prstGeom prst="rect">
@@ -4264,7 +4282,7 @@
                   <a:srgbClr val="FFFFFF"/>
                 </a:solidFill>
               </a:rPr>
-              <a:t>7  Decision-gate metrics</a:t>
+              <a:t>8  Safety factor &amp; FreeGS cross-check</a:t>
             </a:r>
           </a:p>
         </p:txBody>
@@ -4277,8 +4295,8 @@
         </p:nvSpPr>
         <p:spPr>
           <a:xfrm>
-            <a:off x="29169360" y="18608039"/>
-            <a:ext cx="13075920" cy="6126480"/>
+            <a:off x="29169360" y="20505420"/>
+            <a:ext cx="13075920" cy="3753611"/>
           </a:xfrm>
           <a:prstGeom prst="rect">
             <a:avLst/>
@@ -4302,7 +4320,7 @@
                   <a:srgbClr val="1F1F1F"/>
                 </a:solidFill>
               </a:rPr>
-              <a:t>Model identified ✓   Compiled &amp; ran ✓   SNES converged ✓</a:t>
+              <a:t>Safety-factor q(ψ_N) computed from the verified flux surfaces:</a:t>
             </a:r>
           </a:p>
           <a:p>
@@ -4312,12 +4330,12 @@
               </a:spcAft>
             </a:pPr>
             <a:r>
-              <a:rPr sz="3000" b="0">
-                <a:solidFill>
-                  <a:srgbClr val="1F1F1F"/>
+              <a:rPr sz="3000" b="1">
+                <a:solidFill>
+                  <a:srgbClr val="007D8A"/>
                 </a:solidFill>
               </a:rPr>
-              <a:t>Second-order: p = 2.00, 2.00, 2.00  (error 8.4e-04 → 1.3e-05, 33→257).</a:t>
+              <a:t>ITER q95≈2.9 · NSTX q95≈12.4 · X-point q95≈3.2</a:t>
             </a:r>
           </a:p>
           <a:p>
@@ -4332,7 +4350,7 @@
                   <a:srgbClr val="1F1F1F"/>
                 </a:solidFill>
               </a:rPr>
-              <a:t>Human effort: 0 solver lines written; 267 generated.</a:t>
+              <a:t>Cross-checked vs FreeGS’s independent q on the SAME field → agree to &lt; 0.2%.</a:t>
             </a:r>
           </a:p>
           <a:p>
@@ -4347,7 +4365,7 @@
                   <a:srgbClr val="1F1F1F"/>
                 </a:solidFill>
               </a:rPr>
-              <a:t>Efficiency: ~450.8 s wall-clock; ~23 LLM completions.</a:t>
+              <a:t>Measured κ, δ match the input shaping to ~1–2%.</a:t>
             </a:r>
           </a:p>
         </p:txBody>
@@ -4360,8 +4378,8 @@
         </p:nvSpPr>
         <p:spPr>
           <a:xfrm>
-            <a:off x="28895039" y="25420319"/>
-            <a:ext cx="13624560" cy="6949440"/>
+            <a:off x="28895039" y="25493472"/>
+            <a:ext cx="13624560" cy="6876288"/>
           </a:xfrm>
           <a:prstGeom prst="roundRect">
             <a:avLst/>
@@ -4406,7 +4424,7 @@
         </p:nvSpPr>
         <p:spPr>
           <a:xfrm>
-            <a:off x="28895039" y="25420319"/>
+            <a:off x="28895039" y="25493472"/>
             <a:ext cx="13624560" cy="1143000"/>
           </a:xfrm>
           <a:prstGeom prst="rect">
@@ -4445,7 +4463,7 @@
                   <a:srgbClr val="FFFFFF"/>
                 </a:solidFill>
               </a:rPr>
-              <a:t>8  Contributions &amp; conclusions</a:t>
+              <a:t>9  Results &amp; conclusions</a:t>
             </a:r>
           </a:p>
         </p:txBody>
@@ -4458,8 +4476,8 @@
         </p:nvSpPr>
         <p:spPr>
           <a:xfrm>
-            <a:off x="29169360" y="26746199"/>
-            <a:ext cx="13075920" cy="5394960"/>
+            <a:off x="29169360" y="26819352"/>
+            <a:ext cx="13075920" cy="5321808"/>
           </a:xfrm>
           <a:prstGeom prst="rect">
             <a:avLst/>
@@ -4483,7 +4501,7 @@
                   <a:srgbClr val="1F1F1F"/>
                 </a:solidFill>
               </a:rPr>
-              <a:t>A verified PETSc fusion-MHD solver produced from a prompt.</a:t>
+              <a:t>One 252-line solver, 0 hand-written, verified on 3 real-machine equilibria.</a:t>
             </a:r>
           </a:p>
           <a:p>
@@ -4498,7 +4516,7 @@
                   <a:srgbClr val="1F1F1F"/>
                 </a:solidFill>
               </a:rPr>
-              <a:t>Verification-driven: exact-solution + convergence checks.</a:t>
+              <a:t>2nd-order accurate (p = 2.00) on every case; runs on 1 &amp; 4 MPI ranks.</a:t>
             </a:r>
           </a:p>
           <a:p>
@@ -4508,12 +4526,12 @@
               </a:spcAft>
             </a:pPr>
             <a:r>
-              <a:rPr sz="2700" b="0">
+              <a:rPr sz="3000" b="0">
                 <a:solidFill>
                   <a:srgbClr val="1F1F1F"/>
                 </a:solidFill>
               </a:rPr>
-              <a:t>Upstream fixes: CWD-independent servers; graceful no-docs/RAG; reliable capture.</a:t>
+              <a:t>Efficiency: ~311.4 s wall-clock; ~27 LLM completions.</a:t>
             </a:r>
           </a:p>
           <a:p>
@@ -4523,6 +4541,21 @@
               </a:spcAft>
             </a:pPr>
             <a:r>
+              <a:rPr sz="3000" b="0">
+                <a:solidFill>
+                  <a:srgbClr val="1F1F1F"/>
+                </a:solidFill>
+              </a:rPr>
+              <a:t>Verification-driven: exact-solution convergence + independent q cross-check.</a:t>
+            </a:r>
+          </a:p>
+          <a:p>
+            <a:pPr algn="l">
+              <a:spcAft>
+                <a:spcPts val="600"/>
+              </a:spcAft>
+            </a:pPr>
+            <a:r>
               <a:rPr sz="2700" b="0">
                 <a:solidFill>
                   <a:srgbClr val="007D8A"/>
@@ -4541,8 +4574,8 @@
         </p:nvSpPr>
         <p:spPr>
           <a:xfrm>
-            <a:off x="14767559" y="22128480"/>
-            <a:ext cx="13624560" cy="10241279"/>
+            <a:off x="640080" y="10661454"/>
+            <a:ext cx="13624560" cy="10367596"/>
           </a:xfrm>
           <a:prstGeom prst="roundRect">
             <a:avLst/>
@@ -4579,9 +4612,61 @@
           </a:p>
         </p:txBody>
       </p:sp>
+      <p:sp>
+        <p:nvSpPr>
+          <p:cNvPr id="26" name="Rectangle 25"/>
+          <p:cNvSpPr/>
+          <p:nvPr/>
+        </p:nvSpPr>
+        <p:spPr>
+          <a:xfrm>
+            <a:off x="640080" y="10661454"/>
+            <a:ext cx="13624560" cy="1143000"/>
+          </a:xfrm>
+          <a:prstGeom prst="rect">
+            <a:avLst/>
+          </a:prstGeom>
+          <a:solidFill>
+            <a:srgbClr val="002B5C"/>
+          </a:solidFill>
+          <a:ln>
+            <a:noFill/>
+          </a:ln>
+          <a:effectLst/>
+        </p:spPr>
+        <p:style>
+          <a:lnRef idx="1">
+            <a:schemeClr val="accent1"/>
+          </a:lnRef>
+          <a:fillRef idx="3">
+            <a:schemeClr val="accent1"/>
+          </a:fillRef>
+          <a:effectRef idx="2">
+            <a:schemeClr val="accent1"/>
+          </a:effectRef>
+          <a:fontRef idx="minor">
+            <a:schemeClr val="lt1"/>
+          </a:fontRef>
+        </p:style>
+        <p:txBody>
+          <a:bodyPr rtlCol="0" anchor="ctr" lIns="274320"/>
+          <a:lstStyle/>
+          <a:p>
+            <a:pPr algn="ctr"/>
+            <a:r>
+              <a:rPr sz="4000" b="1">
+                <a:solidFill>
+                  <a:srgbClr val="FFFFFF"/>
+                </a:solidFill>
+              </a:rPr>
+              <a:t>Fusion energy</a:t>
+            </a:r>
+          </a:p>
+        </p:txBody>
+      </p:sp>
       <p:pic>
         <p:nvPicPr>
-          <p:cNvPr id="26" name="Picture 25" descr="gs_flux_surfaces.png"/>
+          <p:cNvPr id="27" name="Picture 26" descr="schematic of nuclear fusion power plant.png"/>
           <p:cNvPicPr>
             <a:picLocks noChangeAspect="1"/>
           </p:cNvPicPr>
@@ -4595,8 +4680,8 @@
         </p:blipFill>
         <p:spPr>
           <a:xfrm>
-            <a:off x="17856925" y="22448520"/>
-            <a:ext cx="7445828" cy="8686799"/>
+            <a:off x="1097280" y="12033054"/>
+            <a:ext cx="12710159" cy="7578676"/>
           </a:xfrm>
           <a:prstGeom prst="rect">
             <a:avLst/>
@@ -4605,13 +4690,13 @@
       </p:pic>
       <p:sp>
         <p:nvSpPr>
-          <p:cNvPr id="27" name="TextBox 26"/>
+          <p:cNvPr id="28" name="TextBox 27"/>
           <p:cNvSpPr txBox="1"/>
           <p:nvPr/>
         </p:nvSpPr>
         <p:spPr>
           <a:xfrm>
-            <a:off x="15041880" y="31135319"/>
+            <a:off x="914400" y="19794610"/>
             <a:ext cx="13075920" cy="1097280"/>
           </a:xfrm>
           <a:prstGeom prst="rect">
@@ -4636,21 +4721,21 @@
                   <a:srgbClr val="4A4A4A"/>
                 </a:solidFill>
               </a:rPr>
-              <a:t>Fig. 1  Poloidal flux surfaces psi(R,Z) of the verified equilibrium.</a:t>
-            </a:r>
-          </a:p>
-        </p:txBody>
-      </p:sp>
-      <p:sp>
-        <p:nvSpPr>
-          <p:cNvPr id="28" name="Rounded Rectangle 27"/>
+              <a:t>A tokamak turns fusion heat into electricity; its plasma equilibrium is governed by the Grad-Shafranov equation.</a:t>
+            </a:r>
+          </a:p>
+        </p:txBody>
+      </p:sp>
+      <p:sp>
+        <p:nvSpPr>
+          <p:cNvPr id="29" name="Rounded Rectangle 28"/>
           <p:cNvSpPr/>
           <p:nvPr/>
         </p:nvSpPr>
         <p:spPr>
           <a:xfrm>
-            <a:off x="28895039" y="5852160"/>
-            <a:ext cx="13624560" cy="10972800"/>
+            <a:off x="14767559" y="21522963"/>
+            <a:ext cx="13624560" cy="10846796"/>
           </a:xfrm>
           <a:prstGeom prst="roundRect">
             <a:avLst/>
@@ -4689,13 +4774,13 @@
       </p:sp>
       <p:sp>
         <p:nvSpPr>
-          <p:cNvPr id="29" name="Rectangle 28"/>
+          <p:cNvPr id="30" name="Rectangle 29"/>
           <p:cNvSpPr/>
           <p:nvPr/>
         </p:nvSpPr>
         <p:spPr>
           <a:xfrm>
-            <a:off x="28895039" y="5852160"/>
+            <a:off x="14767559" y="21522963"/>
             <a:ext cx="13624560" cy="1143000"/>
           </a:xfrm>
           <a:prstGeom prst="rect">
@@ -4734,14 +4819,14 @@
                   <a:srgbClr val="FFFFFF"/>
                 </a:solidFill>
               </a:rPr>
-              <a:t>6  Verification</a:t>
+              <a:t>6  Real-machine equilibria</a:t>
             </a:r>
           </a:p>
         </p:txBody>
       </p:sp>
       <p:pic>
         <p:nvPicPr>
-          <p:cNvPr id="30" name="Picture 29" descr="gs_convergence.png"/>
+          <p:cNvPr id="31" name="Picture 30" descr="shaped_equilibria.png"/>
           <p:cNvPicPr>
             <a:picLocks noChangeAspect="1"/>
           </p:cNvPicPr>
@@ -4755,8 +4840,8 @@
         </p:blipFill>
         <p:spPr>
           <a:xfrm>
-            <a:off x="30129480" y="7223760"/>
-            <a:ext cx="11155679" cy="8366759"/>
+            <a:off x="15224759" y="22894563"/>
+            <a:ext cx="12710159" cy="8057876"/>
           </a:xfrm>
           <a:prstGeom prst="rect">
             <a:avLst/>
@@ -4765,13 +4850,13 @@
       </p:pic>
       <p:sp>
         <p:nvSpPr>
-          <p:cNvPr id="31" name="TextBox 30"/>
+          <p:cNvPr id="32" name="TextBox 31"/>
           <p:cNvSpPr txBox="1"/>
           <p:nvPr/>
         </p:nvSpPr>
         <p:spPr>
           <a:xfrm>
-            <a:off x="29169360" y="15590519"/>
+            <a:off x="15041880" y="31135320"/>
             <a:ext cx="13075920" cy="1097280"/>
           </a:xfrm>
           <a:prstGeom prst="rect">
@@ -4796,7 +4881,167 @@
                   <a:srgbClr val="4A4A4A"/>
                 </a:solidFill>
               </a:rPr>
-              <a:t>Fig. 2  Error vs grid spacing tracks h² → observed order p = 2.00, 2.00, 2.00.</a:t>
+              <a:t>Fig. 1  One agent-generated solver → ITER, spherical-tokamak (NSTX-like) and diverted double-null (X-point) equilibria. Red = separatrix; × = X-points.</a:t>
+            </a:r>
+          </a:p>
+        </p:txBody>
+      </p:sp>
+      <p:sp>
+        <p:nvSpPr>
+          <p:cNvPr id="33" name="Rounded Rectangle 32"/>
+          <p:cNvSpPr/>
+          <p:nvPr/>
+        </p:nvSpPr>
+        <p:spPr>
+          <a:xfrm>
+            <a:off x="28895039" y="5852160"/>
+            <a:ext cx="13624560" cy="12321540"/>
+          </a:xfrm>
+          <a:prstGeom prst="roundRect">
+            <a:avLst/>
+          </a:prstGeom>
+          <a:solidFill>
+            <a:srgbClr val="FFFFFF"/>
+          </a:solidFill>
+          <a:ln w="25400">
+            <a:solidFill>
+              <a:srgbClr val="007D8A"/>
+            </a:solidFill>
+          </a:ln>
+          <a:effectLst/>
+        </p:spPr>
+        <p:style>
+          <a:lnRef idx="1">
+            <a:schemeClr val="accent1"/>
+          </a:lnRef>
+          <a:fillRef idx="3">
+            <a:schemeClr val="accent1"/>
+          </a:fillRef>
+          <a:effectRef idx="2">
+            <a:schemeClr val="accent1"/>
+          </a:effectRef>
+          <a:fontRef idx="minor">
+            <a:schemeClr val="lt1"/>
+          </a:fontRef>
+        </p:style>
+        <p:txBody>
+          <a:bodyPr rtlCol="0" anchor="ctr"/>
+          <a:lstStyle/>
+          <a:p>
+            <a:pPr algn="ctr"/>
+          </a:p>
+        </p:txBody>
+      </p:sp>
+      <p:sp>
+        <p:nvSpPr>
+          <p:cNvPr id="34" name="Rectangle 33"/>
+          <p:cNvSpPr/>
+          <p:nvPr/>
+        </p:nvSpPr>
+        <p:spPr>
+          <a:xfrm>
+            <a:off x="28895039" y="5852160"/>
+            <a:ext cx="13624560" cy="1143000"/>
+          </a:xfrm>
+          <a:prstGeom prst="rect">
+            <a:avLst/>
+          </a:prstGeom>
+          <a:solidFill>
+            <a:srgbClr val="002B5C"/>
+          </a:solidFill>
+          <a:ln>
+            <a:noFill/>
+          </a:ln>
+          <a:effectLst/>
+        </p:spPr>
+        <p:style>
+          <a:lnRef idx="1">
+            <a:schemeClr val="accent1"/>
+          </a:lnRef>
+          <a:fillRef idx="3">
+            <a:schemeClr val="accent1"/>
+          </a:fillRef>
+          <a:effectRef idx="2">
+            <a:schemeClr val="accent1"/>
+          </a:effectRef>
+          <a:fontRef idx="minor">
+            <a:schemeClr val="lt1"/>
+          </a:fontRef>
+        </p:style>
+        <p:txBody>
+          <a:bodyPr rtlCol="0" anchor="ctr" lIns="274320"/>
+          <a:lstStyle/>
+          <a:p>
+            <a:pPr algn="ctr"/>
+            <a:r>
+              <a:rPr sz="4000" b="1">
+                <a:solidFill>
+                  <a:srgbClr val="FFFFFF"/>
+                </a:solidFill>
+              </a:rPr>
+              <a:t>7  Verification: 2nd order</a:t>
+            </a:r>
+          </a:p>
+        </p:txBody>
+      </p:sp>
+      <p:pic>
+        <p:nvPicPr>
+          <p:cNvPr id="35" name="Picture 34" descr="shaped_convergence.png"/>
+          <p:cNvPicPr>
+            <a:picLocks noChangeAspect="1"/>
+          </p:cNvPicPr>
+          <p:nvPr/>
+        </p:nvPicPr>
+        <p:blipFill>
+          <a:blip r:embed="rId4"/>
+          <a:stretch>
+            <a:fillRect/>
+          </a:stretch>
+        </p:blipFill>
+        <p:spPr>
+          <a:xfrm>
+            <a:off x="29352239" y="7223760"/>
+            <a:ext cx="12710159" cy="9532619"/>
+          </a:xfrm>
+          <a:prstGeom prst="rect">
+            <a:avLst/>
+          </a:prstGeom>
+        </p:spPr>
+      </p:pic>
+      <p:sp>
+        <p:nvSpPr>
+          <p:cNvPr id="36" name="TextBox 35"/>
+          <p:cNvSpPr txBox="1"/>
+          <p:nvPr/>
+        </p:nvSpPr>
+        <p:spPr>
+          <a:xfrm>
+            <a:off x="29169360" y="16939260"/>
+            <a:ext cx="13075920" cy="1097280"/>
+          </a:xfrm>
+          <a:prstGeom prst="rect">
+            <a:avLst/>
+          </a:prstGeom>
+          <a:noFill/>
+        </p:spPr>
+        <p:txBody>
+          <a:bodyPr wrap="square" anchor="t">
+            <a:spAutoFit/>
+          </a:bodyPr>
+          <a:lstStyle/>
+          <a:p>
+            <a:pPr algn="l">
+              <a:spcAft>
+                <a:spcPts val="600"/>
+              </a:spcAft>
+            </a:pPr>
+            <a:r>
+              <a:rPr sz="2500" b="0">
+                <a:solidFill>
+                  <a:srgbClr val="4A4A4A"/>
+                </a:solidFill>
+              </a:rPr>
+              <a:t>Fig. 2  Method of manufactured solutions vs the exact Cerfon-Freidberg solution: observed order p = 2.00 for all three machines.</a:t>
             </a:r>
           </a:p>
         </p:txBody>

</xml_diff>

<commit_message>
Update USRSE26 poster and its abstract.
</commit_message>
<xml_diff>
--- a/poster/USRSE26_poster.pptx
+++ b/poster/USRSE26_poster.pptx
@@ -5,9 +5,9 @@
     <p:sldMasterId id="2147483648" r:id="rId1"/>
   </p:sldMasterIdLst>
   <p:sldIdLst>
-    <p:sldId id="256" r:id="rId7"/>
+    <p:sldId id="256" r:id="rId2"/>
   </p:sldIdLst>
-  <p:sldSz cx="43891200" cy="32918400" type="screen4x3"/>
+  <p:sldSz cx="43891200" cy="32918400"/>
   <p:notesSz cx="6858000" cy="9144000"/>
   <p:defaultTextStyle>
     <a:defPPr>
@@ -104,6 +104,22 @@
       </a:defRPr>
     </a:lvl9pPr>
   </p:defaultTextStyle>
+  <p:extLst>
+    <p:ext uri="{EFAFB233-063F-42B5-8137-9DF3F51BA10A}">
+      <p15:sldGuideLst xmlns:p15="http://schemas.microsoft.com/office/powerpoint/2012/main">
+        <p15:guide id="1" orient="horz" pos="2160">
+          <p15:clr>
+            <a:srgbClr val="A4A3A4"/>
+          </p15:clr>
+        </p15:guide>
+        <p15:guide id="2" pos="2880">
+          <p15:clr>
+            <a:srgbClr val="A4A3A4"/>
+          </p15:clr>
+        </p15:guide>
+      </p15:sldGuideLst>
+    </p:ext>
+  </p:extLst>
 </p:presentation>
 </file>
 
@@ -145,10 +161,9 @@
           <a:lstStyle/>
           <a:p>
             <a:r>
-              <a:rPr lang="en-US" smtClean="0"/>
+              <a:rPr lang="en-US"/>
               <a:t>Click to edit Master title style</a:t>
             </a:r>
-            <a:endParaRPr lang="en-US"/>
           </a:p>
         </p:txBody>
       </p:sp>
@@ -264,10 +279,9 @@
           </a:lstStyle>
           <a:p>
             <a:r>
-              <a:rPr lang="en-US" smtClean="0"/>
+              <a:rPr lang="en-US"/>
               <a:t>Click to edit Master subtitle style</a:t>
             </a:r>
-            <a:endParaRPr lang="en-US"/>
           </a:p>
         </p:txBody>
       </p:sp>
@@ -288,7 +302,7 @@
           <a:p>
             <a:fld id="{5BCAD085-E8A6-8845-BD4E-CB4CCA059FC4}" type="datetimeFigureOut">
               <a:rPr lang="en-US" smtClean="0"/>
-              <a:t>1/27/13</a:t>
+              <a:t>2026-08-06</a:t>
             </a:fld>
             <a:endParaRPr lang="en-US"/>
           </a:p>
@@ -382,10 +396,9 @@
           <a:lstStyle/>
           <a:p>
             <a:r>
-              <a:rPr lang="en-US" smtClean="0"/>
+              <a:rPr lang="en-US"/>
               <a:t>Click to edit Master title style</a:t>
             </a:r>
-            <a:endParaRPr lang="en-US"/>
           </a:p>
         </p:txBody>
       </p:sp>
@@ -406,38 +419,37 @@
           <a:p>
             <a:pPr lvl="0"/>
             <a:r>
-              <a:rPr lang="en-US" smtClean="0"/>
+              <a:rPr lang="en-US"/>
               <a:t>Click to edit Master text styles</a:t>
             </a:r>
           </a:p>
           <a:p>
             <a:pPr lvl="1"/>
             <a:r>
-              <a:rPr lang="en-US" smtClean="0"/>
+              <a:rPr lang="en-US"/>
               <a:t>Second level</a:t>
             </a:r>
           </a:p>
           <a:p>
             <a:pPr lvl="2"/>
             <a:r>
-              <a:rPr lang="en-US" smtClean="0"/>
+              <a:rPr lang="en-US"/>
               <a:t>Third level</a:t>
             </a:r>
           </a:p>
           <a:p>
             <a:pPr lvl="3"/>
             <a:r>
-              <a:rPr lang="en-US" smtClean="0"/>
+              <a:rPr lang="en-US"/>
               <a:t>Fourth level</a:t>
             </a:r>
           </a:p>
           <a:p>
             <a:pPr lvl="4"/>
             <a:r>
-              <a:rPr lang="en-US" smtClean="0"/>
+              <a:rPr lang="en-US"/>
               <a:t>Fifth level</a:t>
             </a:r>
-            <a:endParaRPr lang="en-US"/>
           </a:p>
         </p:txBody>
       </p:sp>
@@ -458,7 +470,7 @@
           <a:p>
             <a:fld id="{5BCAD085-E8A6-8845-BD4E-CB4CCA059FC4}" type="datetimeFigureOut">
               <a:rPr lang="en-US" smtClean="0"/>
-              <a:t>1/27/13</a:t>
+              <a:t>2026-08-06</a:t>
             </a:fld>
             <a:endParaRPr lang="en-US"/>
           </a:p>
@@ -557,10 +569,9 @@
           <a:lstStyle/>
           <a:p>
             <a:r>
-              <a:rPr lang="en-US" smtClean="0"/>
+              <a:rPr lang="en-US"/>
               <a:t>Click to edit Master title style</a:t>
             </a:r>
-            <a:endParaRPr lang="en-US"/>
           </a:p>
         </p:txBody>
       </p:sp>
@@ -586,38 +597,37 @@
           <a:p>
             <a:pPr lvl="0"/>
             <a:r>
-              <a:rPr lang="en-US" smtClean="0"/>
+              <a:rPr lang="en-US"/>
               <a:t>Click to edit Master text styles</a:t>
             </a:r>
           </a:p>
           <a:p>
             <a:pPr lvl="1"/>
             <a:r>
-              <a:rPr lang="en-US" smtClean="0"/>
+              <a:rPr lang="en-US"/>
               <a:t>Second level</a:t>
             </a:r>
           </a:p>
           <a:p>
             <a:pPr lvl="2"/>
             <a:r>
-              <a:rPr lang="en-US" smtClean="0"/>
+              <a:rPr lang="en-US"/>
               <a:t>Third level</a:t>
             </a:r>
           </a:p>
           <a:p>
             <a:pPr lvl="3"/>
             <a:r>
-              <a:rPr lang="en-US" smtClean="0"/>
+              <a:rPr lang="en-US"/>
               <a:t>Fourth level</a:t>
             </a:r>
           </a:p>
           <a:p>
             <a:pPr lvl="4"/>
             <a:r>
-              <a:rPr lang="en-US" smtClean="0"/>
+              <a:rPr lang="en-US"/>
               <a:t>Fifth level</a:t>
             </a:r>
-            <a:endParaRPr lang="en-US"/>
           </a:p>
         </p:txBody>
       </p:sp>
@@ -638,7 +648,7 @@
           <a:p>
             <a:fld id="{5BCAD085-E8A6-8845-BD4E-CB4CCA059FC4}" type="datetimeFigureOut">
               <a:rPr lang="en-US" smtClean="0"/>
-              <a:t>1/27/13</a:t>
+              <a:t>2026-08-06</a:t>
             </a:fld>
             <a:endParaRPr lang="en-US"/>
           </a:p>
@@ -732,10 +742,9 @@
           <a:lstStyle/>
           <a:p>
             <a:r>
-              <a:rPr lang="en-US" smtClean="0"/>
+              <a:rPr lang="en-US"/>
               <a:t>Click to edit Master title style</a:t>
             </a:r>
-            <a:endParaRPr lang="en-US"/>
           </a:p>
         </p:txBody>
       </p:sp>
@@ -756,38 +765,37 @@
           <a:p>
             <a:pPr lvl="0"/>
             <a:r>
-              <a:rPr lang="en-US" smtClean="0"/>
+              <a:rPr lang="en-US"/>
               <a:t>Click to edit Master text styles</a:t>
             </a:r>
           </a:p>
           <a:p>
             <a:pPr lvl="1"/>
             <a:r>
-              <a:rPr lang="en-US" smtClean="0"/>
+              <a:rPr lang="en-US"/>
               <a:t>Second level</a:t>
             </a:r>
           </a:p>
           <a:p>
             <a:pPr lvl="2"/>
             <a:r>
-              <a:rPr lang="en-US" smtClean="0"/>
+              <a:rPr lang="en-US"/>
               <a:t>Third level</a:t>
             </a:r>
           </a:p>
           <a:p>
             <a:pPr lvl="3"/>
             <a:r>
-              <a:rPr lang="en-US" smtClean="0"/>
+              <a:rPr lang="en-US"/>
               <a:t>Fourth level</a:t>
             </a:r>
           </a:p>
           <a:p>
             <a:pPr lvl="4"/>
             <a:r>
-              <a:rPr lang="en-US" smtClean="0"/>
+              <a:rPr lang="en-US"/>
               <a:t>Fifth level</a:t>
             </a:r>
-            <a:endParaRPr lang="en-US"/>
           </a:p>
         </p:txBody>
       </p:sp>
@@ -808,7 +816,7 @@
           <a:p>
             <a:fld id="{5BCAD085-E8A6-8845-BD4E-CB4CCA059FC4}" type="datetimeFigureOut">
               <a:rPr lang="en-US" smtClean="0"/>
-              <a:t>1/27/13</a:t>
+              <a:t>2026-08-06</a:t>
             </a:fld>
             <a:endParaRPr lang="en-US"/>
           </a:p>
@@ -911,10 +919,9 @@
           </a:lstStyle>
           <a:p>
             <a:r>
-              <a:rPr lang="en-US" smtClean="0"/>
+              <a:rPr lang="en-US"/>
               <a:t>Click to edit Master title style</a:t>
             </a:r>
-            <a:endParaRPr lang="en-US"/>
           </a:p>
         </p:txBody>
       </p:sp>
@@ -1031,7 +1038,7 @@
           <a:p>
             <a:pPr lvl="0"/>
             <a:r>
-              <a:rPr lang="en-US" smtClean="0"/>
+              <a:rPr lang="en-US"/>
               <a:t>Click to edit Master text styles</a:t>
             </a:r>
           </a:p>
@@ -1054,7 +1061,7 @@
           <a:p>
             <a:fld id="{5BCAD085-E8A6-8845-BD4E-CB4CCA059FC4}" type="datetimeFigureOut">
               <a:rPr lang="en-US" smtClean="0"/>
-              <a:t>1/27/13</a:t>
+              <a:t>2026-08-06</a:t>
             </a:fld>
             <a:endParaRPr lang="en-US"/>
           </a:p>
@@ -1148,10 +1155,9 @@
           <a:lstStyle/>
           <a:p>
             <a:r>
-              <a:rPr lang="en-US" smtClean="0"/>
+              <a:rPr lang="en-US"/>
               <a:t>Click to edit Master title style</a:t>
             </a:r>
-            <a:endParaRPr lang="en-US"/>
           </a:p>
         </p:txBody>
       </p:sp>
@@ -1205,38 +1211,37 @@
           <a:p>
             <a:pPr lvl="0"/>
             <a:r>
-              <a:rPr lang="en-US" smtClean="0"/>
+              <a:rPr lang="en-US"/>
               <a:t>Click to edit Master text styles</a:t>
             </a:r>
           </a:p>
           <a:p>
             <a:pPr lvl="1"/>
             <a:r>
-              <a:rPr lang="en-US" smtClean="0"/>
+              <a:rPr lang="en-US"/>
               <a:t>Second level</a:t>
             </a:r>
           </a:p>
           <a:p>
             <a:pPr lvl="2"/>
             <a:r>
-              <a:rPr lang="en-US" smtClean="0"/>
+              <a:rPr lang="en-US"/>
               <a:t>Third level</a:t>
             </a:r>
           </a:p>
           <a:p>
             <a:pPr lvl="3"/>
             <a:r>
-              <a:rPr lang="en-US" smtClean="0"/>
+              <a:rPr lang="en-US"/>
               <a:t>Fourth level</a:t>
             </a:r>
           </a:p>
           <a:p>
             <a:pPr lvl="4"/>
             <a:r>
-              <a:rPr lang="en-US" smtClean="0"/>
+              <a:rPr lang="en-US"/>
               <a:t>Fifth level</a:t>
             </a:r>
-            <a:endParaRPr lang="en-US"/>
           </a:p>
         </p:txBody>
       </p:sp>
@@ -1290,38 +1295,37 @@
           <a:p>
             <a:pPr lvl="0"/>
             <a:r>
-              <a:rPr lang="en-US" smtClean="0"/>
+              <a:rPr lang="en-US"/>
               <a:t>Click to edit Master text styles</a:t>
             </a:r>
           </a:p>
           <a:p>
             <a:pPr lvl="1"/>
             <a:r>
-              <a:rPr lang="en-US" smtClean="0"/>
+              <a:rPr lang="en-US"/>
               <a:t>Second level</a:t>
             </a:r>
           </a:p>
           <a:p>
             <a:pPr lvl="2"/>
             <a:r>
-              <a:rPr lang="en-US" smtClean="0"/>
+              <a:rPr lang="en-US"/>
               <a:t>Third level</a:t>
             </a:r>
           </a:p>
           <a:p>
             <a:pPr lvl="3"/>
             <a:r>
-              <a:rPr lang="en-US" smtClean="0"/>
+              <a:rPr lang="en-US"/>
               <a:t>Fourth level</a:t>
             </a:r>
           </a:p>
           <a:p>
             <a:pPr lvl="4"/>
             <a:r>
-              <a:rPr lang="en-US" smtClean="0"/>
+              <a:rPr lang="en-US"/>
               <a:t>Fifth level</a:t>
             </a:r>
-            <a:endParaRPr lang="en-US"/>
           </a:p>
         </p:txBody>
       </p:sp>
@@ -1342,7 +1346,7 @@
           <a:p>
             <a:fld id="{5BCAD085-E8A6-8845-BD4E-CB4CCA059FC4}" type="datetimeFigureOut">
               <a:rPr lang="en-US" smtClean="0"/>
-              <a:t>1/27/13</a:t>
+              <a:t>2026-08-06</a:t>
             </a:fld>
             <a:endParaRPr lang="en-US"/>
           </a:p>
@@ -1440,10 +1444,9 @@
           </a:lstStyle>
           <a:p>
             <a:r>
-              <a:rPr lang="en-US" smtClean="0"/>
+              <a:rPr lang="en-US"/>
               <a:t>Click to edit Master title style</a:t>
             </a:r>
-            <a:endParaRPr lang="en-US"/>
           </a:p>
         </p:txBody>
       </p:sp>
@@ -1506,7 +1509,7 @@
           <a:p>
             <a:pPr lvl="0"/>
             <a:r>
-              <a:rPr lang="en-US" smtClean="0"/>
+              <a:rPr lang="en-US"/>
               <a:t>Click to edit Master text styles</a:t>
             </a:r>
           </a:p>
@@ -1562,38 +1565,37 @@
           <a:p>
             <a:pPr lvl="0"/>
             <a:r>
-              <a:rPr lang="en-US" smtClean="0"/>
+              <a:rPr lang="en-US"/>
               <a:t>Click to edit Master text styles</a:t>
             </a:r>
           </a:p>
           <a:p>
             <a:pPr lvl="1"/>
             <a:r>
-              <a:rPr lang="en-US" smtClean="0"/>
+              <a:rPr lang="en-US"/>
               <a:t>Second level</a:t>
             </a:r>
           </a:p>
           <a:p>
             <a:pPr lvl="2"/>
             <a:r>
-              <a:rPr lang="en-US" smtClean="0"/>
+              <a:rPr lang="en-US"/>
               <a:t>Third level</a:t>
             </a:r>
           </a:p>
           <a:p>
             <a:pPr lvl="3"/>
             <a:r>
-              <a:rPr lang="en-US" smtClean="0"/>
+              <a:rPr lang="en-US"/>
               <a:t>Fourth level</a:t>
             </a:r>
           </a:p>
           <a:p>
             <a:pPr lvl="4"/>
             <a:r>
-              <a:rPr lang="en-US" smtClean="0"/>
+              <a:rPr lang="en-US"/>
               <a:t>Fifth level</a:t>
             </a:r>
-            <a:endParaRPr lang="en-US"/>
           </a:p>
         </p:txBody>
       </p:sp>
@@ -1656,7 +1658,7 @@
           <a:p>
             <a:pPr lvl="0"/>
             <a:r>
-              <a:rPr lang="en-US" smtClean="0"/>
+              <a:rPr lang="en-US"/>
               <a:t>Click to edit Master text styles</a:t>
             </a:r>
           </a:p>
@@ -1712,38 +1714,37 @@
           <a:p>
             <a:pPr lvl="0"/>
             <a:r>
-              <a:rPr lang="en-US" smtClean="0"/>
+              <a:rPr lang="en-US"/>
               <a:t>Click to edit Master text styles</a:t>
             </a:r>
           </a:p>
           <a:p>
             <a:pPr lvl="1"/>
             <a:r>
-              <a:rPr lang="en-US" smtClean="0"/>
+              <a:rPr lang="en-US"/>
               <a:t>Second level</a:t>
             </a:r>
           </a:p>
           <a:p>
             <a:pPr lvl="2"/>
             <a:r>
-              <a:rPr lang="en-US" smtClean="0"/>
+              <a:rPr lang="en-US"/>
               <a:t>Third level</a:t>
             </a:r>
           </a:p>
           <a:p>
             <a:pPr lvl="3"/>
             <a:r>
-              <a:rPr lang="en-US" smtClean="0"/>
+              <a:rPr lang="en-US"/>
               <a:t>Fourth level</a:t>
             </a:r>
           </a:p>
           <a:p>
             <a:pPr lvl="4"/>
             <a:r>
-              <a:rPr lang="en-US" smtClean="0"/>
+              <a:rPr lang="en-US"/>
               <a:t>Fifth level</a:t>
             </a:r>
-            <a:endParaRPr lang="en-US"/>
           </a:p>
         </p:txBody>
       </p:sp>
@@ -1764,7 +1765,7 @@
           <a:p>
             <a:fld id="{5BCAD085-E8A6-8845-BD4E-CB4CCA059FC4}" type="datetimeFigureOut">
               <a:rPr lang="en-US" smtClean="0"/>
-              <a:t>1/27/13</a:t>
+              <a:t>2026-08-06</a:t>
             </a:fld>
             <a:endParaRPr lang="en-US"/>
           </a:p>
@@ -1858,10 +1859,9 @@
           <a:lstStyle/>
           <a:p>
             <a:r>
-              <a:rPr lang="en-US" smtClean="0"/>
+              <a:rPr lang="en-US"/>
               <a:t>Click to edit Master title style</a:t>
             </a:r>
-            <a:endParaRPr lang="en-US"/>
           </a:p>
         </p:txBody>
       </p:sp>
@@ -1882,7 +1882,7 @@
           <a:p>
             <a:fld id="{5BCAD085-E8A6-8845-BD4E-CB4CCA059FC4}" type="datetimeFigureOut">
               <a:rPr lang="en-US" smtClean="0"/>
-              <a:t>1/27/13</a:t>
+              <a:t>2026-08-06</a:t>
             </a:fld>
             <a:endParaRPr lang="en-US"/>
           </a:p>
@@ -1977,7 +1977,7 @@
           <a:p>
             <a:fld id="{5BCAD085-E8A6-8845-BD4E-CB4CCA059FC4}" type="datetimeFigureOut">
               <a:rPr lang="en-US" smtClean="0"/>
-              <a:t>1/27/13</a:t>
+              <a:t>2026-08-06</a:t>
             </a:fld>
             <a:endParaRPr lang="en-US"/>
           </a:p>
@@ -2080,10 +2080,9 @@
           </a:lstStyle>
           <a:p>
             <a:r>
-              <a:rPr lang="en-US" smtClean="0"/>
+              <a:rPr lang="en-US"/>
               <a:t>Click to edit Master title style</a:t>
             </a:r>
-            <a:endParaRPr lang="en-US"/>
           </a:p>
         </p:txBody>
       </p:sp>
@@ -2137,38 +2136,37 @@
           <a:p>
             <a:pPr lvl="0"/>
             <a:r>
-              <a:rPr lang="en-US" smtClean="0"/>
+              <a:rPr lang="en-US"/>
               <a:t>Click to edit Master text styles</a:t>
             </a:r>
           </a:p>
           <a:p>
             <a:pPr lvl="1"/>
             <a:r>
-              <a:rPr lang="en-US" smtClean="0"/>
+              <a:rPr lang="en-US"/>
               <a:t>Second level</a:t>
             </a:r>
           </a:p>
           <a:p>
             <a:pPr lvl="2"/>
             <a:r>
-              <a:rPr lang="en-US" smtClean="0"/>
+              <a:rPr lang="en-US"/>
               <a:t>Third level</a:t>
             </a:r>
           </a:p>
           <a:p>
             <a:pPr lvl="3"/>
             <a:r>
-              <a:rPr lang="en-US" smtClean="0"/>
+              <a:rPr lang="en-US"/>
               <a:t>Fourth level</a:t>
             </a:r>
           </a:p>
           <a:p>
             <a:pPr lvl="4"/>
             <a:r>
-              <a:rPr lang="en-US" smtClean="0"/>
+              <a:rPr lang="en-US"/>
               <a:t>Fifth level</a:t>
             </a:r>
-            <a:endParaRPr lang="en-US"/>
           </a:p>
         </p:txBody>
       </p:sp>
@@ -2231,7 +2229,7 @@
           <a:p>
             <a:pPr lvl="0"/>
             <a:r>
-              <a:rPr lang="en-US" smtClean="0"/>
+              <a:rPr lang="en-US"/>
               <a:t>Click to edit Master text styles</a:t>
             </a:r>
           </a:p>
@@ -2254,7 +2252,7 @@
           <a:p>
             <a:fld id="{5BCAD085-E8A6-8845-BD4E-CB4CCA059FC4}" type="datetimeFigureOut">
               <a:rPr lang="en-US" smtClean="0"/>
-              <a:t>1/27/13</a:t>
+              <a:t>2026-08-06</a:t>
             </a:fld>
             <a:endParaRPr lang="en-US"/>
           </a:p>
@@ -2357,10 +2355,9 @@
           </a:lstStyle>
           <a:p>
             <a:r>
-              <a:rPr lang="en-US" smtClean="0"/>
+              <a:rPr lang="en-US"/>
               <a:t>Click to edit Master title style</a:t>
             </a:r>
-            <a:endParaRPr lang="en-US"/>
           </a:p>
         </p:txBody>
       </p:sp>
@@ -2484,7 +2481,7 @@
           <a:p>
             <a:pPr lvl="0"/>
             <a:r>
-              <a:rPr lang="en-US" smtClean="0"/>
+              <a:rPr lang="en-US"/>
               <a:t>Click to edit Master text styles</a:t>
             </a:r>
           </a:p>
@@ -2507,7 +2504,7 @@
           <a:p>
             <a:fld id="{5BCAD085-E8A6-8845-BD4E-CB4CCA059FC4}" type="datetimeFigureOut">
               <a:rPr lang="en-US" smtClean="0"/>
-              <a:t>1/27/13</a:t>
+              <a:t>2026-08-06</a:t>
             </a:fld>
             <a:endParaRPr lang="en-US"/>
           </a:p>
@@ -2616,10 +2613,9 @@
           <a:lstStyle/>
           <a:p>
             <a:r>
-              <a:rPr lang="en-US" smtClean="0"/>
+              <a:rPr lang="en-US"/>
               <a:t>Click to edit Master title style</a:t>
             </a:r>
-            <a:endParaRPr lang="en-US"/>
           </a:p>
         </p:txBody>
       </p:sp>
@@ -2650,38 +2646,37 @@
           <a:p>
             <a:pPr lvl="0"/>
             <a:r>
-              <a:rPr lang="en-US" smtClean="0"/>
+              <a:rPr lang="en-US"/>
               <a:t>Click to edit Master text styles</a:t>
             </a:r>
           </a:p>
           <a:p>
             <a:pPr lvl="1"/>
             <a:r>
-              <a:rPr lang="en-US" smtClean="0"/>
+              <a:rPr lang="en-US"/>
               <a:t>Second level</a:t>
             </a:r>
           </a:p>
           <a:p>
             <a:pPr lvl="2"/>
             <a:r>
-              <a:rPr lang="en-US" smtClean="0"/>
+              <a:rPr lang="en-US"/>
               <a:t>Third level</a:t>
             </a:r>
           </a:p>
           <a:p>
             <a:pPr lvl="3"/>
             <a:r>
-              <a:rPr lang="en-US" smtClean="0"/>
+              <a:rPr lang="en-US"/>
               <a:t>Fourth level</a:t>
             </a:r>
           </a:p>
           <a:p>
             <a:pPr lvl="4"/>
             <a:r>
-              <a:rPr lang="en-US" smtClean="0"/>
+              <a:rPr lang="en-US"/>
               <a:t>Fifth level</a:t>
             </a:r>
-            <a:endParaRPr lang="en-US"/>
           </a:p>
         </p:txBody>
       </p:sp>
@@ -2720,7 +2715,7 @@
           <a:p>
             <a:fld id="{5BCAD085-E8A6-8845-BD4E-CB4CCA059FC4}" type="datetimeFigureOut">
               <a:rPr lang="en-US" smtClean="0"/>
-              <a:t>1/27/13</a:t>
+              <a:t>2026-08-06</a:t>
             </a:fld>
             <a:endParaRPr lang="en-US"/>
           </a:p>
@@ -3079,7 +3074,7 @@
 </file>
 
 <file path=ppt/slides/slide1.xml><?xml version="1.0" encoding="utf-8"?>
-<p:sld xmlns:a="http://schemas.openxmlformats.org/drawingml/2006/main" xmlns:p="http://schemas.openxmlformats.org/presentationml/2006/main" xmlns:r="http://schemas.openxmlformats.org/officeDocument/2006/relationships">
+<p:sld xmlns:a="http://schemas.openxmlformats.org/drawingml/2006/main" xmlns:r="http://schemas.openxmlformats.org/officeDocument/2006/relationships" xmlns:p="http://schemas.openxmlformats.org/presentationml/2006/main">
   <p:cSld>
     <p:spTree>
       <p:nvGrpSpPr>
@@ -3087,7 +3082,14 @@
         <p:cNvGrpSpPr/>
         <p:nvPr/>
       </p:nvGrpSpPr>
-      <p:grpSpPr/>
+      <p:grpSpPr>
+        <a:xfrm>
+          <a:off x="0" y="0"/>
+          <a:ext cx="0" cy="0"/>
+          <a:chOff x="0" y="0"/>
+          <a:chExt cx="0" cy="0"/>
+        </a:xfrm>
+      </p:grpSpPr>
       <p:sp>
         <p:nvSpPr>
           <p:cNvPr id="2" name="Rectangle 1"/>
@@ -3129,6 +3131,7 @@
           <a:lstStyle/>
           <a:p>
             <a:pPr algn="ctr"/>
+            <a:endParaRPr/>
           </a:p>
         </p:txBody>
       </p:sp>
@@ -3141,7 +3144,7 @@
         <p:spPr>
           <a:xfrm>
             <a:off x="731520" y="320040"/>
-            <a:ext cx="42428160" cy="3474720"/>
+            <a:ext cx="42428160" cy="3554819"/>
           </a:xfrm>
           <a:prstGeom prst="rect">
             <a:avLst/>
@@ -3160,13 +3163,26 @@
               </a:spcAft>
             </a:pPr>
             <a:r>
-              <a:rPr sz="5800" b="1">
+              <a:rPr sz="7000" b="1" dirty="0">
                 <a:solidFill>
                   <a:srgbClr val="FFFFFF"/>
                 </a:solidFill>
               </a:rPr>
               <a:t>A System of Multiple AI Agents for Automating Tokamak-Plasma Simulation for Nuclear Fusion Energy</a:t>
             </a:r>
+            <a:r>
+              <a:rPr lang="en-US" sz="7000" b="1" dirty="0">
+                <a:solidFill>
+                  <a:srgbClr val="FFFFFF"/>
+                </a:solidFill>
+              </a:rPr>
+              <a:t>.</a:t>
+            </a:r>
+            <a:endParaRPr sz="7000" b="1" dirty="0">
+              <a:solidFill>
+                <a:srgbClr val="FFFFFF"/>
+              </a:solidFill>
+            </a:endParaRPr>
           </a:p>
           <a:p>
             <a:pPr algn="l">
@@ -3175,12 +3191,200 @@
               </a:spcAft>
             </a:pPr>
             <a:r>
-              <a:rPr sz="3400" b="0">
+              <a:rPr sz="6000" b="0" dirty="0">
                 <a:solidFill>
                   <a:srgbClr val="CFE6EA"/>
                 </a:solidFill>
               </a:rPr>
-              <a:t>A hierarchical multi-agent PETSc system: from a plain-language prompt to verified, real-machine Grad-Shafranov equilibria</a:t>
+              <a:t>A hierarchical multi-agent </a:t>
+            </a:r>
+            <a:r>
+              <a:rPr sz="6000" b="0" dirty="0" err="1">
+                <a:solidFill>
+                  <a:srgbClr val="CFE6EA"/>
+                </a:solidFill>
+              </a:rPr>
+              <a:t>PETSc</a:t>
+            </a:r>
+            <a:r>
+              <a:rPr sz="6000" b="0" dirty="0">
+                <a:solidFill>
+                  <a:srgbClr val="CFE6EA"/>
+                </a:solidFill>
+              </a:rPr>
+              <a:t> system: from a plain-language prompt to verified, real-machine Grad-</a:t>
+            </a:r>
+            <a:r>
+              <a:rPr sz="6000" b="0" dirty="0" err="1">
+                <a:solidFill>
+                  <a:srgbClr val="CFE6EA"/>
+                </a:solidFill>
+              </a:rPr>
+              <a:t>Shafranov</a:t>
+            </a:r>
+            <a:r>
+              <a:rPr sz="6000" b="0" dirty="0">
+                <a:solidFill>
+                  <a:srgbClr val="CFE6EA"/>
+                </a:solidFill>
+              </a:rPr>
+              <a:t> equilibria</a:t>
+            </a:r>
+            <a:r>
+              <a:rPr lang="en-US" sz="6000" b="0" dirty="0">
+                <a:solidFill>
+                  <a:srgbClr val="CFE6EA"/>
+                </a:solidFill>
+              </a:rPr>
+              <a:t>.</a:t>
+            </a:r>
+            <a:endParaRPr sz="6000" b="0" dirty="0">
+              <a:solidFill>
+                <a:srgbClr val="CFE6EA"/>
+              </a:solidFill>
+            </a:endParaRPr>
+          </a:p>
+          <a:p>
+            <a:pPr>
+              <a:spcAft>
+                <a:spcPts val="600"/>
+              </a:spcAft>
+            </a:pPr>
+            <a:r>
+              <a:rPr sz="4000" b="0" dirty="0">
+                <a:solidFill>
+                  <a:srgbClr val="FFFFFF"/>
+                </a:solidFill>
+              </a:rPr>
+              <a:t>Sarthak Sharma¹  ·  Dr </a:t>
+            </a:r>
+            <a:r>
+              <a:rPr sz="4000" b="0" dirty="0" err="1">
+                <a:solidFill>
+                  <a:srgbClr val="FFFFFF"/>
+                </a:solidFill>
+              </a:rPr>
+              <a:t>Junchao</a:t>
+            </a:r>
+            <a:r>
+              <a:rPr sz="4000" b="0" dirty="0">
+                <a:solidFill>
+                  <a:srgbClr val="FFFFFF"/>
+                </a:solidFill>
+              </a:rPr>
+              <a:t> Zhang²  </a:t>
+            </a:r>
+            <a:r>
+              <a:rPr lang="en-US" sz="4000" dirty="0">
+                <a:solidFill>
+                  <a:srgbClr val="FFFFFF"/>
+                </a:solidFill>
+              </a:rPr>
+              <a:t>·  Dr Lois Curfman McInnes²  </a:t>
+            </a:r>
+            <a:r>
+              <a:rPr sz="4000" b="0" dirty="0">
+                <a:solidFill>
+                  <a:srgbClr val="FFFFFF"/>
+                </a:solidFill>
+              </a:rPr>
+              <a:t>·  </a:t>
+            </a:r>
+            <a:r>
+              <a:rPr lang="en-US" sz="4000" dirty="0">
+                <a:solidFill>
+                  <a:srgbClr val="FFFFFF"/>
+                </a:solidFill>
+              </a:rPr>
+              <a:t>Prof Matthew Knepley¹</a:t>
+            </a:r>
+            <a:r>
+              <a:rPr sz="4000" b="0" dirty="0">
+                <a:solidFill>
+                  <a:srgbClr val="FFFFFF"/>
+                </a:solidFill>
+              </a:rPr>
+              <a:t>  </a:t>
+            </a:r>
+            <a:r>
+              <a:rPr lang="en-US" sz="4000" dirty="0">
+                <a:solidFill>
+                  <a:srgbClr val="FFFFFF"/>
+                </a:solidFill>
+              </a:rPr>
+              <a:t>																											</a:t>
+            </a:r>
+            <a:r>
+              <a:rPr sz="4000" b="0" dirty="0">
+                <a:solidFill>
+                  <a:srgbClr val="FFFFFF"/>
+                </a:solidFill>
+              </a:rPr>
+              <a:t>US</a:t>
+            </a:r>
+            <a:r>
+              <a:rPr lang="en-US" sz="4000" b="0" dirty="0">
+                <a:solidFill>
+                  <a:srgbClr val="FFFFFF"/>
+                </a:solidFill>
+              </a:rPr>
+              <a:t> </a:t>
+            </a:r>
+            <a:r>
+              <a:rPr sz="4000" b="0" dirty="0">
+                <a:solidFill>
+                  <a:srgbClr val="FFFFFF"/>
+                </a:solidFill>
+              </a:rPr>
+              <a:t>R</a:t>
+            </a:r>
+            <a:r>
+              <a:rPr lang="en-US" sz="4000" b="0" dirty="0">
+                <a:solidFill>
+                  <a:srgbClr val="FFFFFF"/>
+                </a:solidFill>
+              </a:rPr>
+              <a:t>esearch </a:t>
+            </a:r>
+            <a:r>
+              <a:rPr sz="4000" b="0" dirty="0">
+                <a:solidFill>
+                  <a:srgbClr val="FFFFFF"/>
+                </a:solidFill>
+              </a:rPr>
+              <a:t>S</a:t>
+            </a:r>
+            <a:r>
+              <a:rPr lang="en-US" sz="4000" b="0" dirty="0">
+                <a:solidFill>
+                  <a:srgbClr val="FFFFFF"/>
+                </a:solidFill>
+              </a:rPr>
+              <a:t>oftware </a:t>
+            </a:r>
+            <a:r>
+              <a:rPr sz="4000" b="0" dirty="0">
+                <a:solidFill>
+                  <a:srgbClr val="FFFFFF"/>
+                </a:solidFill>
+              </a:rPr>
+              <a:t>E</a:t>
+            </a:r>
+            <a:r>
+              <a:rPr lang="en-US" sz="4000" b="0" dirty="0">
+                <a:solidFill>
+                  <a:srgbClr val="FFFFFF"/>
+                </a:solidFill>
+              </a:rPr>
+              <a:t>ngineering Conference</a:t>
+            </a:r>
+            <a:r>
+              <a:rPr sz="4000" b="0" dirty="0">
+                <a:solidFill>
+                  <a:srgbClr val="FFFFFF"/>
+                </a:solidFill>
+              </a:rPr>
+              <a:t> 2026</a:t>
             </a:r>
           </a:p>
           <a:p>
@@ -3190,27 +3394,28 @@
               </a:spcAft>
             </a:pPr>
             <a:r>
-              <a:rPr sz="2700" b="0">
-                <a:solidFill>
-                  <a:srgbClr val="FFFFFF"/>
-                </a:solidFill>
-              </a:rPr>
-              <a:t>Sarthak Sharma¹  ·  Dr Junchao Zhang²  ·  Prof Matthew Knepley¹  ·  Dr Lois Curfman McInnes²  ·  US-RSE 2026</a:t>
-            </a:r>
-          </a:p>
-          <a:p>
-            <a:pPr algn="l">
-              <a:spcAft>
-                <a:spcPts val="600"/>
-              </a:spcAft>
-            </a:pPr>
-            <a:r>
-              <a:rPr sz="2300" b="0">
+              <a:rPr sz="4000" b="0" dirty="0">
                 <a:solidFill>
                   <a:srgbClr val="CFE6EA"/>
                 </a:solidFill>
               </a:rPr>
-              <a:t>¹ Computational and Data Sciences, State University of New York at Buffalo        ² Division of Mathematics and Computer Science, Argonne National Laboratory</a:t>
+              <a:t>¹ Computational and Data Sciences, State University of New York at Buffalo </a:t>
+            </a:r>
+            <a:r>
+              <a:rPr lang="en-US" sz="4000" b="0" dirty="0">
+                <a:solidFill>
+                  <a:srgbClr val="CFE6EA"/>
+                </a:solidFill>
+              </a:rPr>
+              <a:t>			</a:t>
+            </a:r>
+            <a:r>
+              <a:rPr sz="4000" b="0" dirty="0">
+                <a:solidFill>
+                  <a:srgbClr val="CFE6EA"/>
+                </a:solidFill>
+              </a:rPr>
+              <a:t>² Division of Mathematics and Computer Science, Argonne National Laboratory</a:t>
             </a:r>
           </a:p>
         </p:txBody>
@@ -3224,9 +3429,9 @@
         <p:spPr>
           <a:xfrm>
             <a:off x="640080" y="4572000"/>
-            <a:ext cx="13624560" cy="5081578"/>
+            <a:ext cx="13624560" cy="5489030"/>
           </a:xfrm>
-          <a:prstGeom prst="roundRect">
+          <a:prstGeom prst="rect">
             <a:avLst/>
           </a:prstGeom>
           <a:solidFill>
@@ -3258,6 +3463,7 @@
           <a:lstStyle/>
           <a:p>
             <a:pPr algn="ctr"/>
+            <a:endParaRPr/>
           </a:p>
         </p:txBody>
       </p:sp>
@@ -3298,17 +3504,33 @@
           </a:fontRef>
         </p:style>
         <p:txBody>
-          <a:bodyPr rtlCol="0" anchor="ctr" lIns="274320"/>
+          <a:bodyPr lIns="274320" rtlCol="0" anchor="ctr"/>
           <a:lstStyle/>
           <a:p>
             <a:pPr algn="ctr"/>
             <a:r>
-              <a:rPr sz="4000" b="1">
+              <a:rPr sz="4000" b="1" dirty="0">
                 <a:solidFill>
                   <a:srgbClr val="FFFFFF"/>
                 </a:solidFill>
               </a:rPr>
-              <a:t>1  Motivation</a:t>
+              <a:t>1</a:t>
+            </a:r>
+            <a:r>
+              <a:rPr lang="en-US" sz="4000" b="1" dirty="0">
+                <a:solidFill>
+                  <a:srgbClr val="FFFFFF"/>
+                </a:solidFill>
+              </a:rPr>
+              <a:t>.</a:t>
+            </a:r>
+            <a:r>
+              <a:rPr sz="4000" b="1" dirty="0">
+                <a:solidFill>
+                  <a:srgbClr val="FFFFFF"/>
+                </a:solidFill>
+              </a:rPr>
+              <a:t>  Motivation</a:t>
             </a:r>
           </a:p>
         </p:txBody>
@@ -3322,7 +3544,7 @@
         <p:spPr>
           <a:xfrm>
             <a:off x="914400" y="5897880"/>
-            <a:ext cx="13075920" cy="3527098"/>
+            <a:ext cx="13075920" cy="4016484"/>
           </a:xfrm>
           <a:prstGeom prst="rect">
             <a:avLst/>
@@ -3341,12 +3563,28 @@
               </a:spcAft>
             </a:pPr>
             <a:r>
-              <a:rPr sz="3000" b="0">
+              <a:rPr sz="3500" b="0" dirty="0">
                 <a:solidFill>
                   <a:srgbClr val="1F1F1F"/>
                 </a:solidFill>
               </a:rPr>
-              <a:t>Building correct, fast HPC simulation code demands scarce, implicit expertise. Can a system of multiple AI agents automate the path from a plain-language idea to VERIFIED code for a real fusion problem?</a:t>
+              <a:t>Building correct, fast HPC simulation code demands scarce, implicit expertise. Can a system of multiple AI agents automate the path from a plain-language idea to </a:t>
+            </a:r>
+            <a:r>
+              <a:rPr lang="en-US" sz="3500" b="0" dirty="0">
+                <a:solidFill>
+                  <a:srgbClr val="1F1F1F"/>
+                </a:solidFill>
+              </a:rPr>
+              <a:t>verified</a:t>
+            </a:r>
+            <a:r>
+              <a:rPr sz="3500" b="0" dirty="0">
+                <a:solidFill>
+                  <a:srgbClr val="1F1F1F"/>
+                </a:solidFill>
+              </a:rPr>
+              <a:t> code for a real fusion problem?</a:t>
             </a:r>
           </a:p>
           <a:p>
@@ -3356,13 +3594,70 @@
               </a:spcAft>
             </a:pPr>
             <a:r>
-              <a:rPr sz="3000" b="1">
+              <a:rPr sz="3500" b="1" dirty="0">
                 <a:solidFill>
                   <a:srgbClr val="007D8A"/>
                 </a:solidFill>
               </a:rPr>
-              <a:t>We answer yes for the tokamak Grad-Shafranov equilibrium — with verification as a first-class deliverable.</a:t>
-            </a:r>
+              <a:t>We answer yes for the tokamak Grad-</a:t>
+            </a:r>
+            <a:r>
+              <a:rPr sz="3500" b="1" dirty="0" err="1">
+                <a:solidFill>
+                  <a:srgbClr val="007D8A"/>
+                </a:solidFill>
+              </a:rPr>
+              <a:t>Shafranov</a:t>
+            </a:r>
+            <a:r>
+              <a:rPr sz="3500" b="1" dirty="0">
+                <a:solidFill>
+                  <a:srgbClr val="007D8A"/>
+                </a:solidFill>
+              </a:rPr>
+              <a:t> equilibrium</a:t>
+            </a:r>
+            <a:r>
+              <a:rPr lang="en-US" sz="3500" b="1" dirty="0">
+                <a:solidFill>
+                  <a:srgbClr val="007D8A"/>
+                </a:solidFill>
+              </a:rPr>
+              <a:t>,</a:t>
+            </a:r>
+            <a:r>
+              <a:rPr sz="3500" b="1" dirty="0">
+                <a:solidFill>
+                  <a:srgbClr val="007D8A"/>
+                </a:solidFill>
+              </a:rPr>
+              <a:t> with verification as a first-class deliverable.</a:t>
+            </a:r>
+            <a:endParaRPr lang="en-US" sz="3500" b="1" dirty="0">
+              <a:solidFill>
+                <a:srgbClr val="007D8A"/>
+              </a:solidFill>
+            </a:endParaRPr>
+          </a:p>
+          <a:p>
+            <a:pPr algn="l">
+              <a:spcAft>
+                <a:spcPts val="600"/>
+              </a:spcAft>
+            </a:pPr>
+            <a:r>
+              <a:rPr lang="en-US" sz="3500" dirty="0"/>
+              <a:t>HPC library used is </a:t>
+            </a:r>
+            <a:r>
+              <a:rPr lang="en-US" sz="3500" dirty="0" err="1"/>
+              <a:t>PETSc</a:t>
+            </a:r>
+            <a:r>
+              <a:rPr lang="en-US" sz="3500" dirty="0"/>
+              <a:t> (Portable, Extensible Toolkit for Scientific Computation).</a:t>
+            </a:r>
+            <a:endParaRPr sz="3500" dirty="0"/>
           </a:p>
         </p:txBody>
       </p:sp>
@@ -3375,9 +3670,9 @@
         <p:spPr>
           <a:xfrm>
             <a:off x="640080" y="10659418"/>
-            <a:ext cx="13624560" cy="5971594"/>
+            <a:ext cx="13624560" cy="6593386"/>
           </a:xfrm>
-          <a:prstGeom prst="roundRect">
+          <a:prstGeom prst="rect">
             <a:avLst/>
           </a:prstGeom>
           <a:solidFill>
@@ -3409,6 +3704,7 @@
           <a:lstStyle/>
           <a:p>
             <a:pPr algn="ctr"/>
+            <a:endParaRPr/>
           </a:p>
         </p:txBody>
       </p:sp>
@@ -3449,104 +3745,869 @@
           </a:fontRef>
         </p:style>
         <p:txBody>
-          <a:bodyPr rtlCol="0" anchor="ctr" lIns="274320"/>
+          <a:bodyPr lIns="274320" rtlCol="0" anchor="ctr"/>
           <a:lstStyle/>
           <a:p>
             <a:pPr algn="ctr"/>
             <a:r>
-              <a:rPr sz="4000" b="1">
+              <a:rPr sz="4000" b="1" dirty="0">
                 <a:solidFill>
                   <a:srgbClr val="FFFFFF"/>
                 </a:solidFill>
               </a:rPr>
-              <a:t>2  The problem</a:t>
-            </a:r>
-          </a:p>
-        </p:txBody>
-      </p:sp>
-      <p:sp>
-        <p:nvSpPr>
-          <p:cNvPr id="9" name="TextBox 8"/>
-          <p:cNvSpPr txBox="1"/>
-          <p:nvPr/>
-        </p:nvSpPr>
-        <p:spPr>
-          <a:xfrm>
-            <a:off x="914400" y="11985298"/>
-            <a:ext cx="13075920" cy="4417114"/>
-          </a:xfrm>
-          <a:prstGeom prst="rect">
-            <a:avLst/>
-          </a:prstGeom>
-          <a:noFill/>
-        </p:spPr>
-        <p:txBody>
-          <a:bodyPr wrap="square" anchor="t">
-            <a:spAutoFit/>
-          </a:bodyPr>
-          <a:lstStyle/>
-          <a:p>
-            <a:pPr algn="l">
-              <a:spcAft>
-                <a:spcPts val="600"/>
-              </a:spcAft>
-            </a:pPr>
-            <a:r>
-              <a:rPr sz="3000" b="0">
-                <a:solidFill>
-                  <a:srgbClr val="1F1F1F"/>
-                </a:solidFill>
-              </a:rPr>
-              <a:t>Axisymmetric ideal-MHD force balance for the poloidal flux psi(R,Z):</a:t>
-            </a:r>
-          </a:p>
-          <a:p>
-            <a:pPr algn="ctr">
-              <a:spcAft>
-                <a:spcPts val="600"/>
-              </a:spcAft>
-            </a:pPr>
-            <a:r>
-              <a:rPr sz="4000" b="1">
-                <a:solidFill>
-                  <a:srgbClr val="007D8A"/>
-                </a:solidFill>
-              </a:rPr>
-              <a:t>Δ*psi = -μ₀R² p'(psi) - F F'(psi)</a:t>
-            </a:r>
-          </a:p>
-          <a:p>
-            <a:pPr algn="l">
-              <a:spcAft>
-                <a:spcPts val="600"/>
-              </a:spcAft>
-            </a:pPr>
-            <a:r>
-              <a:rPr sz="3000" b="0">
-                <a:solidFill>
-                  <a:srgbClr val="1F1F1F"/>
-                </a:solidFill>
-              </a:rPr>
-              <a:t>Sets the flux surfaces, magnetic axis, plasma shape, and safety factor q.</a:t>
-            </a:r>
-          </a:p>
-          <a:p>
-            <a:pPr algn="l">
-              <a:spcAft>
-                <a:spcPts val="600"/>
-              </a:spcAft>
-            </a:pPr>
-            <a:r>
-              <a:rPr sz="3000" b="0">
-                <a:solidFill>
-                  <a:srgbClr val="1F1F1F"/>
-                </a:solidFill>
-              </a:rPr>
-              <a:t>Solov'ev profiles admit an EXACT solution → a rigorous verification anchor.</a:t>
-            </a:r>
-          </a:p>
-        </p:txBody>
-      </p:sp>
+              <a:t>2</a:t>
+            </a:r>
+            <a:r>
+              <a:rPr lang="en-US" sz="4000" b="1" dirty="0">
+                <a:solidFill>
+                  <a:srgbClr val="FFFFFF"/>
+                </a:solidFill>
+              </a:rPr>
+              <a:t>.</a:t>
+            </a:r>
+            <a:r>
+              <a:rPr sz="4000" b="1" dirty="0">
+                <a:solidFill>
+                  <a:srgbClr val="FFFFFF"/>
+                </a:solidFill>
+              </a:rPr>
+              <a:t>  The problem</a:t>
+            </a:r>
+            <a:r>
+              <a:rPr lang="en-US" sz="4000" b="1" dirty="0">
+                <a:solidFill>
+                  <a:srgbClr val="FFFFFF"/>
+                </a:solidFill>
+              </a:rPr>
+              <a:t> being solved</a:t>
+            </a:r>
+            <a:endParaRPr sz="4000" b="1" dirty="0">
+              <a:solidFill>
+                <a:srgbClr val="FFFFFF"/>
+              </a:solidFill>
+            </a:endParaRPr>
+          </a:p>
+        </p:txBody>
+      </p:sp>
+      <mc:AlternateContent xmlns:mc="http://schemas.openxmlformats.org/markup-compatibility/2006">
+        <mc:Choice xmlns:a14="http://schemas.microsoft.com/office/drawing/2010/main" Requires="a14">
+          <p:sp>
+            <p:nvSpPr>
+              <p:cNvPr id="9" name="TextBox 8"/>
+              <p:cNvSpPr txBox="1"/>
+              <p:nvPr/>
+            </p:nvSpPr>
+            <p:spPr>
+              <a:xfrm>
+                <a:off x="914400" y="11985298"/>
+                <a:ext cx="13075920" cy="5341847"/>
+              </a:xfrm>
+              <a:prstGeom prst="rect">
+                <a:avLst/>
+              </a:prstGeom>
+              <a:noFill/>
+            </p:spPr>
+            <p:txBody>
+              <a:bodyPr wrap="square" anchor="t">
+                <a:spAutoFit/>
+              </a:bodyPr>
+              <a:lstStyle/>
+              <a:p>
+                <a:pPr algn="l">
+                  <a:spcAft>
+                    <a:spcPts val="600"/>
+                  </a:spcAft>
+                </a:pPr>
+                <a:r>
+                  <a:rPr lang="en-US" sz="3500" b="0" dirty="0">
+                    <a:solidFill>
+                      <a:srgbClr val="1F1F1F"/>
+                    </a:solidFill>
+                  </a:rPr>
+                  <a:t>Axisymmetric ideal-magnetohydrodynamics force balance for the poloidal magnetic flux </a:t>
+                </a:r>
+                <a14:m>
+                  <m:oMath xmlns:m="http://schemas.openxmlformats.org/officeDocument/2006/math">
+                    <m:r>
+                      <a:rPr lang="en-US" sz="3500" b="0" i="1" dirty="0" smtClean="0">
+                        <a:solidFill>
+                          <a:srgbClr val="1F1F1F"/>
+                        </a:solidFill>
+                        <a:latin typeface="Cambria Math" panose="02040503050406030204" pitchFamily="18" charset="0"/>
+                      </a:rPr>
+                      <m:t>𝜓</m:t>
+                    </m:r>
+                    <m:r>
+                      <a:rPr lang="en-US" sz="3500" b="0" i="1" dirty="0" smtClean="0">
+                        <a:solidFill>
+                          <a:srgbClr val="1F1F1F"/>
+                        </a:solidFill>
+                        <a:latin typeface="Cambria Math" panose="02040503050406030204" pitchFamily="18" charset="0"/>
+                      </a:rPr>
+                      <m:t>(</m:t>
+                    </m:r>
+                    <m:r>
+                      <a:rPr lang="en-US" sz="3500" b="0" i="1" dirty="0" smtClean="0">
+                        <a:solidFill>
+                          <a:srgbClr val="1F1F1F"/>
+                        </a:solidFill>
+                        <a:latin typeface="Cambria Math" panose="02040503050406030204" pitchFamily="18" charset="0"/>
+                      </a:rPr>
+                      <m:t>𝑟</m:t>
+                    </m:r>
+                    <m:r>
+                      <a:rPr lang="en-US" sz="3500" b="0" i="1" dirty="0" smtClean="0">
+                        <a:solidFill>
+                          <a:srgbClr val="1F1F1F"/>
+                        </a:solidFill>
+                        <a:latin typeface="Cambria Math" panose="02040503050406030204" pitchFamily="18" charset="0"/>
+                      </a:rPr>
+                      <m:t>,</m:t>
+                    </m:r>
+                    <m:r>
+                      <a:rPr lang="en-US" sz="3500" b="0" i="1" dirty="0" smtClean="0">
+                        <a:solidFill>
+                          <a:srgbClr val="1F1F1F"/>
+                        </a:solidFill>
+                        <a:latin typeface="Cambria Math" panose="02040503050406030204" pitchFamily="18" charset="0"/>
+                      </a:rPr>
+                      <m:t>𝑧</m:t>
+                    </m:r>
+                    <m:r>
+                      <a:rPr lang="en-US" sz="3500" b="0" i="1" dirty="0" smtClean="0">
+                        <a:solidFill>
+                          <a:srgbClr val="1F1F1F"/>
+                        </a:solidFill>
+                        <a:latin typeface="Cambria Math" panose="02040503050406030204" pitchFamily="18" charset="0"/>
+                      </a:rPr>
+                      <m:t>)</m:t>
+                    </m:r>
+                  </m:oMath>
+                </a14:m>
+                <a:r>
+                  <a:rPr lang="en-US" sz="3500" b="0" dirty="0">
+                    <a:solidFill>
+                      <a:srgbClr val="1F1F1F"/>
+                    </a:solidFill>
+                  </a:rPr>
+                  <a:t>:</a:t>
+                </a:r>
+              </a:p>
+              <a:p>
+                <a:pPr algn="ctr">
+                  <a:spcAft>
+                    <a:spcPts val="600"/>
+                  </a:spcAft>
+                </a:pPr>
+                <a14:m>
+                  <m:oMathPara xmlns:m="http://schemas.openxmlformats.org/officeDocument/2006/math">
+                    <m:oMath>
+                      <m:f>
+                        <m:fPr>
+                          <m:ctrlPr>
+                            <a:rPr lang="ar-AE" sz="3500" i="1">
+                              <a:latin typeface="Cambria Math" panose="02040503050406030204" pitchFamily="18" charset="0"/>
+                            </a:rPr>
+                          </m:ctrlPr>
+                        </m:fPr>
+                        <m:num>
+                          <m:sSup>
+                            <m:sSupPr>
+                              <m:ctrlPr>
+                                <a:rPr lang="ar-AE" sz="3500" i="1">
+                                  <a:latin typeface="Cambria Math" panose="02040503050406030204" pitchFamily="18" charset="0"/>
+                                </a:rPr>
+                              </m:ctrlPr>
+                            </m:sSupPr>
+                            <m:e>
+                              <m:r>
+                                <a:rPr lang="ar-AE" sz="3500" i="1">
+                                  <a:latin typeface="Cambria Math" panose="02040503050406030204" pitchFamily="18" charset="0"/>
+                                </a:rPr>
+                                <m:t>𝜕</m:t>
+                              </m:r>
+                            </m:e>
+                            <m:sup>
+                              <m:r>
+                                <a:rPr lang="ar-AE" sz="3500" i="1">
+                                  <a:latin typeface="Cambria Math" panose="02040503050406030204" pitchFamily="18" charset="0"/>
+                                </a:rPr>
+                                <m:t>2</m:t>
+                              </m:r>
+                            </m:sup>
+                          </m:sSup>
+                          <m:r>
+                            <a:rPr lang="ar-AE" sz="3500" i="1">
+                              <a:latin typeface="Cambria Math" panose="02040503050406030204" pitchFamily="18" charset="0"/>
+                            </a:rPr>
+                            <m:t>𝜓</m:t>
+                          </m:r>
+                        </m:num>
+                        <m:den>
+                          <m:r>
+                            <a:rPr lang="ar-AE" sz="3500" i="1">
+                              <a:latin typeface="Cambria Math" panose="02040503050406030204" pitchFamily="18" charset="0"/>
+                            </a:rPr>
+                            <m:t>𝜕</m:t>
+                          </m:r>
+                          <m:sSup>
+                            <m:sSupPr>
+                              <m:ctrlPr>
+                                <a:rPr lang="ar-AE" sz="3500" i="1">
+                                  <a:latin typeface="Cambria Math" panose="02040503050406030204" pitchFamily="18" charset="0"/>
+                                </a:rPr>
+                              </m:ctrlPr>
+                            </m:sSupPr>
+                            <m:e>
+                              <m:r>
+                                <a:rPr lang="ar-AE" sz="3500" i="1">
+                                  <a:latin typeface="Cambria Math" panose="02040503050406030204" pitchFamily="18" charset="0"/>
+                                </a:rPr>
+                                <m:t>𝑟</m:t>
+                              </m:r>
+                            </m:e>
+                            <m:sup>
+                              <m:r>
+                                <a:rPr lang="ar-AE" sz="3500" i="1">
+                                  <a:latin typeface="Cambria Math" panose="02040503050406030204" pitchFamily="18" charset="0"/>
+                                </a:rPr>
+                                <m:t>2</m:t>
+                              </m:r>
+                            </m:sup>
+                          </m:sSup>
+                        </m:den>
+                      </m:f>
+                      <m:r>
+                        <a:rPr lang="ar-AE" sz="3500" i="1">
+                          <a:latin typeface="Cambria Math" panose="02040503050406030204" pitchFamily="18" charset="0"/>
+                        </a:rPr>
+                        <m:t>  −  </m:t>
+                      </m:r>
+                      <m:f>
+                        <m:fPr>
+                          <m:ctrlPr>
+                            <a:rPr lang="ar-AE" sz="3500" i="1">
+                              <a:latin typeface="Cambria Math" panose="02040503050406030204" pitchFamily="18" charset="0"/>
+                            </a:rPr>
+                          </m:ctrlPr>
+                        </m:fPr>
+                        <m:num>
+                          <m:r>
+                            <a:rPr lang="ar-AE" sz="3500" i="1">
+                              <a:latin typeface="Cambria Math" panose="02040503050406030204" pitchFamily="18" charset="0"/>
+                            </a:rPr>
+                            <m:t>1</m:t>
+                          </m:r>
+                        </m:num>
+                        <m:den>
+                          <m:r>
+                            <a:rPr lang="ar-AE" sz="3500" i="1">
+                              <a:latin typeface="Cambria Math" panose="02040503050406030204" pitchFamily="18" charset="0"/>
+                            </a:rPr>
+                            <m:t>𝑟</m:t>
+                          </m:r>
+                        </m:den>
+                      </m:f>
+                      <m:r>
+                        <a:rPr lang="ar-AE" sz="3500" i="1">
+                          <a:latin typeface="Cambria Math" panose="02040503050406030204" pitchFamily="18" charset="0"/>
+                        </a:rPr>
+                        <m:t> </m:t>
+                      </m:r>
+                      <m:f>
+                        <m:fPr>
+                          <m:ctrlPr>
+                            <a:rPr lang="ar-AE" sz="3500" i="1">
+                              <a:latin typeface="Cambria Math" panose="02040503050406030204" pitchFamily="18" charset="0"/>
+                            </a:rPr>
+                          </m:ctrlPr>
+                        </m:fPr>
+                        <m:num>
+                          <m:r>
+                            <a:rPr lang="ar-AE" sz="3500" i="1">
+                              <a:latin typeface="Cambria Math" panose="02040503050406030204" pitchFamily="18" charset="0"/>
+                            </a:rPr>
+                            <m:t>𝜕𝜓</m:t>
+                          </m:r>
+                        </m:num>
+                        <m:den>
+                          <m:r>
+                            <a:rPr lang="ar-AE" sz="3500" i="1">
+                              <a:latin typeface="Cambria Math" panose="02040503050406030204" pitchFamily="18" charset="0"/>
+                            </a:rPr>
+                            <m:t>𝜕</m:t>
+                          </m:r>
+                          <m:r>
+                            <a:rPr lang="ar-AE" sz="3500" i="1">
+                              <a:latin typeface="Cambria Math" panose="02040503050406030204" pitchFamily="18" charset="0"/>
+                            </a:rPr>
+                            <m:t>𝑟</m:t>
+                          </m:r>
+                        </m:den>
+                      </m:f>
+                      <m:r>
+                        <a:rPr lang="ar-AE" sz="3500" i="1">
+                          <a:latin typeface="Cambria Math" panose="02040503050406030204" pitchFamily="18" charset="0"/>
+                        </a:rPr>
+                        <m:t>  +  </m:t>
+                      </m:r>
+                      <m:f>
+                        <m:fPr>
+                          <m:ctrlPr>
+                            <a:rPr lang="ar-AE" sz="3500" i="1">
+                              <a:latin typeface="Cambria Math" panose="02040503050406030204" pitchFamily="18" charset="0"/>
+                            </a:rPr>
+                          </m:ctrlPr>
+                        </m:fPr>
+                        <m:num>
+                          <m:sSup>
+                            <m:sSupPr>
+                              <m:ctrlPr>
+                                <a:rPr lang="ar-AE" sz="3500" i="1">
+                                  <a:latin typeface="Cambria Math" panose="02040503050406030204" pitchFamily="18" charset="0"/>
+                                </a:rPr>
+                              </m:ctrlPr>
+                            </m:sSupPr>
+                            <m:e>
+                              <m:r>
+                                <a:rPr lang="ar-AE" sz="3500" i="1">
+                                  <a:latin typeface="Cambria Math" panose="02040503050406030204" pitchFamily="18" charset="0"/>
+                                </a:rPr>
+                                <m:t>𝜕</m:t>
+                              </m:r>
+                            </m:e>
+                            <m:sup>
+                              <m:r>
+                                <a:rPr lang="ar-AE" sz="3500" i="1">
+                                  <a:latin typeface="Cambria Math" panose="02040503050406030204" pitchFamily="18" charset="0"/>
+                                </a:rPr>
+                                <m:t>2</m:t>
+                              </m:r>
+                            </m:sup>
+                          </m:sSup>
+                          <m:r>
+                            <a:rPr lang="ar-AE" sz="3500" i="1">
+                              <a:latin typeface="Cambria Math" panose="02040503050406030204" pitchFamily="18" charset="0"/>
+                            </a:rPr>
+                            <m:t>𝜓</m:t>
+                          </m:r>
+                        </m:num>
+                        <m:den>
+                          <m:r>
+                            <a:rPr lang="ar-AE" sz="3500" i="1">
+                              <a:latin typeface="Cambria Math" panose="02040503050406030204" pitchFamily="18" charset="0"/>
+                            </a:rPr>
+                            <m:t>𝜕</m:t>
+                          </m:r>
+                          <m:sSup>
+                            <m:sSupPr>
+                              <m:ctrlPr>
+                                <a:rPr lang="ar-AE" sz="3500" i="1">
+                                  <a:latin typeface="Cambria Math" panose="02040503050406030204" pitchFamily="18" charset="0"/>
+                                </a:rPr>
+                              </m:ctrlPr>
+                            </m:sSupPr>
+                            <m:e>
+                              <m:r>
+                                <a:rPr lang="ar-AE" sz="3500" i="1">
+                                  <a:latin typeface="Cambria Math" panose="02040503050406030204" pitchFamily="18" charset="0"/>
+                                </a:rPr>
+                                <m:t>𝑧</m:t>
+                              </m:r>
+                            </m:e>
+                            <m:sup>
+                              <m:r>
+                                <a:rPr lang="ar-AE" sz="3500" i="1">
+                                  <a:latin typeface="Cambria Math" panose="02040503050406030204" pitchFamily="18" charset="0"/>
+                                </a:rPr>
+                                <m:t>2</m:t>
+                              </m:r>
+                            </m:sup>
+                          </m:sSup>
+                        </m:den>
+                      </m:f>
+                      <m:r>
+                        <a:rPr lang="ar-AE" sz="3500" i="1">
+                          <a:latin typeface="Cambria Math" panose="02040503050406030204" pitchFamily="18" charset="0"/>
+                        </a:rPr>
+                        <m:t>   =   − </m:t>
+                      </m:r>
+                      <m:sSub>
+                        <m:sSubPr>
+                          <m:ctrlPr>
+                            <a:rPr lang="ar-AE" sz="3500" i="1">
+                              <a:latin typeface="Cambria Math" panose="02040503050406030204" pitchFamily="18" charset="0"/>
+                            </a:rPr>
+                          </m:ctrlPr>
+                        </m:sSubPr>
+                        <m:e>
+                          <m:r>
+                            <a:rPr lang="ar-AE" sz="3500" i="1">
+                              <a:latin typeface="Cambria Math" panose="02040503050406030204" pitchFamily="18" charset="0"/>
+                            </a:rPr>
+                            <m:t>𝜇</m:t>
+                          </m:r>
+                        </m:e>
+                        <m:sub>
+                          <m:r>
+                            <a:rPr lang="ar-AE" sz="3500" i="1">
+                              <a:latin typeface="Cambria Math" panose="02040503050406030204" pitchFamily="18" charset="0"/>
+                            </a:rPr>
+                            <m:t>0</m:t>
+                          </m:r>
+                        </m:sub>
+                      </m:sSub>
+                      <m:r>
+                        <a:rPr lang="ar-AE" sz="3500" i="1">
+                          <a:latin typeface="Cambria Math" panose="02040503050406030204" pitchFamily="18" charset="0"/>
+                        </a:rPr>
+                        <m:t> </m:t>
+                      </m:r>
+                      <m:sSup>
+                        <m:sSupPr>
+                          <m:ctrlPr>
+                            <a:rPr lang="ar-AE" sz="3500" i="1">
+                              <a:latin typeface="Cambria Math" panose="02040503050406030204" pitchFamily="18" charset="0"/>
+                            </a:rPr>
+                          </m:ctrlPr>
+                        </m:sSupPr>
+                        <m:e>
+                          <m:r>
+                            <a:rPr lang="ar-AE" sz="3500" i="1">
+                              <a:latin typeface="Cambria Math" panose="02040503050406030204" pitchFamily="18" charset="0"/>
+                            </a:rPr>
+                            <m:t>𝑟</m:t>
+                          </m:r>
+                        </m:e>
+                        <m:sup>
+                          <m:r>
+                            <a:rPr lang="ar-AE" sz="3500" i="1">
+                              <a:latin typeface="Cambria Math" panose="02040503050406030204" pitchFamily="18" charset="0"/>
+                            </a:rPr>
+                            <m:t>2</m:t>
+                          </m:r>
+                        </m:sup>
+                      </m:sSup>
+                      <m:r>
+                        <a:rPr lang="ar-AE" sz="3500" i="1">
+                          <a:latin typeface="Cambria Math" panose="02040503050406030204" pitchFamily="18" charset="0"/>
+                        </a:rPr>
+                        <m:t> </m:t>
+                      </m:r>
+                      <m:f>
+                        <m:fPr>
+                          <m:ctrlPr>
+                            <a:rPr lang="ar-AE" sz="3500" i="1">
+                              <a:latin typeface="Cambria Math" panose="02040503050406030204" pitchFamily="18" charset="0"/>
+                            </a:rPr>
+                          </m:ctrlPr>
+                        </m:fPr>
+                        <m:num>
+                          <m:r>
+                            <a:rPr lang="ar-AE" sz="3500" i="1">
+                              <a:latin typeface="Cambria Math" panose="02040503050406030204" pitchFamily="18" charset="0"/>
+                            </a:rPr>
+                            <m:t>𝑑𝑝</m:t>
+                          </m:r>
+                        </m:num>
+                        <m:den>
+                          <m:r>
+                            <a:rPr lang="ar-AE" sz="3500" i="1">
+                              <a:latin typeface="Cambria Math" panose="02040503050406030204" pitchFamily="18" charset="0"/>
+                            </a:rPr>
+                            <m:t>𝑑</m:t>
+                          </m:r>
+                          <m:r>
+                            <a:rPr lang="ar-AE" sz="3500" i="1">
+                              <a:latin typeface="Cambria Math" panose="02040503050406030204" pitchFamily="18" charset="0"/>
+                            </a:rPr>
+                            <m:t>𝜓</m:t>
+                          </m:r>
+                        </m:den>
+                      </m:f>
+                      <m:r>
+                        <a:rPr lang="ar-AE" sz="3500" i="1">
+                          <a:latin typeface="Cambria Math" panose="02040503050406030204" pitchFamily="18" charset="0"/>
+                        </a:rPr>
+                        <m:t>  −  </m:t>
+                      </m:r>
+                      <m:f>
+                        <m:fPr>
+                          <m:ctrlPr>
+                            <a:rPr lang="ar-AE" sz="3500" i="1">
+                              <a:latin typeface="Cambria Math" panose="02040503050406030204" pitchFamily="18" charset="0"/>
+                            </a:rPr>
+                          </m:ctrlPr>
+                        </m:fPr>
+                        <m:num>
+                          <m:r>
+                            <a:rPr lang="ar-AE" sz="3500" i="1">
+                              <a:latin typeface="Cambria Math" panose="02040503050406030204" pitchFamily="18" charset="0"/>
+                            </a:rPr>
+                            <m:t>1</m:t>
+                          </m:r>
+                        </m:num>
+                        <m:den>
+                          <m:r>
+                            <a:rPr lang="ar-AE" sz="3500" i="1">
+                              <a:latin typeface="Cambria Math" panose="02040503050406030204" pitchFamily="18" charset="0"/>
+                            </a:rPr>
+                            <m:t>2</m:t>
+                          </m:r>
+                        </m:den>
+                      </m:f>
+                      <m:r>
+                        <a:rPr lang="ar-AE" sz="3500" i="1">
+                          <a:latin typeface="Cambria Math" panose="02040503050406030204" pitchFamily="18" charset="0"/>
+                        </a:rPr>
+                        <m:t> </m:t>
+                      </m:r>
+                      <m:f>
+                        <m:fPr>
+                          <m:ctrlPr>
+                            <a:rPr lang="ar-AE" sz="3500" i="1">
+                              <a:latin typeface="Cambria Math" panose="02040503050406030204" pitchFamily="18" charset="0"/>
+                            </a:rPr>
+                          </m:ctrlPr>
+                        </m:fPr>
+                        <m:num>
+                          <m:r>
+                            <a:rPr lang="ar-AE" sz="3500" i="1">
+                              <a:latin typeface="Cambria Math" panose="02040503050406030204" pitchFamily="18" charset="0"/>
+                            </a:rPr>
+                            <m:t>𝑑</m:t>
+                          </m:r>
+                          <m:sSup>
+                            <m:sSupPr>
+                              <m:ctrlPr>
+                                <a:rPr lang="ar-AE" sz="3500" i="1">
+                                  <a:latin typeface="Cambria Math" panose="02040503050406030204" pitchFamily="18" charset="0"/>
+                                </a:rPr>
+                              </m:ctrlPr>
+                            </m:sSupPr>
+                            <m:e>
+                              <m:r>
+                                <a:rPr lang="ar-AE" sz="3500" i="1">
+                                  <a:latin typeface="Cambria Math" panose="02040503050406030204" pitchFamily="18" charset="0"/>
+                                </a:rPr>
+                                <m:t>𝐹</m:t>
+                              </m:r>
+                            </m:e>
+                            <m:sup>
+                              <m:r>
+                                <a:rPr lang="ar-AE" sz="3500" i="1">
+                                  <a:latin typeface="Cambria Math" panose="02040503050406030204" pitchFamily="18" charset="0"/>
+                                </a:rPr>
+                                <m:t>2</m:t>
+                              </m:r>
+                            </m:sup>
+                          </m:sSup>
+                        </m:num>
+                        <m:den>
+                          <m:r>
+                            <a:rPr lang="ar-AE" sz="3500" i="1">
+                              <a:latin typeface="Cambria Math" panose="02040503050406030204" pitchFamily="18" charset="0"/>
+                            </a:rPr>
+                            <m:t>𝑑</m:t>
+                          </m:r>
+                          <m:r>
+                            <a:rPr lang="ar-AE" sz="3500" i="1">
+                              <a:latin typeface="Cambria Math" panose="02040503050406030204" pitchFamily="18" charset="0"/>
+                            </a:rPr>
+                            <m:t>𝜓</m:t>
+                          </m:r>
+                        </m:den>
+                      </m:f>
+                      <m:r>
+                        <a:rPr lang="ar-AE" sz="3500" i="1">
+                          <a:latin typeface="Cambria Math" panose="02040503050406030204" pitchFamily="18" charset="0"/>
+                        </a:rPr>
+                        <m:t> </m:t>
+                      </m:r>
+                    </m:oMath>
+                  </m:oMathPara>
+                </a14:m>
+                <a:endParaRPr lang="en-US" sz="3500" dirty="0"/>
+              </a:p>
+              <a:p>
+                <a:pPr algn="just">
+                  <a:spcAft>
+                    <a:spcPts val="600"/>
+                  </a:spcAft>
+                </a:pPr>
+                <a:r>
+                  <a:rPr lang="en-US" sz="3500" dirty="0"/>
+                  <a:t>where </a:t>
+                </a:r>
+                <a14:m>
+                  <m:oMath xmlns:m="http://schemas.openxmlformats.org/officeDocument/2006/math">
+                    <m:r>
+                      <a:rPr lang="en-US" sz="3500" i="1" dirty="0" smtClean="0">
+                        <a:latin typeface="Cambria Math" panose="02040503050406030204" pitchFamily="18" charset="0"/>
+                      </a:rPr>
+                      <m:t>𝑝</m:t>
+                    </m:r>
+                  </m:oMath>
+                </a14:m>
+                <a:r>
+                  <a:rPr lang="en-US" sz="3500" dirty="0"/>
+                  <a:t> is plasma pressure, </a:t>
+                </a:r>
+                <a14:m>
+                  <m:oMath xmlns:m="http://schemas.openxmlformats.org/officeDocument/2006/math">
+                    <m:sSub>
+                      <m:sSubPr>
+                        <m:ctrlPr>
+                          <a:rPr lang="en-US" sz="3500" i="1" dirty="0" smtClean="0">
+                            <a:latin typeface="Cambria Math" panose="02040503050406030204" pitchFamily="18" charset="0"/>
+                          </a:rPr>
+                        </m:ctrlPr>
+                      </m:sSubPr>
+                      <m:e>
+                        <m:r>
+                          <a:rPr lang="en-US" sz="3500" i="1" dirty="0" smtClean="0">
+                            <a:latin typeface="Cambria Math" panose="02040503050406030204" pitchFamily="18" charset="0"/>
+                          </a:rPr>
+                          <m:t>𝜇</m:t>
+                        </m:r>
+                      </m:e>
+                      <m:sub>
+                        <m:r>
+                          <a:rPr lang="en-US" sz="3500" i="1" dirty="0" smtClean="0">
+                            <a:latin typeface="Cambria Math" panose="02040503050406030204" pitchFamily="18" charset="0"/>
+                          </a:rPr>
+                          <m:t>0</m:t>
+                        </m:r>
+                      </m:sub>
+                    </m:sSub>
+                  </m:oMath>
+                </a14:m>
+                <a:r>
+                  <a:rPr lang="en-US" sz="3500" dirty="0"/>
+                  <a:t> is magnetic permeability, </a:t>
+                </a:r>
+                <a14:m>
+                  <m:oMath xmlns:m="http://schemas.openxmlformats.org/officeDocument/2006/math">
+                    <m:r>
+                      <a:rPr lang="en-US" sz="3500" i="1" dirty="0" smtClean="0">
+                        <a:latin typeface="Cambria Math" panose="02040503050406030204" pitchFamily="18" charset="0"/>
+                      </a:rPr>
+                      <m:t>𝐹</m:t>
+                    </m:r>
+                    <m:r>
+                      <a:rPr lang="en-US" sz="3500" i="1" dirty="0" smtClean="0">
+                        <a:latin typeface="Cambria Math" panose="02040503050406030204" pitchFamily="18" charset="0"/>
+                      </a:rPr>
+                      <m:t>=</m:t>
+                    </m:r>
+                    <m:r>
+                      <a:rPr lang="en-US" sz="3500" i="1" dirty="0" smtClean="0">
+                        <a:latin typeface="Cambria Math" panose="02040503050406030204" pitchFamily="18" charset="0"/>
+                      </a:rPr>
+                      <m:t>𝑟</m:t>
+                    </m:r>
+                    <m:sSub>
+                      <m:sSubPr>
+                        <m:ctrlPr>
+                          <a:rPr lang="en-US" sz="3500" i="1" dirty="0" smtClean="0">
+                            <a:latin typeface="Cambria Math" panose="02040503050406030204" pitchFamily="18" charset="0"/>
+                          </a:rPr>
+                        </m:ctrlPr>
+                      </m:sSubPr>
+                      <m:e>
+                        <m:r>
+                          <a:rPr lang="en-US" sz="3500" i="1" dirty="0" smtClean="0">
+                            <a:latin typeface="Cambria Math" panose="02040503050406030204" pitchFamily="18" charset="0"/>
+                          </a:rPr>
+                          <m:t>𝐵</m:t>
+                        </m:r>
+                      </m:e>
+                      <m:sub>
+                        <m:r>
+                          <a:rPr lang="en-US" sz="3500" i="1" dirty="0" smtClean="0">
+                            <a:latin typeface="Cambria Math" panose="02040503050406030204" pitchFamily="18" charset="0"/>
+                          </a:rPr>
+                          <m:t>𝜃</m:t>
+                        </m:r>
+                      </m:sub>
+                    </m:sSub>
+                  </m:oMath>
+                </a14:m>
+                <a:r>
+                  <a:rPr lang="en-US" sz="3500" dirty="0"/>
+                  <a:t>, </a:t>
+                </a:r>
+                <a14:m>
+                  <m:oMath xmlns:m="http://schemas.openxmlformats.org/officeDocument/2006/math">
+                    <m:r>
+                      <a:rPr lang="en-US" sz="3500" i="1" dirty="0" smtClean="0">
+                        <a:latin typeface="Cambria Math" panose="02040503050406030204" pitchFamily="18" charset="0"/>
+                      </a:rPr>
+                      <m:t>𝐵</m:t>
+                    </m:r>
+                  </m:oMath>
+                </a14:m>
+                <a:r>
+                  <a:rPr lang="en-US" sz="3500" dirty="0"/>
+                  <a:t> is magnetic field, and </a:t>
+                </a:r>
+                <a14:m>
+                  <m:oMath xmlns:m="http://schemas.openxmlformats.org/officeDocument/2006/math">
+                    <m:r>
+                      <a:rPr lang="en-US" sz="3500" i="1" dirty="0" smtClean="0">
+                        <a:latin typeface="Cambria Math" panose="02040503050406030204" pitchFamily="18" charset="0"/>
+                      </a:rPr>
+                      <m:t>(</m:t>
+                    </m:r>
+                    <m:r>
+                      <a:rPr lang="en-US" sz="3500" i="1" dirty="0" smtClean="0">
+                        <a:latin typeface="Cambria Math" panose="02040503050406030204" pitchFamily="18" charset="0"/>
+                      </a:rPr>
+                      <m:t>𝑟</m:t>
+                    </m:r>
+                    <m:r>
+                      <a:rPr lang="en-US" sz="3500" i="1" dirty="0" smtClean="0">
+                        <a:latin typeface="Cambria Math" panose="02040503050406030204" pitchFamily="18" charset="0"/>
+                      </a:rPr>
+                      <m:t>,</m:t>
+                    </m:r>
+                    <m:r>
+                      <a:rPr lang="en-US" sz="3500" i="1" dirty="0" smtClean="0">
+                        <a:latin typeface="Cambria Math" panose="02040503050406030204" pitchFamily="18" charset="0"/>
+                      </a:rPr>
+                      <m:t>𝜃</m:t>
+                    </m:r>
+                    <m:r>
+                      <a:rPr lang="en-US" sz="3500" i="1" dirty="0" smtClean="0">
+                        <a:latin typeface="Cambria Math" panose="02040503050406030204" pitchFamily="18" charset="0"/>
+                      </a:rPr>
+                      <m:t>,</m:t>
+                    </m:r>
+                    <m:r>
+                      <a:rPr lang="en-US" sz="3500" i="1" dirty="0" smtClean="0">
+                        <a:latin typeface="Cambria Math" panose="02040503050406030204" pitchFamily="18" charset="0"/>
+                      </a:rPr>
+                      <m:t>𝑧</m:t>
+                    </m:r>
+                    <m:r>
+                      <a:rPr lang="en-US" sz="3500" i="1" dirty="0" smtClean="0">
+                        <a:latin typeface="Cambria Math" panose="02040503050406030204" pitchFamily="18" charset="0"/>
+                      </a:rPr>
+                      <m:t>) </m:t>
+                    </m:r>
+                  </m:oMath>
+                </a14:m>
+                <a:r>
+                  <a:rPr lang="en-US" sz="3500" dirty="0"/>
+                  <a:t>are cylindrical coordinates. </a:t>
+                </a:r>
+              </a:p>
+              <a:p>
+                <a:pPr algn="just">
+                  <a:spcAft>
+                    <a:spcPts val="600"/>
+                  </a:spcAft>
+                </a:pPr>
+                <a:r>
+                  <a:rPr lang="en-US" sz="3500" b="0" dirty="0">
+                    <a:solidFill>
+                      <a:srgbClr val="1F1F1F"/>
+                    </a:solidFill>
+                  </a:rPr>
+                  <a:t>Sets the flux surfaces, magnetic axis, plasma shape, and safety factor </a:t>
+                </a:r>
+                <a14:m>
+                  <m:oMath xmlns:m="http://schemas.openxmlformats.org/officeDocument/2006/math">
+                    <m:r>
+                      <a:rPr lang="en-US" sz="3500" b="0" i="1" dirty="0" smtClean="0">
+                        <a:solidFill>
+                          <a:srgbClr val="1F1F1F"/>
+                        </a:solidFill>
+                        <a:latin typeface="Cambria Math" panose="02040503050406030204" pitchFamily="18" charset="0"/>
+                      </a:rPr>
+                      <m:t>𝑞</m:t>
+                    </m:r>
+                  </m:oMath>
+                </a14:m>
+                <a:r>
+                  <a:rPr lang="en-US" sz="3500" b="0" dirty="0">
+                    <a:solidFill>
+                      <a:srgbClr val="1F1F1F"/>
+                    </a:solidFill>
+                  </a:rPr>
+                  <a:t>.</a:t>
+                </a:r>
+              </a:p>
+              <a:p>
+                <a:pPr algn="l">
+                  <a:spcAft>
+                    <a:spcPts val="600"/>
+                  </a:spcAft>
+                </a:pPr>
+                <a:r>
+                  <a:rPr lang="en-US" sz="3500" b="0" dirty="0" err="1">
+                    <a:solidFill>
+                      <a:srgbClr val="1F1F1F"/>
+                    </a:solidFill>
+                  </a:rPr>
+                  <a:t>Solov'ev</a:t>
+                </a:r>
+                <a:r>
+                  <a:rPr lang="en-US" sz="3500" b="0" dirty="0">
+                    <a:solidFill>
+                      <a:srgbClr val="1F1F1F"/>
+                    </a:solidFill>
+                  </a:rPr>
+                  <a:t> profiles admit an exact solution → a rigorous verification anchor.</a:t>
+                </a:r>
+                <a:endParaRPr sz="3500" b="0" dirty="0">
+                  <a:solidFill>
+                    <a:srgbClr val="1F1F1F"/>
+                  </a:solidFill>
+                </a:endParaRPr>
+              </a:p>
+            </p:txBody>
+          </p:sp>
+        </mc:Choice>
+        <mc:Fallback>
+          <p:sp>
+            <p:nvSpPr>
+              <p:cNvPr id="9" name="TextBox 8"/>
+              <p:cNvSpPr txBox="1">
+                <a:spLocks noRot="1" noChangeAspect="1" noMove="1" noResize="1" noEditPoints="1" noAdjustHandles="1" noChangeArrowheads="1" noChangeShapeType="1" noTextEdit="1"/>
+              </p:cNvSpPr>
+              <p:nvPr/>
+            </p:nvSpPr>
+            <p:spPr>
+              <a:xfrm>
+                <a:off x="914400" y="11985298"/>
+                <a:ext cx="13075920" cy="5341847"/>
+              </a:xfrm>
+              <a:prstGeom prst="rect">
+                <a:avLst/>
+              </a:prstGeom>
+              <a:blipFill>
+                <a:blip r:embed="rId2"/>
+                <a:stretch>
+                  <a:fillRect l="-1352" t="-1712" r="-1352" b="-3425"/>
+                </a:stretch>
+              </a:blipFill>
+            </p:spPr>
+            <p:txBody>
+              <a:bodyPr/>
+              <a:lstStyle/>
+              <a:p>
+                <a:r>
+                  <a:rPr lang="en-US">
+                    <a:noFill/>
+                  </a:rPr>
+                  <a:t> </a:t>
+                </a:r>
+              </a:p>
+            </p:txBody>
+          </p:sp>
+        </mc:Fallback>
+      </mc:AlternateContent>
       <p:sp>
         <p:nvSpPr>
           <p:cNvPr id="10" name="Rounded Rectangle 9"/>
@@ -3558,7 +4619,7 @@
             <a:off x="14767559" y="4572000"/>
             <a:ext cx="13624560" cy="5720851"/>
           </a:xfrm>
-          <a:prstGeom prst="roundRect">
+          <a:prstGeom prst="rect">
             <a:avLst/>
           </a:prstGeom>
           <a:solidFill>
@@ -3590,6 +4651,7 @@
           <a:lstStyle/>
           <a:p>
             <a:pPr algn="ctr"/>
+            <a:endParaRPr/>
           </a:p>
         </p:txBody>
       </p:sp>
@@ -3630,17 +4692,33 @@
           </a:fontRef>
         </p:style>
         <p:txBody>
-          <a:bodyPr rtlCol="0" anchor="ctr" lIns="274320"/>
+          <a:bodyPr lIns="274320" rtlCol="0" anchor="ctr"/>
           <a:lstStyle/>
           <a:p>
             <a:pPr algn="ctr"/>
             <a:r>
-              <a:rPr sz="4000" b="1">
+              <a:rPr sz="4000" b="1" dirty="0">
                 <a:solidFill>
                   <a:srgbClr val="FFFFFF"/>
                 </a:solidFill>
               </a:rPr>
-              <a:t>4  The pipeline in action</a:t>
+              <a:t>4</a:t>
+            </a:r>
+            <a:r>
+              <a:rPr lang="en-US" sz="4000" b="1" dirty="0">
+                <a:solidFill>
+                  <a:srgbClr val="FFFFFF"/>
+                </a:solidFill>
+              </a:rPr>
+              <a:t>.</a:t>
+            </a:r>
+            <a:r>
+              <a:rPr sz="4000" b="1" dirty="0">
+                <a:solidFill>
+                  <a:srgbClr val="FFFFFF"/>
+                </a:solidFill>
+              </a:rPr>
+              <a:t>  The pipeline in action</a:t>
             </a:r>
           </a:p>
         </p:txBody>
@@ -3654,7 +4732,7 @@
         <p:spPr>
           <a:xfrm>
             <a:off x="15041880" y="5897880"/>
-            <a:ext cx="13075920" cy="4166371"/>
+            <a:ext cx="13075920" cy="3631763"/>
           </a:xfrm>
           <a:prstGeom prst="rect">
             <a:avLst/>
@@ -3673,12 +4751,28 @@
               </a:spcAft>
             </a:pPr>
             <a:r>
-              <a:rPr sz="3000" b="1">
+              <a:rPr sz="3500" b="1" dirty="0">
                 <a:solidFill>
                   <a:srgbClr val="1F1F1F"/>
                 </a:solidFill>
               </a:rPr>
-              <a:t>Prompt: “the Grad-Shafranov equilibrium for a tokamak plasma.”</a:t>
+              <a:t>Prompt: “the Grad-</a:t>
+            </a:r>
+            <a:r>
+              <a:rPr sz="3500" b="1" dirty="0" err="1">
+                <a:solidFill>
+                  <a:srgbClr val="1F1F1F"/>
+                </a:solidFill>
+              </a:rPr>
+              <a:t>Shafranov</a:t>
+            </a:r>
+            <a:r>
+              <a:rPr sz="3500" b="1" dirty="0">
+                <a:solidFill>
+                  <a:srgbClr val="1F1F1F"/>
+                </a:solidFill>
+              </a:rPr>
+              <a:t> equilibrium for a tokamak plasma.”</a:t>
             </a:r>
           </a:p>
           <a:p>
@@ -3688,12 +4782,95 @@
               </a:spcAft>
             </a:pPr>
             <a:r>
-              <a:rPr sz="3000" b="0">
+              <a:rPr sz="3500" b="0" dirty="0">
                 <a:solidFill>
                   <a:srgbClr val="1F1F1F"/>
                 </a:solidFill>
               </a:rPr>
-              <a:t>Modeling → ‘Grad-Shafranov equation’, steady.</a:t>
+              <a:t>Modeling → ‘Grad-</a:t>
+            </a:r>
+            <a:r>
+              <a:rPr sz="3500" b="0" dirty="0" err="1">
+                <a:solidFill>
+                  <a:srgbClr val="1F1F1F"/>
+                </a:solidFill>
+              </a:rPr>
+              <a:t>Shafranov</a:t>
+            </a:r>
+            <a:r>
+              <a:rPr sz="3500" b="0" dirty="0">
+                <a:solidFill>
+                  <a:srgbClr val="1F1F1F"/>
+                </a:solidFill>
+              </a:rPr>
+              <a:t> equation’, steady.</a:t>
+            </a:r>
+          </a:p>
+          <a:p>
+            <a:pPr>
+              <a:spcAft>
+                <a:spcPts val="600"/>
+              </a:spcAft>
+            </a:pPr>
+            <a:r>
+              <a:rPr sz="3500" b="0" dirty="0">
+                <a:solidFill>
+                  <a:srgbClr val="1F1F1F"/>
+                </a:solidFill>
+              </a:rPr>
+              <a:t>Numerical Analysis → non</a:t>
+            </a:r>
+            <a:r>
+              <a:rPr lang="en-US" sz="3500" b="0" dirty="0">
+                <a:solidFill>
+                  <a:srgbClr val="1F1F1F"/>
+                </a:solidFill>
+              </a:rPr>
+              <a:t>-</a:t>
+            </a:r>
+            <a:r>
+              <a:rPr sz="3500" b="0" dirty="0">
+                <a:solidFill>
+                  <a:srgbClr val="1F1F1F"/>
+                </a:solidFill>
+              </a:rPr>
+              <a:t>linear ⇒ SNES </a:t>
+            </a:r>
+            <a:r>
+              <a:rPr lang="en-US" sz="3500" b="0" dirty="0">
+                <a:solidFill>
+                  <a:srgbClr val="1F1F1F"/>
+                </a:solidFill>
+              </a:rPr>
+              <a:t>(Scalable Nonlinear Equations Solvers) </a:t>
+            </a:r>
+            <a:r>
+              <a:rPr sz="3500" b="0" dirty="0">
+                <a:solidFill>
+                  <a:srgbClr val="1F1F1F"/>
+                </a:solidFill>
+              </a:rPr>
+              <a:t>on a DMDA</a:t>
+            </a:r>
+            <a:r>
+              <a:rPr lang="en-US" sz="3500" b="0" dirty="0">
+                <a:solidFill>
+                  <a:srgbClr val="1F1F1F"/>
+                </a:solidFill>
+              </a:rPr>
+              <a:t> (</a:t>
+            </a:r>
+            <a:r>
+              <a:rPr lang="en-US" sz="3600" dirty="0"/>
+              <a:t>Distributed Management Distributed Array)</a:t>
+            </a:r>
+            <a:r>
+              <a:rPr sz="3500" b="0" dirty="0">
+                <a:solidFill>
+                  <a:srgbClr val="1F1F1F"/>
+                </a:solidFill>
+              </a:rPr>
+              <a:t>.</a:t>
             </a:r>
           </a:p>
           <a:p>
@@ -3703,12 +4880,44 @@
               </a:spcAft>
             </a:pPr>
             <a:r>
-              <a:rPr sz="3000" b="0">
+              <a:rPr sz="3500" b="0" dirty="0">
                 <a:solidFill>
                   <a:srgbClr val="1F1F1F"/>
                 </a:solidFill>
               </a:rPr>
-              <a:t>Numerical Analysis → nonlinear ⇒ SNES on a DMDA.</a:t>
+              <a:t>Code Generation → </a:t>
+            </a:r>
+            <a:r>
+              <a:rPr lang="en-US" sz="3500" b="0" dirty="0">
+                <a:solidFill>
+                  <a:srgbClr val="1F1F1F"/>
+                </a:solidFill>
+              </a:rPr>
+              <a:t>one</a:t>
+            </a:r>
+            <a:r>
+              <a:rPr sz="3500" b="0" dirty="0">
+                <a:solidFill>
+                  <a:srgbClr val="1F1F1F"/>
+                </a:solidFill>
+              </a:rPr>
+              <a:t> 252-line parametrized </a:t>
+            </a:r>
+            <a:r>
+              <a:rPr sz="3500" b="0" dirty="0" err="1">
+                <a:solidFill>
+                  <a:srgbClr val="1F1F1F"/>
+                </a:solidFill>
+              </a:rPr>
+              <a:t>PETSc</a:t>
+            </a:r>
+            <a:r>
+              <a:rPr sz="3500" b="0" dirty="0">
+                <a:solidFill>
+                  <a:srgbClr val="1F1F1F"/>
+                </a:solidFill>
+              </a:rPr>
+              <a:t> solver.</a:t>
             </a:r>
           </a:p>
           <a:p>
@@ -3718,27 +4927,44 @@
               </a:spcAft>
             </a:pPr>
             <a:r>
-              <a:rPr sz="3000" b="0">
-                <a:solidFill>
-                  <a:srgbClr val="1F1F1F"/>
-                </a:solidFill>
-              </a:rPr>
-              <a:t>Code Generation → ONE 252-line parametrized PETSc solver.</a:t>
-            </a:r>
-          </a:p>
-          <a:p>
-            <a:pPr algn="l">
-              <a:spcAft>
-                <a:spcPts val="600"/>
-              </a:spcAft>
-            </a:pPr>
-            <a:r>
-              <a:rPr sz="3000" b="1">
+              <a:rPr sz="3500" b="1" dirty="0">
                 <a:solidFill>
                   <a:srgbClr val="007D8A"/>
                 </a:solidFill>
               </a:rPr>
-              <a:t>Compiled &amp; ran on 1 and 4 MPI ranks — no human edits.</a:t>
+              <a:t>Compiled </a:t>
+            </a:r>
+            <a:r>
+              <a:rPr lang="en-US" sz="3500" b="1" dirty="0">
+                <a:solidFill>
+                  <a:srgbClr val="007D8A"/>
+                </a:solidFill>
+              </a:rPr>
+              <a:t>and</a:t>
+            </a:r>
+            <a:r>
+              <a:rPr sz="3500" b="1" dirty="0">
+                <a:solidFill>
+                  <a:srgbClr val="007D8A"/>
+                </a:solidFill>
+              </a:rPr>
+              <a:t> ran on 1 and 4 MPI ranks </a:t>
+            </a:r>
+            <a:r>
+              <a:rPr lang="en-US" sz="3500" b="1" dirty="0">
+                <a:solidFill>
+                  <a:srgbClr val="007D8A"/>
+                </a:solidFill>
+              </a:rPr>
+              <a:t>without any</a:t>
+            </a:r>
+            <a:r>
+              <a:rPr sz="3500" b="1" dirty="0">
+                <a:solidFill>
+                  <a:srgbClr val="007D8A"/>
+                </a:solidFill>
+              </a:rPr>
+              <a:t> human edits.</a:t>
             </a:r>
           </a:p>
         </p:txBody>
@@ -3754,7 +4980,7 @@
             <a:off x="14767559" y="11298691"/>
             <a:ext cx="13624560" cy="7115311"/>
           </a:xfrm>
-          <a:prstGeom prst="roundRect">
+          <a:prstGeom prst="rect">
             <a:avLst/>
           </a:prstGeom>
           <a:solidFill>
@@ -3786,6 +5012,7 @@
           <a:lstStyle/>
           <a:p>
             <a:pPr algn="ctr"/>
+            <a:endParaRPr/>
           </a:p>
         </p:txBody>
       </p:sp>
@@ -3826,17 +5053,33 @@
           </a:fontRef>
         </p:style>
         <p:txBody>
-          <a:bodyPr rtlCol="0" anchor="ctr" lIns="274320"/>
+          <a:bodyPr lIns="274320" rtlCol="0" anchor="ctr"/>
           <a:lstStyle/>
           <a:p>
             <a:pPr algn="ctr"/>
             <a:r>
-              <a:rPr sz="4000" b="1">
+              <a:rPr sz="4000" b="1" dirty="0">
                 <a:solidFill>
                   <a:srgbClr val="FFFFFF"/>
                 </a:solidFill>
               </a:rPr>
-              <a:t>5  Generated solver (excerpt)</a:t>
+              <a:t>5</a:t>
+            </a:r>
+            <a:r>
+              <a:rPr lang="en-US" sz="4000" b="1" dirty="0">
+                <a:solidFill>
+                  <a:srgbClr val="FFFFFF"/>
+                </a:solidFill>
+              </a:rPr>
+              <a:t>.</a:t>
+            </a:r>
+            <a:r>
+              <a:rPr sz="4000" b="1" dirty="0">
+                <a:solidFill>
+                  <a:srgbClr val="FFFFFF"/>
+                </a:solidFill>
+              </a:rPr>
+              <a:t>  Generated solver (excerpt)</a:t>
             </a:r>
           </a:p>
         </p:txBody>
@@ -3850,7 +5093,7 @@
         <p:spPr>
           <a:xfrm>
             <a:off x="15041880" y="12624571"/>
-            <a:ext cx="13075920" cy="5560831"/>
+            <a:ext cx="13075920" cy="4862870"/>
           </a:xfrm>
           <a:prstGeom prst="rect">
             <a:avLst/>
@@ -3869,7 +5112,7 @@
               </a:spcAft>
             </a:pPr>
             <a:r>
-              <a:rPr sz="2300" b="0">
+              <a:rPr sz="3000" b="0" dirty="0">
                 <a:solidFill>
                   <a:srgbClr val="4A4A4A"/>
                 </a:solidFill>
@@ -3885,7 +5128,7 @@
               </a:spcAft>
             </a:pPr>
             <a:r>
-              <a:rPr sz="2300" b="0">
+              <a:rPr sz="3000" b="0" dirty="0">
                 <a:solidFill>
                   <a:srgbClr val="1F1F1F"/>
                 </a:solidFill>
@@ -3901,13 +5144,31 @@
               </a:spcAft>
             </a:pPr>
             <a:r>
-              <a:rPr sz="2300" b="0">
+              <a:rPr sz="3000" b="0" dirty="0">
                 <a:solidFill>
                   <a:srgbClr val="1F1F1F"/>
                 </a:solidFill>
                 <a:latin typeface="Consolas"/>
               </a:rPr>
-              <a:t>dxx=(u[j][i+1]-2*u[j][i]+u[j][i-1])/hx2;</a:t>
+              <a:t>dxx=(u[j][i+1]-2*u[j][</a:t>
+            </a:r>
+            <a:r>
+              <a:rPr sz="3000" b="0" dirty="0" err="1">
+                <a:solidFill>
+                  <a:srgbClr val="1F1F1F"/>
+                </a:solidFill>
+                <a:latin typeface="Consolas"/>
+              </a:rPr>
+              <a:t>i</a:t>
+            </a:r>
+            <a:r>
+              <a:rPr sz="3000" b="0" dirty="0">
+                <a:solidFill>
+                  <a:srgbClr val="1F1F1F"/>
+                </a:solidFill>
+                <a:latin typeface="Consolas"/>
+              </a:rPr>
+              <a:t>]+u[j][i-1])/hx2;</a:t>
             </a:r>
           </a:p>
           <a:p>
@@ -3917,13 +5178,76 @@
               </a:spcAft>
             </a:pPr>
             <a:r>
-              <a:rPr sz="2300" b="0">
+              <a:rPr sz="3000" b="0" dirty="0" err="1">
                 <a:solidFill>
                   <a:srgbClr val="1F1F1F"/>
                 </a:solidFill>
                 <a:latin typeface="Consolas"/>
               </a:rPr>
-              <a:t>dyy=(u[j+1][i]-2*u[j][i]+u[j-1][i])/hy2;</a:t>
+              <a:t>dyy</a:t>
+            </a:r>
+            <a:r>
+              <a:rPr sz="3000" b="0" dirty="0">
+                <a:solidFill>
+                  <a:srgbClr val="1F1F1F"/>
+                </a:solidFill>
+                <a:latin typeface="Consolas"/>
+              </a:rPr>
+              <a:t>=(u[j+1][</a:t>
+            </a:r>
+            <a:r>
+              <a:rPr sz="3000" b="0" dirty="0" err="1">
+                <a:solidFill>
+                  <a:srgbClr val="1F1F1F"/>
+                </a:solidFill>
+                <a:latin typeface="Consolas"/>
+              </a:rPr>
+              <a:t>i</a:t>
+            </a:r>
+            <a:r>
+              <a:rPr sz="3000" b="0" dirty="0">
+                <a:solidFill>
+                  <a:srgbClr val="1F1F1F"/>
+                </a:solidFill>
+                <a:latin typeface="Consolas"/>
+              </a:rPr>
+              <a:t>]-2*u[j][</a:t>
+            </a:r>
+            <a:r>
+              <a:rPr sz="3000" b="0" dirty="0" err="1">
+                <a:solidFill>
+                  <a:srgbClr val="1F1F1F"/>
+                </a:solidFill>
+                <a:latin typeface="Consolas"/>
+              </a:rPr>
+              <a:t>i</a:t>
+            </a:r>
+            <a:r>
+              <a:rPr sz="3000" b="0" dirty="0">
+                <a:solidFill>
+                  <a:srgbClr val="1F1F1F"/>
+                </a:solidFill>
+                <a:latin typeface="Consolas"/>
+              </a:rPr>
+              <a:t>]+u[j-1][</a:t>
+            </a:r>
+            <a:r>
+              <a:rPr sz="3000" b="0" dirty="0" err="1">
+                <a:solidFill>
+                  <a:srgbClr val="1F1F1F"/>
+                </a:solidFill>
+                <a:latin typeface="Consolas"/>
+              </a:rPr>
+              <a:t>i</a:t>
+            </a:r>
+            <a:r>
+              <a:rPr sz="3000" b="0" dirty="0">
+                <a:solidFill>
+                  <a:srgbClr val="1F1F1F"/>
+                </a:solidFill>
+                <a:latin typeface="Consolas"/>
+              </a:rPr>
+              <a:t>])/hy2;</a:t>
             </a:r>
           </a:p>
           <a:p>
@@ -3933,13 +5257,67 @@
               </a:spcAft>
             </a:pPr>
             <a:r>
-              <a:rPr sz="2300" b="0">
+              <a:rPr sz="3000" b="0" dirty="0">
                 <a:solidFill>
                   <a:srgbClr val="1F1F1F"/>
                 </a:solidFill>
                 <a:latin typeface="Consolas"/>
               </a:rPr>
-              <a:t>f[j][i]=dxx-dx/x+dyy-((1-A)*x*x+A);</a:t>
+              <a:t>f[j][</a:t>
+            </a:r>
+            <a:r>
+              <a:rPr sz="3000" b="0" dirty="0" err="1">
+                <a:solidFill>
+                  <a:srgbClr val="1F1F1F"/>
+                </a:solidFill>
+                <a:latin typeface="Consolas"/>
+              </a:rPr>
+              <a:t>i</a:t>
+            </a:r>
+            <a:r>
+              <a:rPr sz="3000" b="0" dirty="0">
+                <a:solidFill>
+                  <a:srgbClr val="1F1F1F"/>
+                </a:solidFill>
+                <a:latin typeface="Consolas"/>
+              </a:rPr>
+              <a:t>]=dxx-dx/</a:t>
+            </a:r>
+            <a:r>
+              <a:rPr sz="3000" b="0" dirty="0" err="1">
+                <a:solidFill>
+                  <a:srgbClr val="1F1F1F"/>
+                </a:solidFill>
+                <a:latin typeface="Consolas"/>
+              </a:rPr>
+              <a:t>x+dyy</a:t>
+            </a:r>
+            <a:r>
+              <a:rPr sz="3000" b="0" dirty="0">
+                <a:solidFill>
+                  <a:srgbClr val="1F1F1F"/>
+                </a:solidFill>
+                <a:latin typeface="Consolas"/>
+              </a:rPr>
+              <a:t>-((1-A)*x*</a:t>
+            </a:r>
+            <a:r>
+              <a:rPr sz="3000" b="0" dirty="0" err="1">
+                <a:solidFill>
+                  <a:srgbClr val="1F1F1F"/>
+                </a:solidFill>
+                <a:latin typeface="Consolas"/>
+              </a:rPr>
+              <a:t>x+A</a:t>
+            </a:r>
+            <a:r>
+              <a:rPr sz="3000" b="0" dirty="0">
+                <a:solidFill>
+                  <a:srgbClr val="1F1F1F"/>
+                </a:solidFill>
+                <a:latin typeface="Consolas"/>
+              </a:rPr>
+              <a:t>);</a:t>
             </a:r>
           </a:p>
           <a:p>
@@ -3949,7 +5327,7 @@
               </a:spcAft>
             </a:pPr>
             <a:r>
-              <a:rPr sz="2300" b="0">
+              <a:rPr sz="3000" b="0" dirty="0">
                 <a:solidFill>
                   <a:srgbClr val="4A4A4A"/>
                 </a:solidFill>
@@ -3965,13 +5343,49 @@
               </a:spcAft>
             </a:pPr>
             <a:r>
-              <a:rPr sz="2300" b="0">
+              <a:rPr sz="3000" b="0" dirty="0">
                 <a:solidFill>
                   <a:srgbClr val="1F1F1F"/>
                 </a:solidFill>
                 <a:latin typeface="Consolas"/>
               </a:rPr>
-              <a:t>f[b]=u[b]-PsiExact(&amp;u,x,y);</a:t>
+              <a:t>f[b]=u[b]-</a:t>
+            </a:r>
+            <a:r>
+              <a:rPr sz="3000" b="0" dirty="0" err="1">
+                <a:solidFill>
+                  <a:srgbClr val="1F1F1F"/>
+                </a:solidFill>
+                <a:latin typeface="Consolas"/>
+              </a:rPr>
+              <a:t>PsiExact</a:t>
+            </a:r>
+            <a:r>
+              <a:rPr sz="3000" b="0" dirty="0">
+                <a:solidFill>
+                  <a:srgbClr val="1F1F1F"/>
+                </a:solidFill>
+                <a:latin typeface="Consolas"/>
+              </a:rPr>
+              <a:t>(&amp;</a:t>
+            </a:r>
+            <a:r>
+              <a:rPr sz="3000" b="0" dirty="0" err="1">
+                <a:solidFill>
+                  <a:srgbClr val="1F1F1F"/>
+                </a:solidFill>
+                <a:latin typeface="Consolas"/>
+              </a:rPr>
+              <a:t>u,x,y</a:t>
+            </a:r>
+            <a:r>
+              <a:rPr sz="3000" b="0" dirty="0">
+                <a:solidFill>
+                  <a:srgbClr val="1F1F1F"/>
+                </a:solidFill>
+                <a:latin typeface="Consolas"/>
+              </a:rPr>
+              <a:t>);</a:t>
             </a:r>
           </a:p>
           <a:p>
@@ -3981,13 +5395,40 @@
               </a:spcAft>
             </a:pPr>
             <a:r>
-              <a:rPr sz="2300" b="0">
+              <a:rPr sz="3000" b="0" dirty="0" err="1">
                 <a:solidFill>
                   <a:srgbClr val="1F1F1F"/>
                 </a:solidFill>
                 <a:latin typeface="Consolas"/>
               </a:rPr>
-              <a:t>SNESSetJacobian(snes,J,J,FormJacobian,&amp;u);</a:t>
+              <a:t>SNESSetJacobian</a:t>
+            </a:r>
+            <a:r>
+              <a:rPr sz="3000" b="0" dirty="0">
+                <a:solidFill>
+                  <a:srgbClr val="1F1F1F"/>
+                </a:solidFill>
+                <a:latin typeface="Consolas"/>
+              </a:rPr>
+              <a:t>(snes,J,J,</a:t>
+            </a:r>
+            <a:r>
+              <a:rPr sz="3000" b="0" dirty="0" err="1">
+                <a:solidFill>
+                  <a:srgbClr val="1F1F1F"/>
+                </a:solidFill>
+                <a:latin typeface="Consolas"/>
+              </a:rPr>
+              <a:t>FormJacobian</a:t>
+            </a:r>
+            <a:r>
+              <a:rPr sz="3000" b="0" dirty="0">
+                <a:solidFill>
+                  <a:srgbClr val="1F1F1F"/>
+                </a:solidFill>
+                <a:latin typeface="Consolas"/>
+              </a:rPr>
+              <a:t>,&amp;u);</a:t>
             </a:r>
           </a:p>
           <a:p>
@@ -3997,13 +5438,40 @@
               </a:spcAft>
             </a:pPr>
             <a:r>
-              <a:rPr sz="2300" b="0">
+              <a:rPr sz="3000" b="0" dirty="0" err="1">
                 <a:solidFill>
                   <a:srgbClr val="1F1F1F"/>
                 </a:solidFill>
                 <a:latin typeface="Consolas"/>
               </a:rPr>
-              <a:t>SNESSolve(snes,NULL,X);</a:t>
+              <a:t>SNESSolve</a:t>
+            </a:r>
+            <a:r>
+              <a:rPr sz="3000" b="0" dirty="0">
+                <a:solidFill>
+                  <a:srgbClr val="1F1F1F"/>
+                </a:solidFill>
+                <a:latin typeface="Consolas"/>
+              </a:rPr>
+              <a:t>(</a:t>
+            </a:r>
+            <a:r>
+              <a:rPr sz="3000" b="0" dirty="0" err="1">
+                <a:solidFill>
+                  <a:srgbClr val="1F1F1F"/>
+                </a:solidFill>
+                <a:latin typeface="Consolas"/>
+              </a:rPr>
+              <a:t>snes,NULL,X</a:t>
+            </a:r>
+            <a:r>
+              <a:rPr sz="3000" b="0" dirty="0">
+                <a:solidFill>
+                  <a:srgbClr val="1F1F1F"/>
+                </a:solidFill>
+                <a:latin typeface="Consolas"/>
+              </a:rPr>
+              <a:t>);</a:t>
             </a:r>
           </a:p>
         </p:txBody>
@@ -4019,7 +5487,7 @@
             <a:off x="28895039" y="17899380"/>
             <a:ext cx="13624560" cy="4896612"/>
           </a:xfrm>
-          <a:prstGeom prst="roundRect">
+          <a:prstGeom prst="rect">
             <a:avLst/>
           </a:prstGeom>
           <a:solidFill>
@@ -4051,6 +5519,7 @@
           <a:lstStyle/>
           <a:p>
             <a:pPr algn="ctr"/>
+            <a:endParaRPr/>
           </a:p>
         </p:txBody>
       </p:sp>
@@ -4091,104 +5560,652 @@
           </a:fontRef>
         </p:style>
         <p:txBody>
-          <a:bodyPr rtlCol="0" anchor="ctr" lIns="274320"/>
+          <a:bodyPr lIns="274320" rtlCol="0" anchor="ctr"/>
           <a:lstStyle/>
           <a:p>
             <a:pPr algn="ctr"/>
             <a:r>
+              <a:rPr sz="4000" b="1" dirty="0">
+                <a:solidFill>
+                  <a:srgbClr val="FFFFFF"/>
+                </a:solidFill>
+              </a:rPr>
+              <a:t>8</a:t>
+            </a:r>
+            <a:r>
+              <a:rPr lang="en-US" sz="4000" b="1" dirty="0">
+                <a:solidFill>
+                  <a:srgbClr val="FFFFFF"/>
+                </a:solidFill>
+              </a:rPr>
+              <a:t>.</a:t>
+            </a:r>
+            <a:r>
+              <a:rPr sz="4000" b="1" dirty="0">
+                <a:solidFill>
+                  <a:srgbClr val="FFFFFF"/>
+                </a:solidFill>
+              </a:rPr>
+              <a:t>  Safety </a:t>
+            </a:r>
+            <a:r>
               <a:rPr sz="4000" b="1">
                 <a:solidFill>
                   <a:srgbClr val="FFFFFF"/>
                 </a:solidFill>
               </a:rPr>
-              <a:t>8  Safety factor &amp; FreeGS cross-check</a:t>
-            </a:r>
-          </a:p>
-        </p:txBody>
-      </p:sp>
-      <p:sp>
-        <p:nvSpPr>
-          <p:cNvPr id="18" name="TextBox 17"/>
-          <p:cNvSpPr txBox="1"/>
-          <p:nvPr/>
-        </p:nvSpPr>
-        <p:spPr>
-          <a:xfrm>
-            <a:off x="29169360" y="19225260"/>
-            <a:ext cx="13075920" cy="3342132"/>
-          </a:xfrm>
-          <a:prstGeom prst="rect">
-            <a:avLst/>
-          </a:prstGeom>
-          <a:noFill/>
-        </p:spPr>
-        <p:txBody>
-          <a:bodyPr wrap="square" anchor="t">
-            <a:spAutoFit/>
-          </a:bodyPr>
-          <a:lstStyle/>
-          <a:p>
-            <a:pPr algn="l">
-              <a:spcAft>
-                <a:spcPts val="600"/>
-              </a:spcAft>
-            </a:pPr>
-            <a:r>
-              <a:rPr sz="3000" b="0">
-                <a:solidFill>
-                  <a:srgbClr val="1F1F1F"/>
-                </a:solidFill>
-              </a:rPr>
-              <a:t>Safety-factor q(ψ_N) computed from the verified flux surfaces:</a:t>
-            </a:r>
-          </a:p>
-          <a:p>
-            <a:pPr algn="l">
-              <a:spcAft>
-                <a:spcPts val="600"/>
-              </a:spcAft>
-            </a:pPr>
-            <a:r>
-              <a:rPr sz="3000" b="1">
-                <a:solidFill>
-                  <a:srgbClr val="007D8A"/>
-                </a:solidFill>
-              </a:rPr>
-              <a:t>ITER q95≈2.9 · NSTX q95≈12.4 · X-point q95≈3.2</a:t>
-            </a:r>
-          </a:p>
-          <a:p>
-            <a:pPr algn="l">
-              <a:spcAft>
-                <a:spcPts val="600"/>
-              </a:spcAft>
-            </a:pPr>
-            <a:r>
-              <a:rPr sz="3000" b="0">
-                <a:solidFill>
-                  <a:srgbClr val="1F1F1F"/>
-                </a:solidFill>
-              </a:rPr>
-              <a:t>Cross-checked vs FreeGS’s independent q on the SAME field → agree to &lt; 0.2%.</a:t>
-            </a:r>
-          </a:p>
-          <a:p>
-            <a:pPr algn="l">
-              <a:spcAft>
-                <a:spcPts val="600"/>
-              </a:spcAft>
-            </a:pPr>
-            <a:r>
-              <a:rPr sz="3000" b="0">
-                <a:solidFill>
-                  <a:srgbClr val="1F1F1F"/>
-                </a:solidFill>
-              </a:rPr>
-              <a:t>Measured κ, δ match the input shaping to ~1–2%.</a:t>
-            </a:r>
-          </a:p>
-        </p:txBody>
-      </p:sp>
+              <a:t>factor </a:t>
+            </a:r>
+            <a:r>
+              <a:rPr lang="en-US" sz="4000" b="1">
+                <a:solidFill>
+                  <a:srgbClr val="FFFFFF"/>
+                </a:solidFill>
+              </a:rPr>
+              <a:t>and</a:t>
+            </a:r>
+            <a:r>
+              <a:rPr sz="4000" b="1">
+                <a:solidFill>
+                  <a:srgbClr val="FFFFFF"/>
+                </a:solidFill>
+              </a:rPr>
+              <a:t> </a:t>
+            </a:r>
+            <a:r>
+              <a:rPr sz="4000" b="1" dirty="0" err="1">
+                <a:solidFill>
+                  <a:srgbClr val="FFFFFF"/>
+                </a:solidFill>
+              </a:rPr>
+              <a:t>FreeGS</a:t>
+            </a:r>
+            <a:r>
+              <a:rPr sz="4000" b="1" dirty="0">
+                <a:solidFill>
+                  <a:srgbClr val="FFFFFF"/>
+                </a:solidFill>
+              </a:rPr>
+              <a:t> cross-check</a:t>
+            </a:r>
+          </a:p>
+        </p:txBody>
+      </p:sp>
+      <mc:AlternateContent xmlns:mc="http://schemas.openxmlformats.org/markup-compatibility/2006">
+        <mc:Choice xmlns:a14="http://schemas.microsoft.com/office/drawing/2010/main" Requires="a14">
+          <p:sp>
+            <p:nvSpPr>
+              <p:cNvPr id="18" name="TextBox 17"/>
+              <p:cNvSpPr txBox="1"/>
+              <p:nvPr/>
+            </p:nvSpPr>
+            <p:spPr>
+              <a:xfrm>
+                <a:off x="29169360" y="19225260"/>
+                <a:ext cx="13075920" cy="3016210"/>
+              </a:xfrm>
+              <a:prstGeom prst="rect">
+                <a:avLst/>
+              </a:prstGeom>
+              <a:noFill/>
+            </p:spPr>
+            <p:txBody>
+              <a:bodyPr wrap="square" anchor="t">
+                <a:spAutoFit/>
+              </a:bodyPr>
+              <a:lstStyle/>
+              <a:p>
+                <a:pPr algn="l">
+                  <a:spcAft>
+                    <a:spcPts val="600"/>
+                  </a:spcAft>
+                </a:pPr>
+                <a:r>
+                  <a:rPr lang="en-US" sz="3500" b="0" dirty="0">
+                    <a:solidFill>
+                      <a:srgbClr val="1F1F1F"/>
+                    </a:solidFill>
+                  </a:rPr>
+                  <a:t>Safety-factor </a:t>
+                </a:r>
+                <a14:m>
+                  <m:oMath xmlns:m="http://schemas.openxmlformats.org/officeDocument/2006/math">
+                    <m:r>
+                      <a:rPr lang="en-US" sz="3500" b="0" i="1" dirty="0" smtClean="0">
+                        <a:solidFill>
+                          <a:srgbClr val="1F1F1F"/>
+                        </a:solidFill>
+                        <a:latin typeface="Cambria Math" panose="02040503050406030204" pitchFamily="18" charset="0"/>
+                      </a:rPr>
+                      <m:t>𝑞</m:t>
+                    </m:r>
+                    <m:r>
+                      <a:rPr lang="en-US" sz="3500" b="0" i="1" dirty="0" smtClean="0">
+                        <a:solidFill>
+                          <a:srgbClr val="1F1F1F"/>
+                        </a:solidFill>
+                        <a:latin typeface="Cambria Math" panose="02040503050406030204" pitchFamily="18" charset="0"/>
+                      </a:rPr>
+                      <m:t>(</m:t>
+                    </m:r>
+                    <m:sSub>
+                      <m:sSubPr>
+                        <m:ctrlPr>
+                          <a:rPr lang="ar-AE" sz="3500" b="0" i="1" dirty="0" err="1">
+                            <a:solidFill>
+                              <a:srgbClr val="1F1F1F"/>
+                            </a:solidFill>
+                            <a:latin typeface="Cambria Math" panose="02040503050406030204" pitchFamily="18" charset="0"/>
+                          </a:rPr>
+                        </m:ctrlPr>
+                      </m:sSubPr>
+                      <m:e>
+                        <m:r>
+                          <a:rPr lang="ar-AE" sz="3500" b="0" i="1" dirty="0" err="1">
+                            <a:solidFill>
+                              <a:srgbClr val="1F1F1F"/>
+                            </a:solidFill>
+                            <a:latin typeface="Cambria Math" panose="02040503050406030204" pitchFamily="18" charset="0"/>
+                          </a:rPr>
+                          <m:t>𝜓</m:t>
+                        </m:r>
+                      </m:e>
+                      <m:sub>
+                        <m:r>
+                          <a:rPr lang="ar-AE" sz="3500" b="0" i="1" dirty="0" err="1">
+                            <a:solidFill>
+                              <a:srgbClr val="1F1F1F"/>
+                            </a:solidFill>
+                            <a:latin typeface="Cambria Math" panose="02040503050406030204" pitchFamily="18" charset="0"/>
+                          </a:rPr>
+                          <m:t>𝑁</m:t>
+                        </m:r>
+                      </m:sub>
+                    </m:sSub>
+                    <m:r>
+                      <a:rPr lang="ar-AE" sz="3500" b="0" i="1" dirty="0">
+                        <a:solidFill>
+                          <a:srgbClr val="1F1F1F"/>
+                        </a:solidFill>
+                        <a:latin typeface="Cambria Math" panose="02040503050406030204" pitchFamily="18" charset="0"/>
+                      </a:rPr>
+                      <m:t>)</m:t>
+                    </m:r>
+                  </m:oMath>
+                </a14:m>
+                <a:r>
+                  <a:rPr lang="ar-AE" sz="3500" b="0" dirty="0">
+                    <a:solidFill>
+                      <a:srgbClr val="1F1F1F"/>
+                    </a:solidFill>
+                  </a:rPr>
+                  <a:t> </a:t>
+                </a:r>
+                <a:r>
+                  <a:rPr lang="en-US" sz="3500" b="0" dirty="0">
+                    <a:solidFill>
+                      <a:srgbClr val="1F1F1F"/>
+                    </a:solidFill>
+                  </a:rPr>
+                  <a:t>computed from the verified flux surfaces:</a:t>
+                </a:r>
+              </a:p>
+              <a:p>
+                <a:pPr algn="l">
+                  <a:spcAft>
+                    <a:spcPts val="600"/>
+                  </a:spcAft>
+                </a:pPr>
+                <a:r>
+                  <a:rPr lang="en-US" sz="3500" b="1" dirty="0">
+                    <a:solidFill>
+                      <a:srgbClr val="007D8A"/>
+                    </a:solidFill>
+                  </a:rPr>
+                  <a:t>ITER </a:t>
+                </a:r>
+                <a14:m>
+                  <m:oMath xmlns:m="http://schemas.openxmlformats.org/officeDocument/2006/math">
+                    <m:sSub>
+                      <m:sSubPr>
+                        <m:ctrlPr>
+                          <a:rPr lang="en-US" sz="3500" b="1" i="1" dirty="0" smtClean="0">
+                            <a:solidFill>
+                              <a:srgbClr val="007D8A"/>
+                            </a:solidFill>
+                            <a:latin typeface="Cambria Math" panose="02040503050406030204" pitchFamily="18" charset="0"/>
+                          </a:rPr>
+                        </m:ctrlPr>
+                      </m:sSubPr>
+                      <m:e>
+                        <m:r>
+                          <a:rPr lang="en-US" sz="3500" b="1" i="1" dirty="0" smtClean="0">
+                            <a:solidFill>
+                              <a:srgbClr val="007D8A"/>
+                            </a:solidFill>
+                            <a:latin typeface="Cambria Math" panose="02040503050406030204" pitchFamily="18" charset="0"/>
+                          </a:rPr>
+                          <m:t>𝒒</m:t>
+                        </m:r>
+                      </m:e>
+                      <m:sub>
+                        <m:r>
+                          <a:rPr lang="en-US" sz="3500" b="1" i="1" dirty="0" smtClean="0">
+                            <a:solidFill>
+                              <a:srgbClr val="007D8A"/>
+                            </a:solidFill>
+                            <a:latin typeface="Cambria Math" panose="02040503050406030204" pitchFamily="18" charset="0"/>
+                          </a:rPr>
+                          <m:t>𝟗𝟓</m:t>
+                        </m:r>
+                      </m:sub>
+                    </m:sSub>
+                    <m:r>
+                      <a:rPr lang="en-US" sz="3500" b="1" i="1" dirty="0" smtClean="0">
+                        <a:solidFill>
+                          <a:srgbClr val="007D8A"/>
+                        </a:solidFill>
+                        <a:latin typeface="Cambria Math" panose="02040503050406030204" pitchFamily="18" charset="0"/>
+                      </a:rPr>
+                      <m:t>≈</m:t>
+                    </m:r>
+                    <m:r>
+                      <a:rPr lang="en-US" sz="3500" b="1" i="1" dirty="0" smtClean="0">
+                        <a:solidFill>
+                          <a:srgbClr val="007D8A"/>
+                        </a:solidFill>
+                        <a:latin typeface="Cambria Math" panose="02040503050406030204" pitchFamily="18" charset="0"/>
+                      </a:rPr>
+                      <m:t>𝟐</m:t>
+                    </m:r>
+                    <m:r>
+                      <a:rPr lang="en-US" sz="3500" b="1" i="1" dirty="0" smtClean="0">
+                        <a:solidFill>
+                          <a:srgbClr val="007D8A"/>
+                        </a:solidFill>
+                        <a:latin typeface="Cambria Math" panose="02040503050406030204" pitchFamily="18" charset="0"/>
+                      </a:rPr>
+                      <m:t>.</m:t>
+                    </m:r>
+                    <m:r>
+                      <a:rPr lang="en-US" sz="3500" b="1" i="1" dirty="0" smtClean="0">
+                        <a:solidFill>
+                          <a:srgbClr val="007D8A"/>
+                        </a:solidFill>
+                        <a:latin typeface="Cambria Math" panose="02040503050406030204" pitchFamily="18" charset="0"/>
+                      </a:rPr>
+                      <m:t>𝟗</m:t>
+                    </m:r>
+                    <m:r>
+                      <a:rPr lang="en-US" sz="3500" b="1" i="1" dirty="0" smtClean="0">
+                        <a:solidFill>
+                          <a:srgbClr val="007D8A"/>
+                        </a:solidFill>
+                        <a:latin typeface="Cambria Math" panose="02040503050406030204" pitchFamily="18" charset="0"/>
+                      </a:rPr>
+                      <m:t> </m:t>
+                    </m:r>
+                  </m:oMath>
+                </a14:m>
+                <a:r>
+                  <a:rPr lang="en-US" sz="3500" b="1" dirty="0">
+                    <a:solidFill>
+                      <a:srgbClr val="007D8A"/>
+                    </a:solidFill>
+                  </a:rPr>
+                  <a:t> ·  NSTX </a:t>
+                </a:r>
+                <a14:m>
+                  <m:oMath xmlns:m="http://schemas.openxmlformats.org/officeDocument/2006/math">
+                    <m:sSub>
+                      <m:sSubPr>
+                        <m:ctrlPr>
+                          <a:rPr lang="en-US" sz="3500" b="1" i="1" dirty="0" smtClean="0">
+                            <a:solidFill>
+                              <a:srgbClr val="007D8A"/>
+                            </a:solidFill>
+                            <a:latin typeface="Cambria Math" panose="02040503050406030204" pitchFamily="18" charset="0"/>
+                          </a:rPr>
+                        </m:ctrlPr>
+                      </m:sSubPr>
+                      <m:e>
+                        <m:r>
+                          <a:rPr lang="en-US" sz="3500" b="1" i="1" dirty="0" smtClean="0">
+                            <a:solidFill>
+                              <a:srgbClr val="007D8A"/>
+                            </a:solidFill>
+                            <a:latin typeface="Cambria Math" panose="02040503050406030204" pitchFamily="18" charset="0"/>
+                          </a:rPr>
+                          <m:t>𝒒</m:t>
+                        </m:r>
+                      </m:e>
+                      <m:sub>
+                        <m:r>
+                          <a:rPr lang="en-US" sz="3500" b="1" i="1" dirty="0" smtClean="0">
+                            <a:solidFill>
+                              <a:srgbClr val="007D8A"/>
+                            </a:solidFill>
+                            <a:latin typeface="Cambria Math" panose="02040503050406030204" pitchFamily="18" charset="0"/>
+                          </a:rPr>
+                          <m:t>𝟗𝟓</m:t>
+                        </m:r>
+                      </m:sub>
+                    </m:sSub>
+                    <m:r>
+                      <a:rPr lang="en-US" sz="3500" b="1" i="1" dirty="0" smtClean="0">
+                        <a:solidFill>
+                          <a:srgbClr val="007D8A"/>
+                        </a:solidFill>
+                        <a:latin typeface="Cambria Math" panose="02040503050406030204" pitchFamily="18" charset="0"/>
+                      </a:rPr>
+                      <m:t>≈</m:t>
+                    </m:r>
+                    <m:r>
+                      <a:rPr lang="en-US" sz="3500" b="1" i="1" dirty="0" smtClean="0">
+                        <a:solidFill>
+                          <a:srgbClr val="007D8A"/>
+                        </a:solidFill>
+                        <a:latin typeface="Cambria Math" panose="02040503050406030204" pitchFamily="18" charset="0"/>
+                      </a:rPr>
+                      <m:t>𝟏𝟐</m:t>
+                    </m:r>
+                    <m:r>
+                      <a:rPr lang="en-US" sz="3500" b="1" i="1" dirty="0" smtClean="0">
+                        <a:solidFill>
+                          <a:srgbClr val="007D8A"/>
+                        </a:solidFill>
+                        <a:latin typeface="Cambria Math" panose="02040503050406030204" pitchFamily="18" charset="0"/>
+                      </a:rPr>
+                      <m:t>.</m:t>
+                    </m:r>
+                    <m:r>
+                      <a:rPr lang="en-US" sz="3500" b="1" i="1" dirty="0" smtClean="0">
+                        <a:solidFill>
+                          <a:srgbClr val="007D8A"/>
+                        </a:solidFill>
+                        <a:latin typeface="Cambria Math" panose="02040503050406030204" pitchFamily="18" charset="0"/>
+                      </a:rPr>
+                      <m:t>𝟒</m:t>
+                    </m:r>
+                    <m:r>
+                      <a:rPr lang="en-US" sz="3500" b="1" i="1" dirty="0" smtClean="0">
+                        <a:solidFill>
+                          <a:srgbClr val="007D8A"/>
+                        </a:solidFill>
+                        <a:latin typeface="Cambria Math" panose="02040503050406030204" pitchFamily="18" charset="0"/>
+                      </a:rPr>
+                      <m:t> </m:t>
+                    </m:r>
+                  </m:oMath>
+                </a14:m>
+                <a:r>
+                  <a:rPr lang="en-US" sz="3500" b="1" dirty="0">
+                    <a:solidFill>
+                      <a:srgbClr val="007D8A"/>
+                    </a:solidFill>
+                  </a:rPr>
+                  <a:t> ·  X-point </a:t>
+                </a:r>
+                <a14:m>
+                  <m:oMath xmlns:m="http://schemas.openxmlformats.org/officeDocument/2006/math">
+                    <m:sSub>
+                      <m:sSubPr>
+                        <m:ctrlPr>
+                          <a:rPr lang="en-US" sz="3500" b="1" i="1" dirty="0" smtClean="0">
+                            <a:solidFill>
+                              <a:srgbClr val="007D8A"/>
+                            </a:solidFill>
+                            <a:latin typeface="Cambria Math" panose="02040503050406030204" pitchFamily="18" charset="0"/>
+                          </a:rPr>
+                        </m:ctrlPr>
+                      </m:sSubPr>
+                      <m:e>
+                        <m:r>
+                          <a:rPr lang="en-US" sz="3500" b="1" i="1" dirty="0" smtClean="0">
+                            <a:solidFill>
+                              <a:srgbClr val="007D8A"/>
+                            </a:solidFill>
+                            <a:latin typeface="Cambria Math" panose="02040503050406030204" pitchFamily="18" charset="0"/>
+                          </a:rPr>
+                          <m:t>𝒒</m:t>
+                        </m:r>
+                      </m:e>
+                      <m:sub>
+                        <m:r>
+                          <a:rPr lang="en-US" sz="3500" b="1" i="1" dirty="0" smtClean="0">
+                            <a:solidFill>
+                              <a:srgbClr val="007D8A"/>
+                            </a:solidFill>
+                            <a:latin typeface="Cambria Math" panose="02040503050406030204" pitchFamily="18" charset="0"/>
+                          </a:rPr>
+                          <m:t>𝟗𝟓</m:t>
+                        </m:r>
+                      </m:sub>
+                    </m:sSub>
+                    <m:r>
+                      <a:rPr lang="en-US" sz="3500" b="1" i="1" dirty="0" smtClean="0">
+                        <a:solidFill>
+                          <a:srgbClr val="007D8A"/>
+                        </a:solidFill>
+                        <a:latin typeface="Cambria Math" panose="02040503050406030204" pitchFamily="18" charset="0"/>
+                      </a:rPr>
+                      <m:t>≈</m:t>
+                    </m:r>
+                    <m:r>
+                      <a:rPr lang="en-US" sz="3500" b="1" i="1" dirty="0" smtClean="0">
+                        <a:solidFill>
+                          <a:srgbClr val="007D8A"/>
+                        </a:solidFill>
+                        <a:latin typeface="Cambria Math" panose="02040503050406030204" pitchFamily="18" charset="0"/>
+                      </a:rPr>
+                      <m:t>𝟑</m:t>
+                    </m:r>
+                    <m:r>
+                      <a:rPr lang="en-US" sz="3500" b="1" i="1" dirty="0" smtClean="0">
+                        <a:solidFill>
+                          <a:srgbClr val="007D8A"/>
+                        </a:solidFill>
+                        <a:latin typeface="Cambria Math" panose="02040503050406030204" pitchFamily="18" charset="0"/>
+                      </a:rPr>
+                      <m:t>.</m:t>
+                    </m:r>
+                    <m:r>
+                      <a:rPr lang="en-US" sz="3500" b="1" i="1" dirty="0" smtClean="0">
+                        <a:solidFill>
+                          <a:srgbClr val="007D8A"/>
+                        </a:solidFill>
+                        <a:latin typeface="Cambria Math" panose="02040503050406030204" pitchFamily="18" charset="0"/>
+                      </a:rPr>
+                      <m:t>𝟐</m:t>
+                    </m:r>
+                  </m:oMath>
+                </a14:m>
+                <a:endParaRPr lang="en-US" sz="3500" b="1" dirty="0">
+                  <a:solidFill>
+                    <a:srgbClr val="007D8A"/>
+                  </a:solidFill>
+                </a:endParaRPr>
+              </a:p>
+              <a:p>
+                <a:pPr algn="l">
+                  <a:spcAft>
+                    <a:spcPts val="600"/>
+                  </a:spcAft>
+                </a:pPr>
+                <a:r>
+                  <a:rPr lang="en-US" sz="3500" b="0" dirty="0">
+                    <a:solidFill>
+                      <a:srgbClr val="1F1F1F"/>
+                    </a:solidFill>
+                  </a:rPr>
+                  <a:t>Cross-checked vs </a:t>
+                </a:r>
+                <a:r>
+                  <a:rPr lang="en-US" sz="3500" b="0" dirty="0" err="1">
+                    <a:solidFill>
+                      <a:srgbClr val="1F1F1F"/>
+                    </a:solidFill>
+                  </a:rPr>
+                  <a:t>FreeGS’s</a:t>
+                </a:r>
+                <a:r>
+                  <a:rPr lang="en-US" sz="3500" b="0" dirty="0">
+                    <a:solidFill>
+                      <a:srgbClr val="1F1F1F"/>
+                    </a:solidFill>
+                  </a:rPr>
+                  <a:t> independent </a:t>
+                </a:r>
+                <a14:m>
+                  <m:oMath xmlns:m="http://schemas.openxmlformats.org/officeDocument/2006/math">
+                    <m:r>
+                      <a:rPr lang="en-US" sz="3500" b="0" i="1" dirty="0" smtClean="0">
+                        <a:solidFill>
+                          <a:srgbClr val="1F1F1F"/>
+                        </a:solidFill>
+                        <a:latin typeface="Cambria Math" panose="02040503050406030204" pitchFamily="18" charset="0"/>
+                      </a:rPr>
+                      <m:t>𝑞</m:t>
+                    </m:r>
+                  </m:oMath>
+                </a14:m>
+                <a:r>
+                  <a:rPr lang="en-US" sz="3500" b="0" dirty="0">
+                    <a:solidFill>
+                      <a:srgbClr val="1F1F1F"/>
+                    </a:solidFill>
+                  </a:rPr>
+                  <a:t> on the SAME field → agree to less than 0.2 %.</a:t>
+                </a:r>
+              </a:p>
+              <a:p>
+                <a:pPr algn="l">
+                  <a:spcAft>
+                    <a:spcPts val="600"/>
+                  </a:spcAft>
+                </a:pPr>
+                <a:r>
+                  <a:rPr lang="en-US" sz="3500" b="0" dirty="0">
+                    <a:solidFill>
+                      <a:srgbClr val="1F1F1F"/>
+                    </a:solidFill>
+                  </a:rPr>
+                  <a:t>Measured </a:t>
+                </a:r>
+                <a14:m>
+                  <m:oMath xmlns:m="http://schemas.openxmlformats.org/officeDocument/2006/math">
+                    <m:r>
+                      <a:rPr lang="el-GR" sz="3500" b="0" i="1" dirty="0" smtClean="0">
+                        <a:solidFill>
+                          <a:srgbClr val="1F1F1F"/>
+                        </a:solidFill>
+                        <a:latin typeface="Cambria Math" panose="02040503050406030204" pitchFamily="18" charset="0"/>
+                      </a:rPr>
+                      <m:t>𝜅</m:t>
+                    </m:r>
+                  </m:oMath>
+                </a14:m>
+                <a:r>
+                  <a:rPr lang="el-GR" sz="3500" b="0" dirty="0">
+                    <a:solidFill>
+                      <a:srgbClr val="1F1F1F"/>
+                    </a:solidFill>
+                  </a:rPr>
+                  <a:t>, </a:t>
+                </a:r>
+                <a14:m>
+                  <m:oMath xmlns:m="http://schemas.openxmlformats.org/officeDocument/2006/math">
+                    <m:r>
+                      <a:rPr lang="el-GR" sz="3500" b="0" i="1" dirty="0" smtClean="0">
+                        <a:solidFill>
+                          <a:srgbClr val="1F1F1F"/>
+                        </a:solidFill>
+                        <a:latin typeface="Cambria Math" panose="02040503050406030204" pitchFamily="18" charset="0"/>
+                      </a:rPr>
+                      <m:t>𝛿</m:t>
+                    </m:r>
+                  </m:oMath>
+                </a14:m>
+                <a:r>
+                  <a:rPr lang="el-GR" sz="3500" b="0" dirty="0">
+                    <a:solidFill>
+                      <a:srgbClr val="1F1F1F"/>
+                    </a:solidFill>
+                  </a:rPr>
+                  <a:t> </a:t>
+                </a:r>
+                <a:r>
+                  <a:rPr lang="en-US" sz="3500" b="0" dirty="0">
+                    <a:solidFill>
+                      <a:srgbClr val="1F1F1F"/>
+                    </a:solidFill>
+                  </a:rPr>
+                  <a:t>match the input shaping to </a:t>
+                </a:r>
+                <a:r>
+                  <a:rPr lang="en-US" sz="3500" dirty="0">
+                    <a:solidFill>
+                      <a:srgbClr val="1F1F1F"/>
+                    </a:solidFill>
+                  </a:rPr>
+                  <a:t>around </a:t>
+                </a:r>
+                <a:r>
+                  <a:rPr lang="en-US" sz="3500" b="0" dirty="0">
+                    <a:solidFill>
+                      <a:srgbClr val="1F1F1F"/>
+                    </a:solidFill>
+                  </a:rPr>
+                  <a:t>1 to 2 %.</a:t>
+                </a:r>
+                <a:endParaRPr sz="3500" b="0" dirty="0">
+                  <a:solidFill>
+                    <a:srgbClr val="1F1F1F"/>
+                  </a:solidFill>
+                </a:endParaRPr>
+              </a:p>
+            </p:txBody>
+          </p:sp>
+        </mc:Choice>
+        <mc:Fallback>
+          <p:sp>
+            <p:nvSpPr>
+              <p:cNvPr id="18" name="TextBox 17"/>
+              <p:cNvSpPr txBox="1">
+                <a:spLocks noRot="1" noChangeAspect="1" noMove="1" noResize="1" noEditPoints="1" noAdjustHandles="1" noChangeArrowheads="1" noChangeShapeType="1" noTextEdit="1"/>
+              </p:cNvSpPr>
+              <p:nvPr/>
+            </p:nvSpPr>
+            <p:spPr>
+              <a:xfrm>
+                <a:off x="29169360" y="19225260"/>
+                <a:ext cx="13075920" cy="3016210"/>
+              </a:xfrm>
+              <a:prstGeom prst="rect">
+                <a:avLst/>
+              </a:prstGeom>
+              <a:blipFill>
+                <a:blip r:embed="rId3"/>
+                <a:stretch>
+                  <a:fillRect l="-1352" t="-3636" r="-1911" b="-6667"/>
+                </a:stretch>
+              </a:blipFill>
+            </p:spPr>
+            <p:txBody>
+              <a:bodyPr/>
+              <a:lstStyle/>
+              <a:p>
+                <a:r>
+                  <a:rPr lang="en-US">
+                    <a:noFill/>
+                  </a:rPr>
+                  <a:t> </a:t>
+                </a:r>
+              </a:p>
+            </p:txBody>
+          </p:sp>
+        </mc:Fallback>
+      </mc:AlternateContent>
       <p:sp>
         <p:nvSpPr>
           <p:cNvPr id="19" name="Rounded Rectangle 18"/>
@@ -4200,7 +6217,7 @@
             <a:off x="28895039" y="23801832"/>
             <a:ext cx="13624560" cy="6464808"/>
           </a:xfrm>
-          <a:prstGeom prst="roundRect">
+          <a:prstGeom prst="rect">
             <a:avLst/>
           </a:prstGeom>
           <a:solidFill>
@@ -4232,6 +6249,7 @@
           <a:lstStyle/>
           <a:p>
             <a:pPr algn="ctr"/>
+            <a:endParaRPr/>
           </a:p>
         </p:txBody>
       </p:sp>
@@ -4272,119 +6290,322 @@
           </a:fontRef>
         </p:style>
         <p:txBody>
-          <a:bodyPr rtlCol="0" anchor="ctr" lIns="274320"/>
+          <a:bodyPr lIns="274320" rtlCol="0" anchor="ctr"/>
           <a:lstStyle/>
           <a:p>
             <a:pPr algn="ctr"/>
             <a:r>
-              <a:rPr sz="4000" b="1">
+              <a:rPr sz="4000" b="1" dirty="0">
                 <a:solidFill>
                   <a:srgbClr val="FFFFFF"/>
                 </a:solidFill>
               </a:rPr>
-              <a:t>9  Results &amp; conclusions</a:t>
-            </a:r>
-          </a:p>
-        </p:txBody>
-      </p:sp>
-      <p:sp>
-        <p:nvSpPr>
-          <p:cNvPr id="21" name="TextBox 20"/>
-          <p:cNvSpPr txBox="1"/>
-          <p:nvPr/>
-        </p:nvSpPr>
-        <p:spPr>
-          <a:xfrm>
-            <a:off x="29169360" y="25127712"/>
-            <a:ext cx="13075920" cy="4910328"/>
-          </a:xfrm>
-          <a:prstGeom prst="rect">
-            <a:avLst/>
-          </a:prstGeom>
-          <a:noFill/>
-        </p:spPr>
-        <p:txBody>
-          <a:bodyPr wrap="square" anchor="t">
-            <a:spAutoFit/>
-          </a:bodyPr>
-          <a:lstStyle/>
-          <a:p>
-            <a:pPr algn="l">
-              <a:spcAft>
-                <a:spcPts val="600"/>
-              </a:spcAft>
-            </a:pPr>
-            <a:r>
-              <a:rPr sz="3000" b="0">
-                <a:solidFill>
-                  <a:srgbClr val="1F1F1F"/>
-                </a:solidFill>
-              </a:rPr>
-              <a:t>One 252-line solver, 0 hand-written, verified on 3 real-machine equilibria.</a:t>
-            </a:r>
-          </a:p>
-          <a:p>
-            <a:pPr algn="l">
-              <a:spcAft>
-                <a:spcPts val="600"/>
-              </a:spcAft>
-            </a:pPr>
-            <a:r>
-              <a:rPr sz="3000" b="0">
-                <a:solidFill>
-                  <a:srgbClr val="1F1F1F"/>
-                </a:solidFill>
-              </a:rPr>
-              <a:t>2nd-order accurate (p = 2.00) on every case; runs on 1 &amp; 4 MPI ranks.</a:t>
-            </a:r>
-          </a:p>
-          <a:p>
-            <a:pPr algn="l">
-              <a:spcAft>
-                <a:spcPts val="600"/>
-              </a:spcAft>
-            </a:pPr>
-            <a:r>
-              <a:rPr sz="3000" b="0">
-                <a:solidFill>
-                  <a:srgbClr val="1F1F1F"/>
-                </a:solidFill>
-              </a:rPr>
-              <a:t>Efficiency: ~311.4 s wall-clock; ~27 LLM completions.</a:t>
-            </a:r>
-          </a:p>
-          <a:p>
-            <a:pPr algn="l">
-              <a:spcAft>
-                <a:spcPts val="600"/>
-              </a:spcAft>
-            </a:pPr>
-            <a:r>
-              <a:rPr sz="3000" b="0">
-                <a:solidFill>
-                  <a:srgbClr val="1F1F1F"/>
-                </a:solidFill>
-              </a:rPr>
-              <a:t>Verification-driven: exact-solution convergence + independent q cross-check.</a:t>
-            </a:r>
-          </a:p>
-          <a:p>
-            <a:pPr algn="l">
-              <a:spcAft>
-                <a:spcPts val="600"/>
-              </a:spcAft>
-            </a:pPr>
-            <a:r>
-              <a:rPr sz="2700" b="0">
-                <a:solidFill>
-                  <a:srgbClr val="007D8A"/>
-                </a:solidFill>
-              </a:rPr>
-              <a:t>github.com/engineer-scientist/petsc_mcp_servers_tokamak</a:t>
-            </a:r>
-          </a:p>
-        </p:txBody>
-      </p:sp>
+              <a:t>9</a:t>
+            </a:r>
+            <a:r>
+              <a:rPr lang="en-US" sz="4000" b="1" dirty="0">
+                <a:solidFill>
+                  <a:srgbClr val="FFFFFF"/>
+                </a:solidFill>
+              </a:rPr>
+              <a:t>.</a:t>
+            </a:r>
+            <a:r>
+              <a:rPr sz="4000" b="1" dirty="0">
+                <a:solidFill>
+                  <a:srgbClr val="FFFFFF"/>
+                </a:solidFill>
+              </a:rPr>
+              <a:t>  Results </a:t>
+            </a:r>
+            <a:r>
+              <a:rPr lang="en-US" sz="4000" b="1" dirty="0">
+                <a:solidFill>
+                  <a:srgbClr val="FFFFFF"/>
+                </a:solidFill>
+              </a:rPr>
+              <a:t>and</a:t>
+            </a:r>
+            <a:r>
+              <a:rPr sz="4000" b="1" dirty="0">
+                <a:solidFill>
+                  <a:srgbClr val="FFFFFF"/>
+                </a:solidFill>
+              </a:rPr>
+              <a:t> conclusions</a:t>
+            </a:r>
+          </a:p>
+        </p:txBody>
+      </p:sp>
+      <mc:AlternateContent xmlns:mc="http://schemas.openxmlformats.org/markup-compatibility/2006">
+        <mc:Choice xmlns:a14="http://schemas.microsoft.com/office/drawing/2010/main" Requires="a14">
+          <p:sp>
+            <p:nvSpPr>
+              <p:cNvPr id="21" name="TextBox 20"/>
+              <p:cNvSpPr txBox="1"/>
+              <p:nvPr/>
+            </p:nvSpPr>
+            <p:spPr>
+              <a:xfrm>
+                <a:off x="29169360" y="25127712"/>
+                <a:ext cx="13075920" cy="4708981"/>
+              </a:xfrm>
+              <a:prstGeom prst="rect">
+                <a:avLst/>
+              </a:prstGeom>
+              <a:noFill/>
+            </p:spPr>
+            <p:txBody>
+              <a:bodyPr wrap="square" anchor="t">
+                <a:spAutoFit/>
+              </a:bodyPr>
+              <a:lstStyle/>
+              <a:p>
+                <a:pPr algn="l">
+                  <a:spcAft>
+                    <a:spcPts val="600"/>
+                  </a:spcAft>
+                </a:pPr>
+                <a:r>
+                  <a:rPr sz="3500" b="0" dirty="0">
+                    <a:solidFill>
+                      <a:srgbClr val="1F1F1F"/>
+                    </a:solidFill>
+                  </a:rPr>
+                  <a:t>One 252-line solver, 0 hand-written, verified on 3 real-machine equilibria.</a:t>
+                </a:r>
+              </a:p>
+              <a:p>
+                <a:pPr algn="l">
+                  <a:spcAft>
+                    <a:spcPts val="600"/>
+                  </a:spcAft>
+                </a:pPr>
+                <a:r>
+                  <a:rPr lang="en-US" sz="3500" dirty="0">
+                    <a:solidFill>
+                      <a:srgbClr val="1F1F1F"/>
+                    </a:solidFill>
+                  </a:rPr>
+                  <a:t>Second</a:t>
+                </a:r>
+                <a:r>
+                  <a:rPr sz="3500" b="0" dirty="0">
+                    <a:solidFill>
+                      <a:srgbClr val="1F1F1F"/>
+                    </a:solidFill>
+                  </a:rPr>
+                  <a:t>-order accurate </a:t>
+                </a:r>
+                <a14:m>
+                  <m:oMath xmlns:m="http://schemas.openxmlformats.org/officeDocument/2006/math">
+                    <m:r>
+                      <a:rPr lang="en-US" sz="3500" b="0" i="1" dirty="0" smtClean="0">
+                        <a:solidFill>
+                          <a:srgbClr val="1F1F1F"/>
+                        </a:solidFill>
+                        <a:latin typeface="Cambria Math" panose="02040503050406030204" pitchFamily="18" charset="0"/>
+                      </a:rPr>
+                      <m:t>(</m:t>
+                    </m:r>
+                    <m:r>
+                      <a:rPr lang="en-US" sz="3500" b="0" i="1" dirty="0" smtClean="0">
+                        <a:solidFill>
+                          <a:srgbClr val="1F1F1F"/>
+                        </a:solidFill>
+                        <a:latin typeface="Cambria Math" panose="02040503050406030204" pitchFamily="18" charset="0"/>
+                      </a:rPr>
+                      <m:t>𝑝</m:t>
+                    </m:r>
+                    <m:r>
+                      <a:rPr lang="en-US" sz="3500" b="0" i="1" dirty="0" smtClean="0">
+                        <a:solidFill>
+                          <a:srgbClr val="1F1F1F"/>
+                        </a:solidFill>
+                        <a:latin typeface="Cambria Math" panose="02040503050406030204" pitchFamily="18" charset="0"/>
+                      </a:rPr>
+                      <m:t>=2.00) </m:t>
+                    </m:r>
+                  </m:oMath>
+                </a14:m>
+                <a:r>
+                  <a:rPr sz="3500" b="0" dirty="0">
+                    <a:solidFill>
+                      <a:srgbClr val="1F1F1F"/>
+                    </a:solidFill>
+                  </a:rPr>
+                  <a:t>on every case; runs on 1 </a:t>
+                </a:r>
+                <a:r>
+                  <a:rPr lang="en-US" sz="3500" b="0" dirty="0">
+                    <a:solidFill>
+                      <a:srgbClr val="1F1F1F"/>
+                    </a:solidFill>
+                  </a:rPr>
+                  <a:t>and</a:t>
+                </a:r>
+                <a:r>
+                  <a:rPr sz="3500" b="0" dirty="0">
+                    <a:solidFill>
+                      <a:srgbClr val="1F1F1F"/>
+                    </a:solidFill>
+                  </a:rPr>
+                  <a:t> 4 MPI ranks.</a:t>
+                </a:r>
+              </a:p>
+              <a:p>
+                <a:pPr>
+                  <a:spcAft>
+                    <a:spcPts val="600"/>
+                  </a:spcAft>
+                </a:pPr>
+                <a:r>
+                  <a:rPr sz="3500" b="0" dirty="0">
+                    <a:solidFill>
+                      <a:srgbClr val="1F1F1F"/>
+                    </a:solidFill>
+                  </a:rPr>
+                  <a:t>Efficiency: </a:t>
+                </a:r>
+                <a:r>
+                  <a:rPr lang="en-US" sz="3500" dirty="0">
+                    <a:solidFill>
+                      <a:srgbClr val="1F1F1F"/>
+                    </a:solidFill>
+                  </a:rPr>
+                  <a:t>wall-clock time of </a:t>
+                </a:r>
+                <a:r>
+                  <a:rPr sz="3500" b="0" dirty="0">
+                    <a:solidFill>
+                      <a:srgbClr val="1F1F1F"/>
+                    </a:solidFill>
+                  </a:rPr>
+                  <a:t>311.4 s; </a:t>
+                </a:r>
+                <a:r>
+                  <a:rPr lang="en-US" sz="3500" dirty="0">
+                    <a:solidFill>
+                      <a:srgbClr val="1F1F1F"/>
+                    </a:solidFill>
+                  </a:rPr>
+                  <a:t>around </a:t>
+                </a:r>
+                <a:r>
+                  <a:rPr sz="3500" b="0" dirty="0">
+                    <a:solidFill>
+                      <a:srgbClr val="1F1F1F"/>
+                    </a:solidFill>
+                  </a:rPr>
+                  <a:t>27 LLM completions.</a:t>
+                </a:r>
+              </a:p>
+              <a:p>
+                <a:pPr algn="l">
+                  <a:spcAft>
+                    <a:spcPts val="600"/>
+                  </a:spcAft>
+                </a:pPr>
+                <a:r>
+                  <a:rPr sz="3500" b="0" dirty="0">
+                    <a:solidFill>
+                      <a:srgbClr val="1F1F1F"/>
+                    </a:solidFill>
+                  </a:rPr>
+                  <a:t>Verification-driven: exact-solution convergence + independent </a:t>
+                </a:r>
+                <a14:m>
+                  <m:oMath xmlns:m="http://schemas.openxmlformats.org/officeDocument/2006/math">
+                    <m:r>
+                      <a:rPr lang="en-US" sz="3500" b="0" i="1" dirty="0" smtClean="0">
+                        <a:solidFill>
+                          <a:srgbClr val="1F1F1F"/>
+                        </a:solidFill>
+                        <a:latin typeface="Cambria Math" panose="02040503050406030204" pitchFamily="18" charset="0"/>
+                      </a:rPr>
+                      <m:t>𝑞</m:t>
+                    </m:r>
+                  </m:oMath>
+                </a14:m>
+                <a:r>
+                  <a:rPr sz="3500" b="0" dirty="0">
+                    <a:solidFill>
+                      <a:srgbClr val="1F1F1F"/>
+                    </a:solidFill>
+                  </a:rPr>
+                  <a:t> cross-check.</a:t>
+                </a:r>
+              </a:p>
+              <a:p>
+                <a:pPr algn="l">
+                  <a:spcAft>
+                    <a:spcPts val="600"/>
+                  </a:spcAft>
+                </a:pPr>
+                <a:r>
+                  <a:rPr sz="3500" b="0" dirty="0">
+                    <a:solidFill>
+                      <a:srgbClr val="007D8A"/>
+                    </a:solidFill>
+                  </a:rPr>
+                  <a:t>github.com/engineer-scientist/</a:t>
+                </a:r>
+                <a:r>
+                  <a:rPr sz="3500" b="0" dirty="0" err="1">
+                    <a:solidFill>
+                      <a:srgbClr val="007D8A"/>
+                    </a:solidFill>
+                  </a:rPr>
+                  <a:t>petsc_mcp_servers_tokamak</a:t>
+                </a:r>
+                <a:endParaRPr sz="3500" b="0" dirty="0">
+                  <a:solidFill>
+                    <a:srgbClr val="007D8A"/>
+                  </a:solidFill>
+                </a:endParaRPr>
+              </a:p>
+            </p:txBody>
+          </p:sp>
+        </mc:Choice>
+        <mc:Fallback>
+          <p:sp>
+            <p:nvSpPr>
+              <p:cNvPr id="21" name="TextBox 20"/>
+              <p:cNvSpPr txBox="1">
+                <a:spLocks noRot="1" noChangeAspect="1" noMove="1" noResize="1" noEditPoints="1" noAdjustHandles="1" noChangeArrowheads="1" noChangeShapeType="1" noTextEdit="1"/>
+              </p:cNvSpPr>
+              <p:nvPr/>
+            </p:nvSpPr>
+            <p:spPr>
+              <a:xfrm>
+                <a:off x="29169360" y="25127712"/>
+                <a:ext cx="13075920" cy="4708981"/>
+              </a:xfrm>
+              <a:prstGeom prst="rect">
+                <a:avLst/>
+              </a:prstGeom>
+              <a:blipFill>
+                <a:blip r:embed="rId4"/>
+                <a:stretch>
+                  <a:fillRect l="-1352" t="-1943" r="-47" b="-4016"/>
+                </a:stretch>
+              </a:blipFill>
+            </p:spPr>
+            <p:txBody>
+              <a:bodyPr/>
+              <a:lstStyle/>
+              <a:p>
+                <a:r>
+                  <a:rPr lang="en-US">
+                    <a:noFill/>
+                  </a:rPr>
+                  <a:t> </a:t>
+                </a:r>
+              </a:p>
+            </p:txBody>
+          </p:sp>
+        </mc:Fallback>
+      </mc:AlternateContent>
       <p:sp>
         <p:nvSpPr>
           <p:cNvPr id="22" name="Rounded Rectangle 21"/>
@@ -4396,7 +6617,7 @@
             <a:off x="640080" y="17636852"/>
             <a:ext cx="13624560" cy="12629787"/>
           </a:xfrm>
-          <a:prstGeom prst="roundRect">
+          <a:prstGeom prst="rect">
             <a:avLst/>
           </a:prstGeom>
           <a:solidFill>
@@ -4428,6 +6649,7 @@
           <a:lstStyle/>
           <a:p>
             <a:pPr algn="ctr"/>
+            <a:endParaRPr/>
           </a:p>
         </p:txBody>
       </p:sp>
@@ -4468,18 +6690,79 @@
           </a:fontRef>
         </p:style>
         <p:txBody>
-          <a:bodyPr rtlCol="0" anchor="ctr" lIns="274320"/>
+          <a:bodyPr lIns="274320" rtlCol="0" anchor="ctr"/>
           <a:lstStyle/>
           <a:p>
             <a:pPr algn="ctr"/>
             <a:r>
-              <a:rPr sz="4000" b="1">
+              <a:rPr sz="4000" b="1" dirty="0">
                 <a:solidFill>
                   <a:srgbClr val="FFFFFF"/>
                 </a:solidFill>
               </a:rPr>
-              <a:t>3  The multi-agent system</a:t>
-            </a:r>
+              <a:t>3</a:t>
+            </a:r>
+            <a:r>
+              <a:rPr lang="en-US" sz="4000" b="1" dirty="0">
+                <a:solidFill>
+                  <a:srgbClr val="FFFFFF"/>
+                </a:solidFill>
+              </a:rPr>
+              <a:t>.</a:t>
+            </a:r>
+            <a:r>
+              <a:rPr sz="4000" b="1" dirty="0">
+                <a:solidFill>
+                  <a:srgbClr val="FFFFFF"/>
+                </a:solidFill>
+              </a:rPr>
+              <a:t>  The </a:t>
+            </a:r>
+            <a:r>
+              <a:rPr lang="en-US" sz="4000" b="1" dirty="0">
+                <a:solidFill>
+                  <a:srgbClr val="FFFFFF"/>
+                </a:solidFill>
+              </a:rPr>
+              <a:t>system of </a:t>
+            </a:r>
+            <a:r>
+              <a:rPr sz="4000" b="1" dirty="0">
+                <a:solidFill>
+                  <a:srgbClr val="FFFFFF"/>
+                </a:solidFill>
+              </a:rPr>
+              <a:t>multi</a:t>
+            </a:r>
+            <a:r>
+              <a:rPr lang="en-US" sz="4000" b="1" dirty="0">
+                <a:solidFill>
+                  <a:srgbClr val="FFFFFF"/>
+                </a:solidFill>
+              </a:rPr>
+              <a:t>ple AI </a:t>
+            </a:r>
+            <a:r>
+              <a:rPr sz="4000" b="1" dirty="0">
+                <a:solidFill>
+                  <a:srgbClr val="FFFFFF"/>
+                </a:solidFill>
+              </a:rPr>
+              <a:t>agent</a:t>
+            </a:r>
+            <a:r>
+              <a:rPr lang="en-US" sz="4000" b="1" dirty="0">
+                <a:solidFill>
+                  <a:srgbClr val="FFFFFF"/>
+                </a:solidFill>
+              </a:rPr>
+              <a:t>s</a:t>
+            </a:r>
+            <a:endParaRPr sz="4000" b="1" dirty="0">
+              <a:solidFill>
+                <a:srgbClr val="FFFFFF"/>
+              </a:solidFill>
+            </a:endParaRPr>
           </a:p>
         </p:txBody>
       </p:sp>
@@ -4492,7 +6775,7 @@
           <p:nvPr/>
         </p:nvPicPr>
         <p:blipFill>
-          <a:blip r:embed="rId2"/>
+          <a:blip r:embed="rId5"/>
           <a:stretch>
             <a:fillRect/>
           </a:stretch>
@@ -4516,7 +6799,7 @@
         <p:spPr>
           <a:xfrm>
             <a:off x="914400" y="29032200"/>
-            <a:ext cx="13075920" cy="1097280"/>
+            <a:ext cx="13075920" cy="1338828"/>
           </a:xfrm>
           <a:prstGeom prst="rect">
             <a:avLst/>
@@ -4535,12 +6818,76 @@
               </a:spcAft>
             </a:pPr>
             <a:r>
-              <a:rPr sz="2500" b="0">
+              <a:rPr sz="2700" b="0" i="1" dirty="0">
                 <a:solidFill>
                   <a:srgbClr val="4A4A4A"/>
                 </a:solidFill>
               </a:rPr>
-              <a:t>Fig. 1  A Problem-Definition layer, an Orchestrator agent + shared/persistent memory (Workflow Control), and specialist Modeling / Numerical-Analysis / Code-Generation / Visualization agents (Agent Execution).</a:t>
+              <a:t>Fig</a:t>
+            </a:r>
+            <a:r>
+              <a:rPr lang="en-US" sz="2700" b="0" i="1" dirty="0">
+                <a:solidFill>
+                  <a:srgbClr val="4A4A4A"/>
+                </a:solidFill>
+              </a:rPr>
+              <a:t>ure</a:t>
+            </a:r>
+            <a:r>
+              <a:rPr sz="2700" b="0" i="1" dirty="0">
+                <a:solidFill>
+                  <a:srgbClr val="4A4A4A"/>
+                </a:solidFill>
+              </a:rPr>
+              <a:t> 1</a:t>
+            </a:r>
+            <a:r>
+              <a:rPr lang="en-US" sz="2700" b="0" i="1" dirty="0">
+                <a:solidFill>
+                  <a:srgbClr val="4A4A4A"/>
+                </a:solidFill>
+              </a:rPr>
+              <a:t>:</a:t>
+            </a:r>
+            <a:r>
+              <a:rPr sz="2700" b="0" i="1" dirty="0">
+                <a:solidFill>
+                  <a:srgbClr val="4A4A4A"/>
+                </a:solidFill>
+              </a:rPr>
+              <a:t>  A Problem-Definition layer, an Orchestrator agent + shared</a:t>
+            </a:r>
+            <a:r>
+              <a:rPr lang="en-US" sz="2700" b="0" i="1" dirty="0">
+                <a:solidFill>
+                  <a:srgbClr val="4A4A4A"/>
+                </a:solidFill>
+              </a:rPr>
+              <a:t> </a:t>
+            </a:r>
+            <a:r>
+              <a:rPr sz="2700" b="0" i="1" dirty="0">
+                <a:solidFill>
+                  <a:srgbClr val="4A4A4A"/>
+                </a:solidFill>
+              </a:rPr>
+              <a:t>/</a:t>
+            </a:r>
+            <a:r>
+              <a:rPr lang="en-US" sz="2700" b="0" i="1" dirty="0">
+                <a:solidFill>
+                  <a:srgbClr val="4A4A4A"/>
+                </a:solidFill>
+              </a:rPr>
+              <a:t> </a:t>
+            </a:r>
+            <a:r>
+              <a:rPr sz="2700" b="0" i="1" dirty="0">
+                <a:solidFill>
+                  <a:srgbClr val="4A4A4A"/>
+                </a:solidFill>
+              </a:rPr>
+              <a:t>persistent memory (Workflow Control), and specialist Modeling / Numerical-Analysis / Code-Generation / Visualization agents (Agent Execution).</a:t>
             </a:r>
           </a:p>
         </p:txBody>
@@ -4556,7 +6903,7 @@
             <a:off x="14767559" y="19419843"/>
             <a:ext cx="13624560" cy="10846796"/>
           </a:xfrm>
-          <a:prstGeom prst="roundRect">
+          <a:prstGeom prst="rect">
             <a:avLst/>
           </a:prstGeom>
           <a:solidFill>
@@ -4588,6 +6935,7 @@
           <a:lstStyle/>
           <a:p>
             <a:pPr algn="ctr"/>
+            <a:endParaRPr/>
           </a:p>
         </p:txBody>
       </p:sp>
@@ -4628,17 +6976,33 @@
           </a:fontRef>
         </p:style>
         <p:txBody>
-          <a:bodyPr rtlCol="0" anchor="ctr" lIns="274320"/>
+          <a:bodyPr lIns="274320" rtlCol="0" anchor="ctr"/>
           <a:lstStyle/>
           <a:p>
             <a:pPr algn="ctr"/>
             <a:r>
-              <a:rPr sz="4000" b="1">
+              <a:rPr sz="4000" b="1" dirty="0">
                 <a:solidFill>
                   <a:srgbClr val="FFFFFF"/>
                 </a:solidFill>
               </a:rPr>
-              <a:t>6  Real-machine equilibria</a:t>
+              <a:t>6</a:t>
+            </a:r>
+            <a:r>
+              <a:rPr lang="en-US" sz="4000" b="1" dirty="0">
+                <a:solidFill>
+                  <a:srgbClr val="FFFFFF"/>
+                </a:solidFill>
+              </a:rPr>
+              <a:t>.</a:t>
+            </a:r>
+            <a:r>
+              <a:rPr sz="4000" b="1" dirty="0">
+                <a:solidFill>
+                  <a:srgbClr val="FFFFFF"/>
+                </a:solidFill>
+              </a:rPr>
+              <a:t>  Real-machine equilibria</a:t>
             </a:r>
           </a:p>
         </p:txBody>
@@ -4652,7 +7016,7 @@
           <p:nvPr/>
         </p:nvPicPr>
         <p:blipFill>
-          <a:blip r:embed="rId3"/>
+          <a:blip r:embed="rId6"/>
           <a:stretch>
             <a:fillRect/>
           </a:stretch>
@@ -4676,7 +7040,7 @@
         <p:spPr>
           <a:xfrm>
             <a:off x="15041880" y="29032200"/>
-            <a:ext cx="13075920" cy="1097280"/>
+            <a:ext cx="13075920" cy="923330"/>
           </a:xfrm>
           <a:prstGeom prst="rect">
             <a:avLst/>
@@ -4695,12 +7059,44 @@
               </a:spcAft>
             </a:pPr>
             <a:r>
-              <a:rPr sz="2500" b="0">
+              <a:rPr sz="2700" b="0" i="1" dirty="0">
                 <a:solidFill>
                   <a:srgbClr val="4A4A4A"/>
                 </a:solidFill>
               </a:rPr>
-              <a:t>Fig. 2  One agent-generated solver → ITER, spherical-tokamak (NSTX-like) and diverted double-null (X-point) equilibria. Red = separatrix; × = X-points.</a:t>
+              <a:t>Fig</a:t>
+            </a:r>
+            <a:r>
+              <a:rPr lang="en-US" sz="2700" b="0" i="1" dirty="0">
+                <a:solidFill>
+                  <a:srgbClr val="4A4A4A"/>
+                </a:solidFill>
+              </a:rPr>
+              <a:t>ure</a:t>
+            </a:r>
+            <a:r>
+              <a:rPr sz="2700" b="0" i="1" dirty="0">
+                <a:solidFill>
+                  <a:srgbClr val="4A4A4A"/>
+                </a:solidFill>
+              </a:rPr>
+              <a:t> 2</a:t>
+            </a:r>
+            <a:r>
+              <a:rPr lang="en-US" sz="2700" b="0" i="1" dirty="0">
+                <a:solidFill>
+                  <a:srgbClr val="4A4A4A"/>
+                </a:solidFill>
+              </a:rPr>
+              <a:t>:</a:t>
+            </a:r>
+            <a:r>
+              <a:rPr sz="2700" b="0" i="1" dirty="0">
+                <a:solidFill>
+                  <a:srgbClr val="4A4A4A"/>
+                </a:solidFill>
+              </a:rPr>
+              <a:t>  One agent-generated solver → ITER, spherical-tokamak (NSTX-like) and diverted double-null (X-point) equilibria. Red = separatrix; × = X-points.</a:t>
             </a:r>
           </a:p>
         </p:txBody>
@@ -4716,7 +7112,7 @@
             <a:off x="28895039" y="4572000"/>
             <a:ext cx="13624560" cy="12321540"/>
           </a:xfrm>
-          <a:prstGeom prst="roundRect">
+          <a:prstGeom prst="rect">
             <a:avLst/>
           </a:prstGeom>
           <a:solidFill>
@@ -4748,6 +7144,7 @@
           <a:lstStyle/>
           <a:p>
             <a:pPr algn="ctr"/>
+            <a:endParaRPr/>
           </a:p>
         </p:txBody>
       </p:sp>
@@ -4788,17 +7185,49 @@
           </a:fontRef>
         </p:style>
         <p:txBody>
-          <a:bodyPr rtlCol="0" anchor="ctr" lIns="274320"/>
+          <a:bodyPr lIns="274320" rtlCol="0" anchor="ctr"/>
           <a:lstStyle/>
           <a:p>
             <a:pPr algn="ctr"/>
             <a:r>
-              <a:rPr sz="4000" b="1">
+              <a:rPr sz="4000" b="1" dirty="0">
                 <a:solidFill>
                   <a:srgbClr val="FFFFFF"/>
                 </a:solidFill>
               </a:rPr>
-              <a:t>7  Verification: 2nd order</a:t>
+              <a:t>7</a:t>
+            </a:r>
+            <a:r>
+              <a:rPr lang="en-US" sz="4000" b="1" dirty="0">
+                <a:solidFill>
+                  <a:srgbClr val="FFFFFF"/>
+                </a:solidFill>
+              </a:rPr>
+              <a:t>.</a:t>
+            </a:r>
+            <a:r>
+              <a:rPr sz="4000" b="1" dirty="0">
+                <a:solidFill>
+                  <a:srgbClr val="FFFFFF"/>
+                </a:solidFill>
+              </a:rPr>
+              <a:t>  Verification: </a:t>
+            </a:r>
+            <a:r>
+              <a:rPr lang="en-US" sz="4000" b="1" dirty="0">
+                <a:solidFill>
+                  <a:srgbClr val="FFFFFF"/>
+                </a:solidFill>
+              </a:rPr>
+              <a:t>second</a:t>
+            </a:r>
+            <a:r>
+              <a:rPr sz="4000" b="1" dirty="0">
+                <a:solidFill>
+                  <a:srgbClr val="FFFFFF"/>
+                </a:solidFill>
+              </a:rPr>
+              <a:t> order</a:t>
             </a:r>
           </a:p>
         </p:txBody>
@@ -4812,7 +7241,7 @@
           <p:nvPr/>
         </p:nvPicPr>
         <p:blipFill>
-          <a:blip r:embed="rId4"/>
+          <a:blip r:embed="rId7"/>
           <a:stretch>
             <a:fillRect/>
           </a:stretch>
@@ -4827,44 +7256,164 @@
           </a:prstGeom>
         </p:spPr>
       </p:pic>
-      <p:sp>
-        <p:nvSpPr>
-          <p:cNvPr id="33" name="TextBox 32"/>
-          <p:cNvSpPr txBox="1"/>
-          <p:nvPr/>
-        </p:nvSpPr>
-        <p:spPr>
-          <a:xfrm>
-            <a:off x="29169360" y="15659100"/>
-            <a:ext cx="13075920" cy="1097280"/>
-          </a:xfrm>
-          <a:prstGeom prst="rect">
-            <a:avLst/>
-          </a:prstGeom>
-          <a:noFill/>
-        </p:spPr>
-        <p:txBody>
-          <a:bodyPr wrap="square" anchor="t">
-            <a:spAutoFit/>
-          </a:bodyPr>
-          <a:lstStyle/>
-          <a:p>
-            <a:pPr algn="l">
-              <a:spcAft>
-                <a:spcPts val="600"/>
-              </a:spcAft>
-            </a:pPr>
-            <a:r>
-              <a:rPr sz="2500" b="0">
-                <a:solidFill>
-                  <a:srgbClr val="4A4A4A"/>
-                </a:solidFill>
-              </a:rPr>
-              <a:t>Fig. 3  Method of manufactured solutions vs the exact Cerfon-Freidberg solution: observed order p = 2.00 for all three machines.</a:t>
-            </a:r>
-          </a:p>
-        </p:txBody>
-      </p:sp>
+      <mc:AlternateContent xmlns:mc="http://schemas.openxmlformats.org/markup-compatibility/2006">
+        <mc:Choice xmlns:a14="http://schemas.microsoft.com/office/drawing/2010/main" Requires="a14">
+          <p:sp>
+            <p:nvSpPr>
+              <p:cNvPr id="33" name="TextBox 32"/>
+              <p:cNvSpPr txBox="1"/>
+              <p:nvPr/>
+            </p:nvSpPr>
+            <p:spPr>
+              <a:xfrm>
+                <a:off x="29169360" y="15659100"/>
+                <a:ext cx="13075920" cy="923330"/>
+              </a:xfrm>
+              <a:prstGeom prst="rect">
+                <a:avLst/>
+              </a:prstGeom>
+              <a:noFill/>
+            </p:spPr>
+            <p:txBody>
+              <a:bodyPr wrap="square" anchor="t">
+                <a:spAutoFit/>
+              </a:bodyPr>
+              <a:lstStyle/>
+              <a:p>
+                <a:pPr algn="l">
+                  <a:spcAft>
+                    <a:spcPts val="600"/>
+                  </a:spcAft>
+                </a:pPr>
+                <a:r>
+                  <a:rPr sz="2700" b="0" i="1" dirty="0">
+                    <a:solidFill>
+                      <a:srgbClr val="4A4A4A"/>
+                    </a:solidFill>
+                  </a:rPr>
+                  <a:t>Fig</a:t>
+                </a:r>
+                <a:r>
+                  <a:rPr lang="en-US" sz="2700" b="0" i="1" dirty="0">
+                    <a:solidFill>
+                      <a:srgbClr val="4A4A4A"/>
+                    </a:solidFill>
+                  </a:rPr>
+                  <a:t>ure</a:t>
+                </a:r>
+                <a:r>
+                  <a:rPr sz="2700" b="0" i="1" dirty="0">
+                    <a:solidFill>
+                      <a:srgbClr val="4A4A4A"/>
+                    </a:solidFill>
+                  </a:rPr>
+                  <a:t> 3</a:t>
+                </a:r>
+                <a:r>
+                  <a:rPr lang="en-US" sz="2700" b="0" i="1" dirty="0">
+                    <a:solidFill>
+                      <a:srgbClr val="4A4A4A"/>
+                    </a:solidFill>
+                  </a:rPr>
+                  <a:t>:</a:t>
+                </a:r>
+                <a:r>
+                  <a:rPr sz="2700" b="0" i="1" dirty="0">
+                    <a:solidFill>
+                      <a:srgbClr val="4A4A4A"/>
+                    </a:solidFill>
+                  </a:rPr>
+                  <a:t>  Method of manufactured solutions vs the exact </a:t>
+                </a:r>
+                <a:r>
+                  <a:rPr sz="2700" b="0" i="1" dirty="0" err="1">
+                    <a:solidFill>
+                      <a:srgbClr val="4A4A4A"/>
+                    </a:solidFill>
+                  </a:rPr>
+                  <a:t>Cerfon-Freidberg</a:t>
+                </a:r>
+                <a:r>
+                  <a:rPr sz="2700" b="0" i="1" dirty="0">
+                    <a:solidFill>
+                      <a:srgbClr val="4A4A4A"/>
+                    </a:solidFill>
+                  </a:rPr>
+                  <a:t> solution: observed order </a:t>
+                </a:r>
+                <a14:m>
+                  <m:oMath xmlns:m="http://schemas.openxmlformats.org/officeDocument/2006/math">
+                    <m:r>
+                      <a:rPr lang="en-US" sz="2700" b="0" i="1" dirty="0" smtClean="0">
+                        <a:solidFill>
+                          <a:srgbClr val="4A4A4A"/>
+                        </a:solidFill>
+                        <a:latin typeface="Cambria Math" panose="02040503050406030204" pitchFamily="18" charset="0"/>
+                      </a:rPr>
+                      <m:t>𝑝</m:t>
+                    </m:r>
+                    <m:r>
+                      <a:rPr lang="en-US" sz="2700" b="0" i="1" dirty="0" smtClean="0">
+                        <a:solidFill>
+                          <a:srgbClr val="4A4A4A"/>
+                        </a:solidFill>
+                        <a:latin typeface="Cambria Math" panose="02040503050406030204" pitchFamily="18" charset="0"/>
+                      </a:rPr>
+                      <m:t>=2.00 </m:t>
+                    </m:r>
+                  </m:oMath>
+                </a14:m>
+                <a:r>
+                  <a:rPr sz="2700" b="0" i="1" dirty="0">
+                    <a:solidFill>
+                      <a:srgbClr val="4A4A4A"/>
+                    </a:solidFill>
+                  </a:rPr>
+                  <a:t>for all three machines.</a:t>
+                </a:r>
+              </a:p>
+            </p:txBody>
+          </p:sp>
+        </mc:Choice>
+        <mc:Fallback>
+          <p:sp>
+            <p:nvSpPr>
+              <p:cNvPr id="33" name="TextBox 32"/>
+              <p:cNvSpPr txBox="1">
+                <a:spLocks noRot="1" noChangeAspect="1" noMove="1" noResize="1" noEditPoints="1" noAdjustHandles="1" noChangeArrowheads="1" noChangeShapeType="1" noTextEdit="1"/>
+              </p:cNvSpPr>
+              <p:nvPr/>
+            </p:nvSpPr>
+            <p:spPr>
+              <a:xfrm>
+                <a:off x="29169360" y="15659100"/>
+                <a:ext cx="13075920" cy="923330"/>
+              </a:xfrm>
+              <a:prstGeom prst="rect">
+                <a:avLst/>
+              </a:prstGeom>
+              <a:blipFill>
+                <a:blip r:embed="rId8"/>
+                <a:stretch>
+                  <a:fillRect l="-886" t="-5960" b="-16556"/>
+                </a:stretch>
+              </a:blipFill>
+            </p:spPr>
+            <p:txBody>
+              <a:bodyPr/>
+              <a:lstStyle/>
+              <a:p>
+                <a:r>
+                  <a:rPr lang="en-US">
+                    <a:noFill/>
+                  </a:rPr>
+                  <a:t> </a:t>
+                </a:r>
+              </a:p>
+            </p:txBody>
+          </p:sp>
+        </mc:Fallback>
+      </mc:AlternateContent>
       <p:sp>
         <p:nvSpPr>
           <p:cNvPr id="34" name="Rectangle 33"/>
@@ -4906,6 +7455,7 @@
           <a:lstStyle/>
           <a:p>
             <a:pPr algn="ctr"/>
+            <a:endParaRPr/>
           </a:p>
         </p:txBody>
       </p:sp>
@@ -4918,14 +7468,14 @@
           <p:nvPr/>
         </p:nvPicPr>
         <p:blipFill>
-          <a:blip r:embed="rId5"/>
+          <a:blip r:embed="rId9"/>
           <a:stretch>
             <a:fillRect/>
           </a:stretch>
         </p:blipFill>
         <p:spPr>
           <a:xfrm>
-            <a:off x="10560307" y="30815280"/>
+            <a:off x="1302007" y="30815280"/>
             <a:ext cx="4562721" cy="1371600"/>
           </a:xfrm>
           <a:prstGeom prst="rect">
@@ -4942,14 +7492,14 @@
           <p:nvPr/>
         </p:nvPicPr>
         <p:blipFill>
-          <a:blip r:embed="rId6"/>
+          <a:blip r:embed="rId10"/>
           <a:stretch>
             <a:fillRect/>
           </a:stretch>
         </p:blipFill>
         <p:spPr>
           <a:xfrm>
-            <a:off x="17500468" y="30815280"/>
+            <a:off x="7232518" y="30815280"/>
             <a:ext cx="8922827" cy="1371600"/>
           </a:xfrm>
           <a:prstGeom prst="rect">
@@ -4966,14 +7516,14 @@
           <p:nvPr/>
         </p:nvPicPr>
         <p:blipFill>
-          <a:blip r:embed="rId7"/>
+          <a:blip r:embed="rId11"/>
           <a:stretch>
             <a:fillRect/>
           </a:stretch>
         </p:blipFill>
         <p:spPr>
           <a:xfrm>
-            <a:off x="28800735" y="30815280"/>
+            <a:off x="17675535" y="30815280"/>
             <a:ext cx="4530157" cy="1371600"/>
           </a:xfrm>
           <a:prstGeom prst="rect">
@@ -4981,6 +7531,74 @@
           </a:prstGeom>
         </p:spPr>
       </p:pic>
+      <p:sp>
+        <p:nvSpPr>
+          <p:cNvPr id="39" name="TextBox 38">
+            <a:extLst>
+              <a:ext uri="{FF2B5EF4-FFF2-40B4-BE49-F238E27FC236}">
+                <a16:creationId xmlns:a16="http://schemas.microsoft.com/office/drawing/2014/main" id="{6FA6BCF0-8BBC-C6AF-BE37-1CDF5332C6A5}"/>
+              </a:ext>
+            </a:extLst>
+          </p:cNvPr>
+          <p:cNvSpPr txBox="1"/>
+          <p:nvPr/>
+        </p:nvSpPr>
+        <p:spPr>
+          <a:xfrm>
+            <a:off x="23602950" y="30815280"/>
+            <a:ext cx="19202400" cy="1384995"/>
+          </a:xfrm>
+          <a:prstGeom prst="rect">
+            <a:avLst/>
+          </a:prstGeom>
+          <a:noFill/>
+        </p:spPr>
+        <p:txBody>
+          <a:bodyPr wrap="square" rtlCol="0">
+            <a:spAutoFit/>
+          </a:bodyPr>
+          <a:lstStyle/>
+          <a:p>
+            <a:r>
+              <a:rPr lang="en-US" sz="2800" dirty="0"/>
+              <a:t>This work was partially supported by the US Department of Energy’s Office of Science “Distinguished Scientist Fellows” Program. </a:t>
+            </a:r>
+          </a:p>
+          <a:p>
+            <a:r>
+              <a:rPr lang="en-US" sz="2800" dirty="0"/>
+              <a:t>This work used ANL CELS General Computing Environment: </a:t>
+            </a:r>
+            <a:r>
+              <a:rPr lang="en-US" sz="2800" dirty="0">
+                <a:hlinkClick r:id="rId12"/>
+              </a:rPr>
+              <a:t>https://help.cels.anl.gov/docs/linux/</a:t>
+            </a:r>
+            <a:endParaRPr lang="en-US" sz="2800" dirty="0"/>
+          </a:p>
+          <a:p>
+            <a:r>
+              <a:rPr lang="en-US" sz="2800" dirty="0" err="1"/>
+              <a:t>PETSc</a:t>
+            </a:r>
+            <a:r>
+              <a:rPr lang="en-US" sz="2800" dirty="0"/>
+              <a:t> AI website: </a:t>
+            </a:r>
+            <a:r>
+              <a:rPr lang="en-US" sz="2800" dirty="0">
+                <a:hlinkClick r:id="rId13"/>
+              </a:rPr>
+              <a:t>https://petsc-ai.org/</a:t>
+            </a:r>
+            <a:r>
+              <a:rPr lang="en-US" sz="2800" dirty="0"/>
+              <a:t> </a:t>
+            </a:r>
+          </a:p>
+        </p:txBody>
+      </p:sp>
     </p:spTree>
   </p:cSld>
   <p:clrMapOvr>

</xml_diff>